<commit_message>
pc bang work 2
</commit_message>
<xml_diff>
--- a/Conference/GraphicsStudy/GraphicsHighLevelDesign.pptx
+++ b/Conference/GraphicsStudy/GraphicsHighLevelDesign.pptx
@@ -24,14 +24,18 @@
     <p:sldId id="273" r:id="rId18"/>
     <p:sldId id="274" r:id="rId19"/>
     <p:sldId id="263" r:id="rId20"/>
-    <p:sldId id="275" r:id="rId21"/>
-    <p:sldId id="276" r:id="rId22"/>
-    <p:sldId id="262" r:id="rId23"/>
-    <p:sldId id="259" r:id="rId24"/>
-    <p:sldId id="260" r:id="rId25"/>
-    <p:sldId id="278" r:id="rId26"/>
-    <p:sldId id="279" r:id="rId27"/>
-    <p:sldId id="281" r:id="rId28"/>
+    <p:sldId id="286" r:id="rId21"/>
+    <p:sldId id="275" r:id="rId22"/>
+    <p:sldId id="276" r:id="rId23"/>
+    <p:sldId id="262" r:id="rId24"/>
+    <p:sldId id="259" r:id="rId25"/>
+    <p:sldId id="260" r:id="rId26"/>
+    <p:sldId id="278" r:id="rId27"/>
+    <p:sldId id="283" r:id="rId28"/>
+    <p:sldId id="279" r:id="rId29"/>
+    <p:sldId id="284" r:id="rId30"/>
+    <p:sldId id="285" r:id="rId31"/>
+    <p:sldId id="281" r:id="rId32"/>
   </p:sldIdLst>
   <p:sldSz cx="12192000" cy="6858000"/>
   <p:notesSz cx="6858000" cy="9144000"/>
@@ -130,6 +134,11 @@
       </a:defRPr>
     </a:lvl9pPr>
   </p:defaultTextStyle>
+  <p:extLst>
+    <p:ext uri="{EFAFB233-063F-42B5-8137-9DF3F51BA10A}">
+      <p15:sldGuideLst xmlns:p15="http://schemas.microsoft.com/office/powerpoint/2012/main"/>
+    </p:ext>
+  </p:extLst>
 </p:presentation>
 </file>
 
@@ -280,7 +289,7 @@
           <a:p>
             <a:fld id="{D8810A9B-0CC6-4053-BA0B-965178095DC3}" type="datetimeFigureOut">
               <a:rPr lang="ko-KR" altLang="en-US" smtClean="0"/>
-              <a:t>2026-03-06</a:t>
+              <a:t>2026-03-07</a:t>
             </a:fld>
             <a:endParaRPr lang="ko-KR" altLang="en-US"/>
           </a:p>
@@ -478,7 +487,7 @@
           <a:p>
             <a:fld id="{D8810A9B-0CC6-4053-BA0B-965178095DC3}" type="datetimeFigureOut">
               <a:rPr lang="ko-KR" altLang="en-US" smtClean="0"/>
-              <a:t>2026-03-06</a:t>
+              <a:t>2026-03-07</a:t>
             </a:fld>
             <a:endParaRPr lang="ko-KR" altLang="en-US"/>
           </a:p>
@@ -686,7 +695,7 @@
           <a:p>
             <a:fld id="{D8810A9B-0CC6-4053-BA0B-965178095DC3}" type="datetimeFigureOut">
               <a:rPr lang="ko-KR" altLang="en-US" smtClean="0"/>
-              <a:t>2026-03-06</a:t>
+              <a:t>2026-03-07</a:t>
             </a:fld>
             <a:endParaRPr lang="ko-KR" altLang="en-US"/>
           </a:p>
@@ -884,7 +893,7 @@
           <a:p>
             <a:fld id="{D8810A9B-0CC6-4053-BA0B-965178095DC3}" type="datetimeFigureOut">
               <a:rPr lang="ko-KR" altLang="en-US" smtClean="0"/>
-              <a:t>2026-03-06</a:t>
+              <a:t>2026-03-07</a:t>
             </a:fld>
             <a:endParaRPr lang="ko-KR" altLang="en-US"/>
           </a:p>
@@ -1159,7 +1168,7 @@
           <a:p>
             <a:fld id="{D8810A9B-0CC6-4053-BA0B-965178095DC3}" type="datetimeFigureOut">
               <a:rPr lang="ko-KR" altLang="en-US" smtClean="0"/>
-              <a:t>2026-03-06</a:t>
+              <a:t>2026-03-07</a:t>
             </a:fld>
             <a:endParaRPr lang="ko-KR" altLang="en-US"/>
           </a:p>
@@ -1424,7 +1433,7 @@
           <a:p>
             <a:fld id="{D8810A9B-0CC6-4053-BA0B-965178095DC3}" type="datetimeFigureOut">
               <a:rPr lang="ko-KR" altLang="en-US" smtClean="0"/>
-              <a:t>2026-03-06</a:t>
+              <a:t>2026-03-07</a:t>
             </a:fld>
             <a:endParaRPr lang="ko-KR" altLang="en-US"/>
           </a:p>
@@ -1836,7 +1845,7 @@
           <a:p>
             <a:fld id="{D8810A9B-0CC6-4053-BA0B-965178095DC3}" type="datetimeFigureOut">
               <a:rPr lang="ko-KR" altLang="en-US" smtClean="0"/>
-              <a:t>2026-03-06</a:t>
+              <a:t>2026-03-07</a:t>
             </a:fld>
             <a:endParaRPr lang="ko-KR" altLang="en-US"/>
           </a:p>
@@ -1977,7 +1986,7 @@
           <a:p>
             <a:fld id="{D8810A9B-0CC6-4053-BA0B-965178095DC3}" type="datetimeFigureOut">
               <a:rPr lang="ko-KR" altLang="en-US" smtClean="0"/>
-              <a:t>2026-03-06</a:t>
+              <a:t>2026-03-07</a:t>
             </a:fld>
             <a:endParaRPr lang="ko-KR" altLang="en-US"/>
           </a:p>
@@ -2090,7 +2099,7 @@
           <a:p>
             <a:fld id="{D8810A9B-0CC6-4053-BA0B-965178095DC3}" type="datetimeFigureOut">
               <a:rPr lang="ko-KR" altLang="en-US" smtClean="0"/>
-              <a:t>2026-03-06</a:t>
+              <a:t>2026-03-07</a:t>
             </a:fld>
             <a:endParaRPr lang="ko-KR" altLang="en-US"/>
           </a:p>
@@ -2401,7 +2410,7 @@
           <a:p>
             <a:fld id="{D8810A9B-0CC6-4053-BA0B-965178095DC3}" type="datetimeFigureOut">
               <a:rPr lang="ko-KR" altLang="en-US" smtClean="0"/>
-              <a:t>2026-03-06</a:t>
+              <a:t>2026-03-07</a:t>
             </a:fld>
             <a:endParaRPr lang="ko-KR" altLang="en-US"/>
           </a:p>
@@ -2689,7 +2698,7 @@
           <a:p>
             <a:fld id="{D8810A9B-0CC6-4053-BA0B-965178095DC3}" type="datetimeFigureOut">
               <a:rPr lang="ko-KR" altLang="en-US" smtClean="0"/>
-              <a:t>2026-03-06</a:t>
+              <a:t>2026-03-07</a:t>
             </a:fld>
             <a:endParaRPr lang="ko-KR" altLang="en-US"/>
           </a:p>
@@ -2930,7 +2939,7 @@
           <a:p>
             <a:fld id="{D8810A9B-0CC6-4053-BA0B-965178095DC3}" type="datetimeFigureOut">
               <a:rPr lang="ko-KR" altLang="en-US" smtClean="0"/>
-              <a:t>2026-03-06</a:t>
+              <a:t>2026-03-07</a:t>
             </a:fld>
             <a:endParaRPr lang="ko-KR" altLang="en-US"/>
           </a:p>
@@ -3495,6 +3504,46 @@
           </a:p>
         </p:txBody>
       </p:sp>
+      <p:sp>
+        <p:nvSpPr>
+          <p:cNvPr id="3" name="TextBox 2">
+            <a:extLst>
+              <a:ext uri="{FF2B5EF4-FFF2-40B4-BE49-F238E27FC236}">
+                <a16:creationId xmlns:a16="http://schemas.microsoft.com/office/drawing/2014/main" id="{9155DF22-CBFA-20BB-DD37-3C4DBA847093}"/>
+              </a:ext>
+            </a:extLst>
+          </p:cNvPr>
+          <p:cNvSpPr txBox="1"/>
+          <p:nvPr/>
+        </p:nvSpPr>
+        <p:spPr>
+          <a:xfrm>
+            <a:off x="0" y="868680"/>
+            <a:ext cx="2327881" cy="369332"/>
+          </a:xfrm>
+          <a:prstGeom prst="rect">
+            <a:avLst/>
+          </a:prstGeom>
+          <a:noFill/>
+        </p:spPr>
+        <p:txBody>
+          <a:bodyPr wrap="none" rtlCol="0">
+            <a:spAutoFit/>
+          </a:bodyPr>
+          <a:lstStyle/>
+          <a:p>
+            <a:r>
+              <a:rPr lang="ko-KR" altLang="en-US" dirty="0"/>
+              <a:t>아직 실현되지 못함</a:t>
+            </a:r>
+            <a:r>
+              <a:rPr lang="en-US" altLang="ko-KR" dirty="0"/>
+              <a:t>.</a:t>
+            </a:r>
+            <a:endParaRPr lang="ko-KR" altLang="en-US" dirty="0"/>
+          </a:p>
+        </p:txBody>
+      </p:sp>
     </p:spTree>
     <p:extLst>
       <p:ext uri="{BB962C8B-B14F-4D97-AF65-F5344CB8AC3E}">
@@ -3643,6 +3692,46 @@
           </a:p>
         </p:txBody>
       </p:sp>
+      <p:sp>
+        <p:nvSpPr>
+          <p:cNvPr id="3" name="TextBox 2">
+            <a:extLst>
+              <a:ext uri="{FF2B5EF4-FFF2-40B4-BE49-F238E27FC236}">
+                <a16:creationId xmlns:a16="http://schemas.microsoft.com/office/drawing/2014/main" id="{F166ADAE-70E3-CF4B-B423-1A220BE1DEFD}"/>
+              </a:ext>
+            </a:extLst>
+          </p:cNvPr>
+          <p:cNvSpPr txBox="1"/>
+          <p:nvPr/>
+        </p:nvSpPr>
+        <p:spPr>
+          <a:xfrm>
+            <a:off x="0" y="868680"/>
+            <a:ext cx="2327881" cy="369332"/>
+          </a:xfrm>
+          <a:prstGeom prst="rect">
+            <a:avLst/>
+          </a:prstGeom>
+          <a:noFill/>
+        </p:spPr>
+        <p:txBody>
+          <a:bodyPr wrap="none" rtlCol="0">
+            <a:spAutoFit/>
+          </a:bodyPr>
+          <a:lstStyle/>
+          <a:p>
+            <a:r>
+              <a:rPr lang="ko-KR" altLang="en-US" dirty="0"/>
+              <a:t>아직 실현되지 못함</a:t>
+            </a:r>
+            <a:r>
+              <a:rPr lang="en-US" altLang="ko-KR" dirty="0"/>
+              <a:t>.</a:t>
+            </a:r>
+            <a:endParaRPr lang="ko-KR" altLang="en-US" dirty="0"/>
+          </a:p>
+        </p:txBody>
+      </p:sp>
     </p:spTree>
     <p:extLst>
       <p:ext uri="{BB962C8B-B14F-4D97-AF65-F5344CB8AC3E}">
@@ -4079,6 +4168,50 @@
           </a:p>
         </p:txBody>
       </p:sp>
+      <p:sp>
+        <p:nvSpPr>
+          <p:cNvPr id="3" name="TextBox 2">
+            <a:extLst>
+              <a:ext uri="{FF2B5EF4-FFF2-40B4-BE49-F238E27FC236}">
+                <a16:creationId xmlns:a16="http://schemas.microsoft.com/office/drawing/2014/main" id="{CD284927-6AF3-F87B-3315-B8AB439EFC04}"/>
+              </a:ext>
+            </a:extLst>
+          </p:cNvPr>
+          <p:cNvSpPr txBox="1"/>
+          <p:nvPr/>
+        </p:nvSpPr>
+        <p:spPr>
+          <a:xfrm>
+            <a:off x="0" y="868680"/>
+            <a:ext cx="2476960" cy="369332"/>
+          </a:xfrm>
+          <a:prstGeom prst="rect">
+            <a:avLst/>
+          </a:prstGeom>
+          <a:noFill/>
+        </p:spPr>
+        <p:txBody>
+          <a:bodyPr wrap="none" rtlCol="0">
+            <a:spAutoFit/>
+          </a:bodyPr>
+          <a:lstStyle/>
+          <a:p>
+            <a:r>
+              <a:rPr lang="ko-KR" altLang="en-US" dirty="0"/>
+              <a:t>동건아 이거 </a:t>
+            </a:r>
+            <a:r>
+              <a:rPr lang="ko-KR" altLang="en-US" dirty="0" err="1"/>
+              <a:t>적어주셈</a:t>
+            </a:r>
+            <a:r>
+              <a:rPr lang="en-US" altLang="ko-KR" dirty="0"/>
+              <a:t>.</a:t>
+            </a:r>
+            <a:endParaRPr lang="ko-KR" altLang="en-US" dirty="0"/>
+          </a:p>
+        </p:txBody>
+      </p:sp>
     </p:spTree>
     <p:extLst>
       <p:ext uri="{BB962C8B-B14F-4D97-AF65-F5344CB8AC3E}">
@@ -4428,8 +4561,8 @@
           </a:p>
         </p:txBody>
       </p:sp>
-      <mc:AlternateContent xmlns:mc="http://schemas.openxmlformats.org/markup-compatibility/2006">
-        <mc:Choice xmlns:pslz="http://schemas.microsoft.com/office/powerpoint/2016/slidezoom" Requires="pslz">
+      <mc:AlternateContent xmlns:mc="http://schemas.openxmlformats.org/markup-compatibility/2006" xmlns:pslz="http://schemas.microsoft.com/office/powerpoint/2016/slidezoom">
+        <mc:Choice Requires="pslz">
           <p:graphicFrame>
             <p:nvGraphicFramePr>
               <p:cNvPr id="10" name="슬라이드 확대/축소 9">
@@ -4486,7 +4619,7 @@
             </a:graphic>
           </p:graphicFrame>
         </mc:Choice>
-        <mc:Fallback>
+        <mc:Fallback xmlns="">
           <p:pic>
             <p:nvPicPr>
               <p:cNvPr id="10" name="슬라이드 확대/축소 9">
@@ -4503,7 +4636,7 @@
               <p:nvPr/>
             </p:nvPicPr>
             <p:blipFill>
-              <a:blip r:embed="rId2"/>
+              <a:blip r:embed="rId4"/>
               <a:stretch>
                 <a:fillRect/>
               </a:stretch>
@@ -4525,8 +4658,8 @@
           </p:pic>
         </mc:Fallback>
       </mc:AlternateContent>
-      <mc:AlternateContent xmlns:mc="http://schemas.openxmlformats.org/markup-compatibility/2006">
-        <mc:Choice xmlns:pslz="http://schemas.microsoft.com/office/powerpoint/2016/slidezoom" Requires="pslz">
+      <mc:AlternateContent xmlns:mc="http://schemas.openxmlformats.org/markup-compatibility/2006" xmlns:pslz="http://schemas.microsoft.com/office/powerpoint/2016/slidezoom">
+        <mc:Choice Requires="pslz">
           <p:graphicFrame>
             <p:nvGraphicFramePr>
               <p:cNvPr id="12" name="슬라이드 확대/축소 11">
@@ -4557,7 +4690,7 @@
                   <pslz:sldZmObj sldId="276" cId="904325592">
                     <pslz:zmPr id="{9E0EBCD9-BD83-4563-B14E-89E01394AE33}" returnToParent="0" transitionDur="1000">
                       <p166:blipFill xmlns:p166="http://schemas.microsoft.com/office/powerpoint/2016/6/main">
-                        <a:blip r:embed="rId4"/>
+                        <a:blip r:embed="rId5"/>
                         <a:stretch>
                           <a:fillRect/>
                         </a:stretch>
@@ -4583,11 +4716,11 @@
             </a:graphic>
           </p:graphicFrame>
         </mc:Choice>
-        <mc:Fallback>
+        <mc:Fallback xmlns="">
           <p:pic>
             <p:nvPicPr>
               <p:cNvPr id="12" name="슬라이드 확대/축소 11">
-                <a:hlinkClick r:id="rId5" action="ppaction://hlinksldjump"/>
+                <a:hlinkClick r:id="rId6" action="ppaction://hlinksldjump"/>
                 <a:extLst>
                   <a:ext uri="{FF2B5EF4-FFF2-40B4-BE49-F238E27FC236}">
                     <a16:creationId xmlns:a16="http://schemas.microsoft.com/office/drawing/2014/main" id="{8F29BC11-36B9-45F7-4879-A46D2C89FB68}"/>
@@ -4600,7 +4733,7 @@
               <p:nvPr/>
             </p:nvPicPr>
             <p:blipFill>
-              <a:blip r:embed="rId4"/>
+              <a:blip r:embed="rId7"/>
               <a:stretch>
                 <a:fillRect/>
               </a:stretch>
@@ -4636,8 +4769,8 @@
         </p:nvSpPr>
         <p:spPr>
           <a:xfrm>
-            <a:off x="180092" y="1453140"/>
-            <a:ext cx="1526380" cy="369332"/>
+            <a:off x="91601" y="1467599"/>
+            <a:ext cx="5779018" cy="923330"/>
           </a:xfrm>
           <a:prstGeom prst="rect">
             <a:avLst/>
@@ -4651,76 +4784,156 @@
           <a:lstStyle/>
           <a:p>
             <a:r>
-              <a:rPr lang="ko-KR" altLang="en-US" dirty="0"/>
-              <a:t>이거</a:t>
+              <a:rPr lang="en-US" altLang="ko-KR" dirty="0" err="1"/>
+              <a:t>SkinMesh</a:t>
+            </a:r>
+            <a:r>
+              <a:rPr lang="ko-KR" altLang="en-US" dirty="0"/>
+              <a:t>의 </a:t>
             </a:r>
             <a:r>
               <a:rPr lang="en-US" altLang="ko-KR" dirty="0"/>
-              <a:t> </a:t>
-            </a:r>
-            <a:r>
-              <a:rPr lang="ko-KR" altLang="en-US" dirty="0"/>
-              <a:t>필요함</a:t>
+              <a:t>BLAS Update</a:t>
+            </a:r>
+            <a:r>
+              <a:rPr lang="ko-KR" altLang="en-US" dirty="0"/>
+              <a:t>의 경우 </a:t>
+            </a:r>
+            <a:r>
+              <a:rPr lang="en-US" altLang="ko-KR" dirty="0" err="1"/>
+              <a:t>game.RenderTour</a:t>
+            </a:r>
+            <a:r>
+              <a:rPr lang="ko-KR" altLang="en-US" dirty="0"/>
+              <a:t>를</a:t>
+            </a:r>
+            <a:endParaRPr lang="en-US" altLang="ko-KR" dirty="0"/>
+          </a:p>
+          <a:p>
+            <a:r>
+              <a:rPr lang="ko-KR" altLang="en-US" dirty="0"/>
+              <a:t>사용해 보이는 스킨 </a:t>
+            </a:r>
+            <a:r>
+              <a:rPr lang="ko-KR" altLang="en-US" dirty="0" err="1"/>
+              <a:t>메쉬에</a:t>
+            </a:r>
+            <a:r>
+              <a:rPr lang="ko-KR" altLang="en-US" dirty="0"/>
+              <a:t> 대해서만 </a:t>
+            </a:r>
+            <a:endParaRPr lang="en-US" altLang="ko-KR" dirty="0"/>
+          </a:p>
+          <a:p>
+            <a:r>
+              <a:rPr lang="ko-KR" altLang="en-US" dirty="0"/>
+              <a:t>업데이트를 수행한다</a:t>
             </a:r>
             <a:r>
               <a:rPr lang="en-US" altLang="ko-KR" dirty="0"/>
-              <a:t>?</a:t>
+              <a:t>.</a:t>
             </a:r>
             <a:endParaRPr lang="ko-KR" altLang="en-US" dirty="0"/>
           </a:p>
         </p:txBody>
       </p:sp>
-      <p:sp>
-        <p:nvSpPr>
-          <p:cNvPr id="14" name="TextBox 13">
-            <a:extLst>
-              <a:ext uri="{FF2B5EF4-FFF2-40B4-BE49-F238E27FC236}">
-                <a16:creationId xmlns:a16="http://schemas.microsoft.com/office/drawing/2014/main" id="{1A0998AD-A07F-1BD6-CC03-61628BF4B0BC}"/>
-              </a:ext>
-            </a:extLst>
-          </p:cNvPr>
-          <p:cNvSpPr txBox="1"/>
-          <p:nvPr/>
-        </p:nvSpPr>
-        <p:spPr>
-          <a:xfrm>
-            <a:off x="6096000" y="1467599"/>
-            <a:ext cx="2032223" cy="923330"/>
-          </a:xfrm>
-          <a:prstGeom prst="rect">
-            <a:avLst/>
-          </a:prstGeom>
-          <a:noFill/>
-        </p:spPr>
-        <p:txBody>
-          <a:bodyPr wrap="none" rtlCol="0">
-            <a:spAutoFit/>
-          </a:bodyPr>
-          <a:lstStyle/>
-          <a:p>
-            <a:r>
-              <a:rPr lang="en-US" altLang="ko-KR" dirty="0"/>
-              <a:t>Vertex Buffer SRV</a:t>
-            </a:r>
-          </a:p>
-          <a:p>
-            <a:r>
-              <a:rPr lang="en-US" altLang="ko-KR" dirty="0"/>
-              <a:t>Index Buffer SRV</a:t>
-            </a:r>
-          </a:p>
-          <a:p>
-            <a:r>
-              <a:rPr lang="ko-KR" altLang="en-US" dirty="0" err="1"/>
-              <a:t>셰이더에</a:t>
-            </a:r>
-            <a:r>
-              <a:rPr lang="ko-KR" altLang="en-US" dirty="0"/>
-              <a:t> 바인딩</a:t>
-            </a:r>
-          </a:p>
-        </p:txBody>
-      </p:sp>
+      <mc:AlternateContent xmlns:mc="http://schemas.openxmlformats.org/markup-compatibility/2006">
+        <mc:Choice xmlns:pslz="http://schemas.microsoft.com/office/powerpoint/2016/slidezoom" Requires="pslz">
+          <p:graphicFrame>
+            <p:nvGraphicFramePr>
+              <p:cNvPr id="11" name="슬라이드 확대/축소 10">
+                <a:extLst>
+                  <a:ext uri="{FF2B5EF4-FFF2-40B4-BE49-F238E27FC236}">
+                    <a16:creationId xmlns:a16="http://schemas.microsoft.com/office/drawing/2014/main" id="{5D85872A-69A6-B12A-6362-54B353177F6F}"/>
+                  </a:ext>
+                </a:extLst>
+              </p:cNvPr>
+              <p:cNvGraphicFramePr>
+                <a:graphicFrameLocks noChangeAspect="1"/>
+              </p:cNvGraphicFramePr>
+              <p:nvPr>
+                <p:extLst>
+                  <p:ext uri="{D42A27DB-BD31-4B8C-83A1-F6EECF244321}">
+                    <p14:modId xmlns:p14="http://schemas.microsoft.com/office/powerpoint/2010/main" val="1374667222"/>
+                  </p:ext>
+                </p:extLst>
+              </p:nvPr>
+            </p:nvGraphicFramePr>
+            <p:xfrm>
+              <a:off x="6096000" y="1520347"/>
+              <a:ext cx="2778325" cy="1562808"/>
+            </p:xfrm>
+            <a:graphic>
+              <a:graphicData uri="http://schemas.microsoft.com/office/powerpoint/2016/slidezoom">
+                <pslz:sldZm>
+                  <pslz:sldZmObj sldId="286" cId="471672495">
+                    <pslz:zmPr id="{47ADBA83-62CC-4C39-B974-4F5B113AD202}" returnToParent="0" transitionDur="1000">
+                      <p166:blipFill xmlns:p166="http://schemas.microsoft.com/office/powerpoint/2016/6/main">
+                        <a:blip r:embed="rId8"/>
+                        <a:stretch>
+                          <a:fillRect/>
+                        </a:stretch>
+                      </p166:blipFill>
+                      <p166:spPr xmlns:p166="http://schemas.microsoft.com/office/powerpoint/2016/6/main">
+                        <a:xfrm>
+                          <a:off x="0" y="0"/>
+                          <a:ext cx="2778325" cy="1562808"/>
+                        </a:xfrm>
+                        <a:prstGeom prst="rect">
+                          <a:avLst/>
+                        </a:prstGeom>
+                        <a:ln w="3175">
+                          <a:solidFill>
+                            <a:prstClr val="ltGray"/>
+                          </a:solidFill>
+                        </a:ln>
+                      </p166:spPr>
+                    </pslz:zmPr>
+                  </pslz:sldZmObj>
+                </pslz:sldZm>
+              </a:graphicData>
+            </a:graphic>
+          </p:graphicFrame>
+        </mc:Choice>
+        <mc:Fallback>
+          <p:pic>
+            <p:nvPicPr>
+              <p:cNvPr id="11" name="슬라이드 확대/축소 10">
+                <a:hlinkClick r:id="rId3" action="ppaction://hlinksldjump"/>
+                <a:extLst>
+                  <a:ext uri="{FF2B5EF4-FFF2-40B4-BE49-F238E27FC236}">
+                    <a16:creationId xmlns:a16="http://schemas.microsoft.com/office/drawing/2014/main" id="{5D85872A-69A6-B12A-6362-54B353177F6F}"/>
+                  </a:ext>
+                </a:extLst>
+              </p:cNvPr>
+              <p:cNvPicPr>
+                <a:picLocks noGrp="1" noRot="1" noChangeAspect="1" noMove="1" noResize="1" noEditPoints="1" noAdjustHandles="1" noChangeArrowheads="1" noChangeShapeType="1"/>
+              </p:cNvPicPr>
+              <p:nvPr/>
+            </p:nvPicPr>
+            <p:blipFill>
+              <a:blip r:embed="rId8"/>
+              <a:stretch>
+                <a:fillRect/>
+              </a:stretch>
+            </p:blipFill>
+            <p:spPr>
+              <a:xfrm>
+                <a:off x="6096000" y="1520347"/>
+                <a:ext cx="2778325" cy="1562808"/>
+              </a:xfrm>
+              <a:prstGeom prst="rect">
+                <a:avLst/>
+              </a:prstGeom>
+              <a:ln w="3175">
+                <a:solidFill>
+                  <a:prstClr val="ltGray"/>
+                </a:solidFill>
+              </a:ln>
+            </p:spPr>
+          </p:pic>
+        </mc:Fallback>
+      </mc:AlternateContent>
     </p:spTree>
     <p:extLst>
       <p:ext uri="{BB962C8B-B14F-4D97-AF65-F5344CB8AC3E}">
@@ -4785,8 +4998,8 @@
           </a:p>
         </p:txBody>
       </p:sp>
-      <mc:AlternateContent xmlns:mc="http://schemas.openxmlformats.org/markup-compatibility/2006">
-        <mc:Choice xmlns:pslz="http://schemas.microsoft.com/office/powerpoint/2016/slidezoom" Requires="pslz">
+      <mc:AlternateContent xmlns:mc="http://schemas.openxmlformats.org/markup-compatibility/2006" xmlns:pslz="http://schemas.microsoft.com/office/powerpoint/2016/slidezoom">
+        <mc:Choice Requires="pslz">
           <p:graphicFrame>
             <p:nvGraphicFramePr>
               <p:cNvPr id="5" name="슬라이드 확대/축소 4">
@@ -4843,7 +5056,7 @@
             </a:graphic>
           </p:graphicFrame>
         </mc:Choice>
-        <mc:Fallback>
+        <mc:Fallback xmlns="">
           <p:pic>
             <p:nvPicPr>
               <p:cNvPr id="5" name="슬라이드 확대/축소 4">
@@ -4860,7 +5073,7 @@
               <p:nvPr/>
             </p:nvPicPr>
             <p:blipFill>
-              <a:blip r:embed="rId2"/>
+              <a:blip r:embed="rId4"/>
               <a:stretch>
                 <a:fillRect/>
               </a:stretch>
@@ -4882,8 +5095,8 @@
           </p:pic>
         </mc:Fallback>
       </mc:AlternateContent>
-      <mc:AlternateContent xmlns:mc="http://schemas.openxmlformats.org/markup-compatibility/2006">
-        <mc:Choice xmlns:pslz="http://schemas.microsoft.com/office/powerpoint/2016/slidezoom" Requires="pslz">
+      <mc:AlternateContent xmlns:mc="http://schemas.openxmlformats.org/markup-compatibility/2006" xmlns:pslz="http://schemas.microsoft.com/office/powerpoint/2016/slidezoom">
+        <mc:Choice Requires="pslz">
           <p:graphicFrame>
             <p:nvGraphicFramePr>
               <p:cNvPr id="7" name="슬라이드 확대/축소 6">
@@ -4914,7 +5127,7 @@
                   <pslz:sldZmObj sldId="259" cId="2433842180">
                     <pslz:zmPr id="{9592065C-C584-4DF5-A15A-E16791647284}" returnToParent="0" transitionDur="1000">
                       <p166:blipFill xmlns:p166="http://schemas.microsoft.com/office/powerpoint/2016/6/main">
-                        <a:blip r:embed="rId4"/>
+                        <a:blip r:embed="rId5"/>
                         <a:stretch>
                           <a:fillRect/>
                         </a:stretch>
@@ -4940,11 +5153,11 @@
             </a:graphic>
           </p:graphicFrame>
         </mc:Choice>
-        <mc:Fallback>
+        <mc:Fallback xmlns="">
           <p:pic>
             <p:nvPicPr>
               <p:cNvPr id="7" name="슬라이드 확대/축소 6">
-                <a:hlinkClick r:id="rId5" action="ppaction://hlinksldjump"/>
+                <a:hlinkClick r:id="rId6" action="ppaction://hlinksldjump"/>
                 <a:extLst>
                   <a:ext uri="{FF2B5EF4-FFF2-40B4-BE49-F238E27FC236}">
                     <a16:creationId xmlns:a16="http://schemas.microsoft.com/office/drawing/2014/main" id="{099CA36F-9802-FBA9-6C3B-B7C08A48B94D}"/>
@@ -4957,7 +5170,7 @@
               <p:nvPr/>
             </p:nvPicPr>
             <p:blipFill>
-              <a:blip r:embed="rId4"/>
+              <a:blip r:embed="rId7"/>
               <a:stretch>
                 <a:fillRect/>
               </a:stretch>
@@ -4979,8 +5192,8 @@
           </p:pic>
         </mc:Fallback>
       </mc:AlternateContent>
-      <mc:AlternateContent xmlns:mc="http://schemas.openxmlformats.org/markup-compatibility/2006">
-        <mc:Choice xmlns:pslz="http://schemas.microsoft.com/office/powerpoint/2016/slidezoom" Requires="pslz">
+      <mc:AlternateContent xmlns:mc="http://schemas.openxmlformats.org/markup-compatibility/2006" xmlns:pslz="http://schemas.microsoft.com/office/powerpoint/2016/slidezoom">
+        <mc:Choice Requires="pslz">
           <p:graphicFrame>
             <p:nvGraphicFramePr>
               <p:cNvPr id="9" name="슬라이드 확대/축소 8">
@@ -5011,7 +5224,7 @@
                   <pslz:sldZmObj sldId="260" cId="2758334147">
                     <pslz:zmPr id="{230FFD24-AFDE-44C3-B5BB-C0CA796D3700}" returnToParent="0" transitionDur="1000">
                       <p166:blipFill xmlns:p166="http://schemas.microsoft.com/office/powerpoint/2016/6/main">
-                        <a:blip r:embed="rId6"/>
+                        <a:blip r:embed="rId8"/>
                         <a:stretch>
                           <a:fillRect/>
                         </a:stretch>
@@ -5037,11 +5250,11 @@
             </a:graphic>
           </p:graphicFrame>
         </mc:Choice>
-        <mc:Fallback>
+        <mc:Fallback xmlns="">
           <p:pic>
             <p:nvPicPr>
               <p:cNvPr id="9" name="슬라이드 확대/축소 8">
-                <a:hlinkClick r:id="rId7" action="ppaction://hlinksldjump"/>
+                <a:hlinkClick r:id="rId9" action="ppaction://hlinksldjump"/>
                 <a:extLst>
                   <a:ext uri="{FF2B5EF4-FFF2-40B4-BE49-F238E27FC236}">
                     <a16:creationId xmlns:a16="http://schemas.microsoft.com/office/drawing/2014/main" id="{D1C1B1AA-7BD2-1858-C0B3-6BB9B3E60AD7}"/>
@@ -5054,7 +5267,7 @@
               <p:nvPr/>
             </p:nvPicPr>
             <p:blipFill>
-              <a:blip r:embed="rId6"/>
+              <a:blip r:embed="rId10"/>
               <a:stretch>
                 <a:fillRect/>
               </a:stretch>
@@ -5097,6 +5310,536 @@
         <p:cNvPr id="1" name="">
           <a:extLst>
             <a:ext uri="{FF2B5EF4-FFF2-40B4-BE49-F238E27FC236}">
+              <a16:creationId xmlns:a16="http://schemas.microsoft.com/office/drawing/2014/main" id="{128D3EA2-2F9A-BBA9-FCED-EA621E860D7B}"/>
+            </a:ext>
+          </a:extLst>
+        </p:cNvPr>
+        <p:cNvGrpSpPr/>
+        <p:nvPr/>
+      </p:nvGrpSpPr>
+      <p:grpSpPr>
+        <a:xfrm>
+          <a:off x="0" y="0"/>
+          <a:ext cx="0" cy="0"/>
+          <a:chOff x="0" y="0"/>
+          <a:chExt cx="0" cy="0"/>
+        </a:xfrm>
+      </p:grpSpPr>
+      <p:sp>
+        <p:nvSpPr>
+          <p:cNvPr id="2" name="제목 1">
+            <a:extLst>
+              <a:ext uri="{FF2B5EF4-FFF2-40B4-BE49-F238E27FC236}">
+                <a16:creationId xmlns:a16="http://schemas.microsoft.com/office/drawing/2014/main" id="{A338507F-D2F3-0813-40BE-C41B7850B7FF}"/>
+              </a:ext>
+            </a:extLst>
+          </p:cNvPr>
+          <p:cNvSpPr>
+            <a:spLocks noGrp="1"/>
+          </p:cNvSpPr>
+          <p:nvPr>
+            <p:ph type="title"/>
+          </p:nvPr>
+        </p:nvSpPr>
+        <p:spPr>
+          <a:xfrm>
+            <a:off x="0" y="18255"/>
+            <a:ext cx="10515600" cy="850425"/>
+          </a:xfrm>
+        </p:spPr>
+        <p:txBody>
+          <a:bodyPr>
+            <a:normAutofit/>
+          </a:bodyPr>
+          <a:lstStyle/>
+          <a:p>
+            <a:r>
+              <a:rPr lang="en-US" altLang="ko-KR" sz="5400" dirty="0"/>
+              <a:t>DXR – Vertex</a:t>
+            </a:r>
+            <a:r>
+              <a:rPr lang="ko-KR" altLang="en-US" sz="5400" dirty="0"/>
+              <a:t> </a:t>
+            </a:r>
+            <a:r>
+              <a:rPr lang="en-US" altLang="ko-KR" sz="5400" dirty="0"/>
+              <a:t>Compute</a:t>
+            </a:r>
+            <a:endParaRPr lang="ko-KR" altLang="en-US" sz="5400" dirty="0"/>
+          </a:p>
+        </p:txBody>
+      </p:sp>
+      <p:sp>
+        <p:nvSpPr>
+          <p:cNvPr id="14" name="TextBox 13">
+            <a:extLst>
+              <a:ext uri="{FF2B5EF4-FFF2-40B4-BE49-F238E27FC236}">
+                <a16:creationId xmlns:a16="http://schemas.microsoft.com/office/drawing/2014/main" id="{1A0998AD-A07F-1BD6-CC03-61628BF4B0BC}"/>
+              </a:ext>
+            </a:extLst>
+          </p:cNvPr>
+          <p:cNvSpPr txBox="1"/>
+          <p:nvPr/>
+        </p:nvSpPr>
+        <p:spPr>
+          <a:xfrm>
+            <a:off x="206477" y="868680"/>
+            <a:ext cx="11344832" cy="5078313"/>
+          </a:xfrm>
+          <a:prstGeom prst="rect">
+            <a:avLst/>
+          </a:prstGeom>
+          <a:noFill/>
+        </p:spPr>
+        <p:txBody>
+          <a:bodyPr wrap="square" rtlCol="0">
+            <a:spAutoFit/>
+          </a:bodyPr>
+          <a:lstStyle/>
+          <a:p>
+            <a:r>
+              <a:rPr lang="ko-KR" altLang="en-US" dirty="0" err="1"/>
+              <a:t>메쉬를</a:t>
+            </a:r>
+            <a:r>
+              <a:rPr lang="ko-KR" altLang="en-US" dirty="0"/>
+              <a:t> </a:t>
+            </a:r>
+            <a:r>
+              <a:rPr lang="ko-KR" altLang="en-US" dirty="0" err="1"/>
+              <a:t>만들때마다</a:t>
+            </a:r>
+            <a:r>
+              <a:rPr lang="ko-KR" altLang="en-US" dirty="0"/>
+              <a:t> </a:t>
+            </a:r>
+            <a:r>
+              <a:rPr lang="en-US" altLang="ko-KR" dirty="0"/>
+              <a:t>BLAS</a:t>
+            </a:r>
+            <a:r>
+              <a:rPr lang="ko-KR" altLang="en-US" dirty="0"/>
+              <a:t>를 함께 빌드하며</a:t>
+            </a:r>
+            <a:r>
+              <a:rPr lang="en-US" altLang="ko-KR" dirty="0"/>
+              <a:t>, </a:t>
+            </a:r>
+            <a:r>
+              <a:rPr lang="ko-KR" altLang="en-US" dirty="0" err="1"/>
+              <a:t>메쉬의</a:t>
+            </a:r>
+            <a:r>
+              <a:rPr lang="ko-KR" altLang="en-US" dirty="0"/>
+              <a:t> </a:t>
+            </a:r>
+            <a:r>
+              <a:rPr lang="ko-KR" altLang="en-US" dirty="0" err="1"/>
+              <a:t>버택스</a:t>
+            </a:r>
+            <a:r>
+              <a:rPr lang="ko-KR" altLang="en-US" dirty="0"/>
+              <a:t> </a:t>
+            </a:r>
+            <a:r>
+              <a:rPr lang="en-US" altLang="ko-KR" dirty="0"/>
+              <a:t>/</a:t>
+            </a:r>
+            <a:r>
+              <a:rPr lang="ko-KR" altLang="en-US" dirty="0"/>
+              <a:t> 인덱스 데이터를 </a:t>
+            </a:r>
+            <a:endParaRPr lang="en-US" altLang="ko-KR" dirty="0"/>
+          </a:p>
+          <a:p>
+            <a:r>
+              <a:rPr lang="ko-KR" altLang="en-US" dirty="0"/>
+              <a:t>두개의 </a:t>
+            </a:r>
+            <a:r>
+              <a:rPr lang="en-US" altLang="ko-KR" dirty="0" err="1"/>
+              <a:t>GPURes</a:t>
+            </a:r>
+            <a:r>
+              <a:rPr lang="ko-KR" altLang="en-US" dirty="0"/>
+              <a:t>인 풀에 집어넣는다</a:t>
+            </a:r>
+            <a:r>
+              <a:rPr lang="en-US" altLang="ko-KR" dirty="0"/>
+              <a:t>. &gt;&gt; </a:t>
+            </a:r>
+            <a:r>
+              <a:rPr lang="ko-KR" altLang="en-US" dirty="0"/>
+              <a:t>때문에 모든 </a:t>
+            </a:r>
+            <a:r>
+              <a:rPr lang="ko-KR" altLang="en-US" dirty="0" err="1"/>
+              <a:t>버택스</a:t>
+            </a:r>
+            <a:r>
+              <a:rPr lang="ko-KR" altLang="en-US" dirty="0"/>
+              <a:t> 데이터</a:t>
+            </a:r>
+            <a:r>
+              <a:rPr lang="en-US" altLang="ko-KR" dirty="0"/>
+              <a:t>, </a:t>
+            </a:r>
+            <a:r>
+              <a:rPr lang="ko-KR" altLang="en-US" dirty="0"/>
+              <a:t>모든 인덱스 데이터가 이 두 리소스 내에 있다</a:t>
+            </a:r>
+            <a:r>
+              <a:rPr lang="en-US" altLang="ko-KR" dirty="0"/>
+              <a:t>.</a:t>
+            </a:r>
+          </a:p>
+          <a:p>
+            <a:r>
+              <a:rPr lang="en-US" altLang="ko-KR" dirty="0"/>
+              <a:t>	- </a:t>
+            </a:r>
+            <a:r>
+              <a:rPr lang="ko-KR" altLang="en-US" dirty="0"/>
+              <a:t>다만 이 </a:t>
+            </a:r>
+            <a:r>
+              <a:rPr lang="ko-KR" altLang="en-US" dirty="0" err="1"/>
+              <a:t>메쉬의</a:t>
+            </a:r>
+            <a:r>
+              <a:rPr lang="ko-KR" altLang="en-US" dirty="0"/>
+              <a:t> 데이터를 레스터 렌더링에서도 재활용하기 위해서는 </a:t>
+            </a:r>
+            <a:endParaRPr lang="en-US" altLang="ko-KR" dirty="0"/>
+          </a:p>
+          <a:p>
+            <a:r>
+              <a:rPr lang="en-US" altLang="ko-KR" dirty="0"/>
+              <a:t>		</a:t>
+            </a:r>
+            <a:r>
+              <a:rPr lang="ko-KR" altLang="en-US" dirty="0" err="1"/>
+              <a:t>메쉬마다</a:t>
+            </a:r>
+            <a:r>
+              <a:rPr lang="ko-KR" altLang="en-US" dirty="0"/>
+              <a:t> </a:t>
+            </a:r>
+            <a:r>
+              <a:rPr lang="en-US" altLang="ko-KR" dirty="0" err="1"/>
+              <a:t>VertexBufferView</a:t>
+            </a:r>
+            <a:r>
+              <a:rPr lang="en-US" altLang="ko-KR" dirty="0"/>
+              <a:t>, </a:t>
+            </a:r>
+            <a:r>
+              <a:rPr lang="en-US" altLang="ko-KR" dirty="0" err="1"/>
+              <a:t>IndexBufferView</a:t>
+            </a:r>
+            <a:r>
+              <a:rPr lang="ko-KR" altLang="en-US" dirty="0"/>
+              <a:t>를 만들어야 했는데 그러기 위해서는 </a:t>
+            </a:r>
+            <a:endParaRPr lang="en-US" altLang="ko-KR" dirty="0"/>
+          </a:p>
+          <a:p>
+            <a:r>
+              <a:rPr lang="en-US" altLang="ko-KR" dirty="0"/>
+              <a:t>		</a:t>
+            </a:r>
+            <a:r>
+              <a:rPr lang="ko-KR" altLang="en-US" dirty="0"/>
+              <a:t>모든 </a:t>
+            </a:r>
+            <a:r>
+              <a:rPr lang="ko-KR" altLang="en-US" dirty="0" err="1"/>
+              <a:t>메쉬의</a:t>
+            </a:r>
+            <a:r>
+              <a:rPr lang="ko-KR" altLang="en-US" dirty="0"/>
+              <a:t> </a:t>
+            </a:r>
+            <a:r>
+              <a:rPr lang="ko-KR" altLang="en-US" dirty="0" err="1"/>
+              <a:t>버택스</a:t>
+            </a:r>
+            <a:r>
+              <a:rPr lang="ko-KR" altLang="en-US" dirty="0"/>
+              <a:t> 시작점</a:t>
+            </a:r>
+            <a:r>
+              <a:rPr lang="en-US" altLang="ko-KR" dirty="0"/>
+              <a:t>, </a:t>
+            </a:r>
+            <a:r>
+              <a:rPr lang="ko-KR" altLang="en-US" dirty="0"/>
+              <a:t>그 안의 모든 </a:t>
+            </a:r>
+            <a:r>
+              <a:rPr lang="ko-KR" altLang="en-US" dirty="0" err="1"/>
+              <a:t>서브메쉬들의</a:t>
+            </a:r>
+            <a:r>
+              <a:rPr lang="ko-KR" altLang="en-US" dirty="0"/>
+              <a:t> 인덱스 시작점들을 </a:t>
+            </a:r>
+            <a:endParaRPr lang="en-US" altLang="ko-KR" dirty="0"/>
+          </a:p>
+          <a:p>
+            <a:r>
+              <a:rPr lang="en-US" altLang="ko-KR" dirty="0"/>
+              <a:t>		256</a:t>
+            </a:r>
+            <a:r>
+              <a:rPr lang="ko-KR" altLang="en-US" dirty="0"/>
+              <a:t>바이트로 얼라인해야 했다</a:t>
+            </a:r>
+            <a:r>
+              <a:rPr lang="en-US" altLang="ko-KR" dirty="0"/>
+              <a:t>.</a:t>
+            </a:r>
+          </a:p>
+          <a:p>
+            <a:r>
+              <a:rPr lang="en-US" altLang="ko-KR" dirty="0"/>
+              <a:t>		</a:t>
+            </a:r>
+            <a:r>
+              <a:rPr lang="ko-KR" altLang="en-US" dirty="0"/>
+              <a:t>때문에 같은 </a:t>
+            </a:r>
+            <a:r>
+              <a:rPr lang="ko-KR" altLang="en-US" dirty="0" err="1"/>
+              <a:t>메쉬라도</a:t>
+            </a:r>
+            <a:r>
+              <a:rPr lang="ko-KR" altLang="en-US" dirty="0"/>
+              <a:t> 데이터가 연속적이지 않고 정렬되어 끊겨져 있을 것이다</a:t>
+            </a:r>
+            <a:r>
+              <a:rPr lang="en-US" altLang="ko-KR" dirty="0"/>
+              <a:t>. </a:t>
+            </a:r>
+          </a:p>
+          <a:p>
+            <a:endParaRPr lang="en-US" altLang="ko-KR" dirty="0"/>
+          </a:p>
+          <a:p>
+            <a:r>
+              <a:rPr lang="ko-KR" altLang="en-US" dirty="0" err="1"/>
+              <a:t>렌더를</a:t>
+            </a:r>
+            <a:r>
+              <a:rPr lang="ko-KR" altLang="en-US" dirty="0"/>
+              <a:t> 시작하면</a:t>
+            </a:r>
+            <a:endParaRPr lang="en-US" altLang="ko-KR" dirty="0"/>
+          </a:p>
+          <a:p>
+            <a:r>
+              <a:rPr lang="ko-KR" altLang="en-US" dirty="0" err="1"/>
+              <a:t>프러스텀</a:t>
+            </a:r>
+            <a:r>
+              <a:rPr lang="ko-KR" altLang="en-US" dirty="0"/>
+              <a:t> </a:t>
+            </a:r>
+            <a:r>
+              <a:rPr lang="ko-KR" altLang="en-US" dirty="0" err="1"/>
+              <a:t>컬링으로</a:t>
+            </a:r>
+            <a:r>
+              <a:rPr lang="ko-KR" altLang="en-US" dirty="0"/>
+              <a:t> 걸러낸 </a:t>
+            </a:r>
+            <a:r>
+              <a:rPr lang="ko-KR" altLang="en-US" dirty="0" err="1"/>
+              <a:t>스킨메쉬들의</a:t>
+            </a:r>
+            <a:r>
+              <a:rPr lang="ko-KR" altLang="en-US" dirty="0"/>
+              <a:t> 데이터를 변형시키고</a:t>
+            </a:r>
+            <a:r>
+              <a:rPr lang="en-US" altLang="ko-KR" dirty="0"/>
+              <a:t>, BLAS refit</a:t>
+            </a:r>
+            <a:r>
+              <a:rPr lang="ko-KR" altLang="en-US" dirty="0"/>
+              <a:t>을 수행한다</a:t>
+            </a:r>
+            <a:r>
+              <a:rPr lang="en-US" altLang="ko-KR" dirty="0"/>
+              <a:t>.</a:t>
+            </a:r>
+          </a:p>
+          <a:p>
+            <a:endParaRPr lang="en-US" altLang="ko-KR" dirty="0"/>
+          </a:p>
+          <a:p>
+            <a:r>
+              <a:rPr lang="ko-KR" altLang="en-US" dirty="0"/>
+              <a:t>또한 각</a:t>
+            </a:r>
+            <a:r>
+              <a:rPr lang="en-US" altLang="ko-KR" dirty="0"/>
+              <a:t> </a:t>
+            </a:r>
+            <a:r>
+              <a:rPr lang="ko-KR" altLang="en-US" dirty="0"/>
+              <a:t>프레임마다</a:t>
+            </a:r>
+            <a:r>
+              <a:rPr lang="en-US" altLang="ko-KR" dirty="0"/>
+              <a:t> TLAS</a:t>
+            </a:r>
+            <a:r>
+              <a:rPr lang="ko-KR" altLang="en-US" dirty="0"/>
+              <a:t>를 빌드하고 </a:t>
+            </a:r>
+            <a:r>
+              <a:rPr lang="en-US" altLang="ko-KR" dirty="0"/>
+              <a:t>AS </a:t>
+            </a:r>
+            <a:r>
+              <a:rPr lang="ko-KR" altLang="en-US" dirty="0"/>
+              <a:t>바인딩</a:t>
+            </a:r>
+            <a:endParaRPr lang="en-US" altLang="ko-KR" dirty="0"/>
+          </a:p>
+          <a:p>
+            <a:r>
+              <a:rPr lang="ko-KR" altLang="en-US" dirty="0" err="1"/>
+              <a:t>메쉬들의</a:t>
+            </a:r>
+            <a:r>
+              <a:rPr lang="ko-KR" altLang="en-US" dirty="0"/>
+              <a:t> 데이터를 모아놓은 </a:t>
+            </a:r>
+            <a:r>
+              <a:rPr lang="en-US" altLang="ko-KR" dirty="0"/>
+              <a:t>Vertex Buffer SRV, Index Buffer SRV</a:t>
+            </a:r>
+            <a:r>
+              <a:rPr lang="ko-KR" altLang="en-US" dirty="0"/>
+              <a:t>를 </a:t>
+            </a:r>
+            <a:r>
+              <a:rPr lang="ko-KR" altLang="en-US" dirty="0" err="1"/>
+              <a:t>셰이더에</a:t>
+            </a:r>
+            <a:r>
+              <a:rPr lang="ko-KR" altLang="en-US" dirty="0"/>
+              <a:t> 바인딩을 하고</a:t>
+            </a:r>
+            <a:endParaRPr lang="en-US" altLang="ko-KR" dirty="0"/>
+          </a:p>
+          <a:p>
+            <a:r>
+              <a:rPr lang="ko-KR" altLang="en-US" dirty="0"/>
+              <a:t>렌더링을 시작한다</a:t>
+            </a:r>
+            <a:r>
+              <a:rPr lang="en-US" altLang="ko-KR" dirty="0"/>
+              <a:t>.</a:t>
+            </a:r>
+          </a:p>
+          <a:p>
+            <a:endParaRPr lang="en-US" altLang="ko-KR" dirty="0"/>
+          </a:p>
+          <a:p>
+            <a:r>
+              <a:rPr lang="ko-KR" altLang="en-US" dirty="0"/>
+              <a:t>화면에서 어떤 픽셀이 </a:t>
+            </a:r>
+            <a:r>
+              <a:rPr lang="ko-KR" altLang="en-US" dirty="0" err="1"/>
+              <a:t>메쉬내부에</a:t>
+            </a:r>
+            <a:r>
+              <a:rPr lang="ko-KR" altLang="en-US" dirty="0"/>
+              <a:t> 있는 점인지는 </a:t>
+            </a:r>
+            <a:r>
+              <a:rPr lang="en-US" altLang="ko-KR" dirty="0"/>
+              <a:t>BLAS</a:t>
+            </a:r>
+            <a:r>
+              <a:rPr lang="ko-KR" altLang="en-US" dirty="0"/>
+              <a:t>가 판단하며</a:t>
+            </a:r>
+            <a:r>
+              <a:rPr lang="en-US" altLang="ko-KR" dirty="0"/>
+              <a:t>, </a:t>
+            </a:r>
+            <a:r>
+              <a:rPr lang="ko-KR" altLang="en-US" dirty="0"/>
+              <a:t>해당 </a:t>
+            </a:r>
+            <a:r>
+              <a:rPr lang="ko-KR" altLang="en-US" dirty="0" err="1"/>
+              <a:t>버택스들의</a:t>
+            </a:r>
+            <a:r>
+              <a:rPr lang="ko-KR" altLang="en-US" dirty="0"/>
+              <a:t> 자세한 데이터들은 </a:t>
+            </a:r>
+            <a:endParaRPr lang="en-US" altLang="ko-KR" dirty="0"/>
+          </a:p>
+          <a:p>
+            <a:r>
+              <a:rPr lang="en-US" altLang="ko-KR" dirty="0"/>
+              <a:t>Vertex Buffer SRV, Index Buffer SRV</a:t>
+            </a:r>
+            <a:r>
+              <a:rPr lang="ko-KR" altLang="en-US" dirty="0"/>
+              <a:t>들을 </a:t>
+            </a:r>
+            <a:r>
+              <a:rPr lang="en-US" altLang="ko-KR" dirty="0"/>
+              <a:t>Shader</a:t>
+            </a:r>
+            <a:r>
+              <a:rPr lang="ko-KR" altLang="en-US" dirty="0"/>
+              <a:t>에서 </a:t>
+            </a:r>
+            <a:r>
+              <a:rPr lang="en-US" altLang="ko-KR" dirty="0" err="1"/>
+              <a:t>StructuredBuffer</a:t>
+            </a:r>
+            <a:r>
+              <a:rPr lang="ko-KR" altLang="en-US" dirty="0"/>
+              <a:t>로 바인딩하여 알아볼 수 있다</a:t>
+            </a:r>
+            <a:r>
+              <a:rPr lang="en-US" altLang="ko-KR" dirty="0"/>
+              <a:t>.</a:t>
+            </a:r>
+          </a:p>
+        </p:txBody>
+      </p:sp>
+    </p:spTree>
+    <p:extLst>
+      <p:ext uri="{BB962C8B-B14F-4D97-AF65-F5344CB8AC3E}">
+        <p14:creationId xmlns:p14="http://schemas.microsoft.com/office/powerpoint/2010/main" val="471672495"/>
+      </p:ext>
+    </p:extLst>
+  </p:cSld>
+  <p:clrMapOvr>
+    <a:masterClrMapping/>
+  </p:clrMapOvr>
+</p:sld>
+</file>
+
+<file path=ppt/slides/slide21.xml><?xml version="1.0" encoding="utf-8"?>
+<p:sld xmlns:a="http://schemas.openxmlformats.org/drawingml/2006/main" xmlns:r="http://schemas.openxmlformats.org/officeDocument/2006/relationships" xmlns:p="http://schemas.openxmlformats.org/presentationml/2006/main">
+  <p:cSld>
+    <p:spTree>
+      <p:nvGrpSpPr>
+        <p:cNvPr id="1" name="">
+          <a:extLst>
+            <a:ext uri="{FF2B5EF4-FFF2-40B4-BE49-F238E27FC236}">
               <a16:creationId xmlns:a16="http://schemas.microsoft.com/office/drawing/2014/main" id="{F0B7CB50-1033-5F70-E3A4-665999B4ACC6}"/>
             </a:ext>
           </a:extLst>
@@ -5161,7 +5904,7 @@
 </p:sld>
 </file>
 
-<file path=ppt/slides/slide21.xml><?xml version="1.0" encoding="utf-8"?>
+<file path=ppt/slides/slide22.xml><?xml version="1.0" encoding="utf-8"?>
 <p:sld xmlns:a="http://schemas.openxmlformats.org/drawingml/2006/main" xmlns:r="http://schemas.openxmlformats.org/officeDocument/2006/relationships" xmlns:p="http://schemas.openxmlformats.org/presentationml/2006/main">
   <p:cSld>
     <p:spTree>
@@ -5237,7 +5980,7 @@
 </p:sld>
 </file>
 
-<file path=ppt/slides/slide22.xml><?xml version="1.0" encoding="utf-8"?>
+<file path=ppt/slides/slide23.xml><?xml version="1.0" encoding="utf-8"?>
 <p:sld xmlns:a="http://schemas.openxmlformats.org/drawingml/2006/main" xmlns:r="http://schemas.openxmlformats.org/officeDocument/2006/relationships" xmlns:p="http://schemas.openxmlformats.org/presentationml/2006/main">
   <p:cSld>
     <p:spTree>
@@ -5309,7 +6052,7 @@
 </p:sld>
 </file>
 
-<file path=ppt/slides/slide23.xml><?xml version="1.0" encoding="utf-8"?>
+<file path=ppt/slides/slide24.xml><?xml version="1.0" encoding="utf-8"?>
 <p:sld xmlns:a="http://schemas.openxmlformats.org/drawingml/2006/main" xmlns:r="http://schemas.openxmlformats.org/officeDocument/2006/relationships" xmlns:p="http://schemas.openxmlformats.org/presentationml/2006/main">
   <p:cSld>
     <p:spTree>
@@ -5411,7 +6154,7 @@
 </p:sld>
 </file>
 
-<file path=ppt/slides/slide24.xml><?xml version="1.0" encoding="utf-8"?>
+<file path=ppt/slides/slide25.xml><?xml version="1.0" encoding="utf-8"?>
 <p:sld xmlns:a="http://schemas.openxmlformats.org/drawingml/2006/main" xmlns:r="http://schemas.openxmlformats.org/officeDocument/2006/relationships" xmlns:p="http://schemas.openxmlformats.org/presentationml/2006/main">
   <p:cSld>
     <p:spTree>
@@ -5470,8 +6213,8 @@
           </a:p>
         </p:txBody>
       </p:sp>
-      <mc:AlternateContent xmlns:mc="http://schemas.openxmlformats.org/markup-compatibility/2006">
-        <mc:Choice xmlns:pslz="http://schemas.microsoft.com/office/powerpoint/2016/slidezoom" Requires="pslz">
+      <mc:AlternateContent xmlns:mc="http://schemas.openxmlformats.org/markup-compatibility/2006" xmlns:pslz="http://schemas.microsoft.com/office/powerpoint/2016/slidezoom">
+        <mc:Choice Requires="pslz">
           <p:graphicFrame>
             <p:nvGraphicFramePr>
               <p:cNvPr id="4" name="슬라이드 확대/축소 3">
@@ -5528,7 +6271,7 @@
             </a:graphic>
           </p:graphicFrame>
         </mc:Choice>
-        <mc:Fallback>
+        <mc:Fallback xmlns="">
           <p:pic>
             <p:nvPicPr>
               <p:cNvPr id="4" name="슬라이드 확대/축소 3">
@@ -5545,7 +6288,7 @@
               <p:nvPr/>
             </p:nvPicPr>
             <p:blipFill>
-              <a:blip r:embed="rId2"/>
+              <a:blip r:embed="rId4"/>
               <a:stretch>
                 <a:fillRect/>
               </a:stretch>
@@ -5567,8 +6310,8 @@
           </p:pic>
         </mc:Fallback>
       </mc:AlternateContent>
-      <mc:AlternateContent xmlns:mc="http://schemas.openxmlformats.org/markup-compatibility/2006">
-        <mc:Choice xmlns:pslz="http://schemas.microsoft.com/office/powerpoint/2016/slidezoom" Requires="pslz">
+      <mc:AlternateContent xmlns:mc="http://schemas.openxmlformats.org/markup-compatibility/2006" xmlns:pslz="http://schemas.microsoft.com/office/powerpoint/2016/slidezoom">
+        <mc:Choice Requires="pslz">
           <p:graphicFrame>
             <p:nvGraphicFramePr>
               <p:cNvPr id="6" name="슬라이드 확대/축소 5">
@@ -5599,7 +6342,7 @@
                   <pslz:sldZmObj sldId="279" cId="2927238059">
                     <pslz:zmPr id="{EFAEE96A-68E4-4BA0-AD76-B19B21DBD83D}" returnToParent="0" transitionDur="1000">
                       <p166:blipFill xmlns:p166="http://schemas.microsoft.com/office/powerpoint/2016/6/main">
-                        <a:blip r:embed="rId4"/>
+                        <a:blip r:embed="rId5"/>
                         <a:stretch>
                           <a:fillRect/>
                         </a:stretch>
@@ -5625,11 +6368,11 @@
             </a:graphic>
           </p:graphicFrame>
         </mc:Choice>
-        <mc:Fallback>
+        <mc:Fallback xmlns="">
           <p:pic>
             <p:nvPicPr>
               <p:cNvPr id="6" name="슬라이드 확대/축소 5">
-                <a:hlinkClick r:id="rId5" action="ppaction://hlinksldjump"/>
+                <a:hlinkClick r:id="rId6" action="ppaction://hlinksldjump"/>
                 <a:extLst>
                   <a:ext uri="{FF2B5EF4-FFF2-40B4-BE49-F238E27FC236}">
                     <a16:creationId xmlns:a16="http://schemas.microsoft.com/office/drawing/2014/main" id="{DDF32986-FF6C-E5A3-849B-D60E77632BCB}"/>
@@ -5642,7 +6385,7 @@
               <p:nvPr/>
             </p:nvPicPr>
             <p:blipFill>
-              <a:blip r:embed="rId4"/>
+              <a:blip r:embed="rId7"/>
               <a:stretch>
                 <a:fillRect/>
               </a:stretch>
@@ -5677,7 +6420,7 @@
 </p:sld>
 </file>
 
-<file path=ppt/slides/slide25.xml><?xml version="1.0" encoding="utf-8"?>
+<file path=ppt/slides/slide26.xml><?xml version="1.0" encoding="utf-8"?>
 <p:sld xmlns:a="http://schemas.openxmlformats.org/drawingml/2006/main" xmlns:r="http://schemas.openxmlformats.org/officeDocument/2006/relationships" xmlns:p="http://schemas.openxmlformats.org/presentationml/2006/main">
   <p:cSld>
     <p:spTree>
@@ -5736,6 +6479,344 @@
           </a:p>
         </p:txBody>
       </p:sp>
+      <p:sp>
+        <p:nvSpPr>
+          <p:cNvPr id="4" name="TextBox 3">
+            <a:extLst>
+              <a:ext uri="{FF2B5EF4-FFF2-40B4-BE49-F238E27FC236}">
+                <a16:creationId xmlns:a16="http://schemas.microsoft.com/office/drawing/2014/main" id="{03D14BEE-5B9D-F77C-1F44-F02DDDD9145C}"/>
+              </a:ext>
+            </a:extLst>
+          </p:cNvPr>
+          <p:cNvSpPr txBox="1"/>
+          <p:nvPr/>
+        </p:nvSpPr>
+        <p:spPr>
+          <a:xfrm>
+            <a:off x="137160" y="868680"/>
+            <a:ext cx="12317796" cy="2031325"/>
+          </a:xfrm>
+          <a:prstGeom prst="rect">
+            <a:avLst/>
+          </a:prstGeom>
+          <a:noFill/>
+        </p:spPr>
+        <p:txBody>
+          <a:bodyPr wrap="none" rtlCol="0">
+            <a:spAutoFit/>
+          </a:bodyPr>
+          <a:lstStyle/>
+          <a:p>
+            <a:r>
+              <a:rPr lang="en-US" altLang="ko-KR" dirty="0" err="1"/>
+              <a:t>bitAlloter</a:t>
+            </a:r>
+            <a:r>
+              <a:rPr lang="ko-KR" altLang="en-US" dirty="0"/>
+              <a:t>는 각 배열의 자리의 활성</a:t>
+            </a:r>
+            <a:r>
+              <a:rPr lang="en-US" altLang="ko-KR" dirty="0"/>
+              <a:t>/</a:t>
+            </a:r>
+            <a:r>
+              <a:rPr lang="ko-KR" altLang="en-US" dirty="0"/>
+              <a:t>비활성 혹은 할당</a:t>
+            </a:r>
+            <a:r>
+              <a:rPr lang="en-US" altLang="ko-KR" dirty="0"/>
+              <a:t>/</a:t>
+            </a:r>
+            <a:r>
+              <a:rPr lang="ko-KR" altLang="en-US" dirty="0" err="1"/>
+              <a:t>비할당</a:t>
+            </a:r>
+            <a:r>
+              <a:rPr lang="ko-KR" altLang="en-US" dirty="0"/>
+              <a:t> 여부를 </a:t>
+            </a:r>
+            <a:r>
+              <a:rPr lang="en-US" altLang="ko-KR" dirty="0"/>
+              <a:t>bit </a:t>
+            </a:r>
+            <a:r>
+              <a:rPr lang="ko-KR" altLang="en-US" dirty="0"/>
+              <a:t>배열로 나타낸다</a:t>
+            </a:r>
+            <a:r>
+              <a:rPr lang="en-US" altLang="ko-KR" dirty="0"/>
+              <a:t>.</a:t>
+            </a:r>
+          </a:p>
+          <a:p>
+            <a:r>
+              <a:rPr lang="en-US" altLang="ko-KR" dirty="0" err="1"/>
+              <a:t>Alloc</a:t>
+            </a:r>
+            <a:r>
+              <a:rPr lang="en-US" altLang="ko-KR" dirty="0"/>
+              <a:t>()</a:t>
+            </a:r>
+            <a:r>
+              <a:rPr lang="ko-KR" altLang="en-US" dirty="0"/>
+              <a:t>을 하면 비트가 </a:t>
+            </a:r>
+            <a:r>
+              <a:rPr lang="en-US" altLang="ko-KR" dirty="0"/>
+              <a:t>0</a:t>
+            </a:r>
+            <a:r>
+              <a:rPr lang="ko-KR" altLang="en-US" dirty="0"/>
+              <a:t>인 자리를 선택하여 </a:t>
+            </a:r>
+            <a:r>
+              <a:rPr lang="en-US" altLang="ko-KR" dirty="0"/>
+              <a:t>1</a:t>
+            </a:r>
+            <a:r>
+              <a:rPr lang="ko-KR" altLang="en-US" dirty="0"/>
+              <a:t>로 만들고 해당 위치를 </a:t>
+            </a:r>
+            <a:r>
+              <a:rPr lang="en-US" altLang="ko-KR" dirty="0"/>
+              <a:t>int </a:t>
+            </a:r>
+            <a:r>
+              <a:rPr lang="ko-KR" altLang="en-US" dirty="0"/>
+              <a:t>인덱스로 반환한다</a:t>
+            </a:r>
+            <a:r>
+              <a:rPr lang="en-US" altLang="ko-KR" dirty="0"/>
+              <a:t>.</a:t>
+            </a:r>
+          </a:p>
+          <a:p>
+            <a:r>
+              <a:rPr lang="ko-KR" altLang="en-US" dirty="0"/>
+              <a:t>그 인덱스를 오브젝트가 가지고 있다가 </a:t>
+            </a:r>
+            <a:r>
+              <a:rPr lang="en-US" altLang="ko-KR" dirty="0"/>
+              <a:t>Free(index) </a:t>
+            </a:r>
+            <a:r>
+              <a:rPr lang="ko-KR" altLang="en-US" dirty="0"/>
+              <a:t>를 호출하여 다시 해제할 수 있다</a:t>
+            </a:r>
+            <a:r>
+              <a:rPr lang="en-US" altLang="ko-KR" dirty="0"/>
+              <a:t>.</a:t>
+            </a:r>
+          </a:p>
+          <a:p>
+            <a:r>
+              <a:rPr lang="ko-KR" altLang="en-US" dirty="0"/>
+              <a:t>할당과정은 꽤나 빠르다</a:t>
+            </a:r>
+            <a:r>
+              <a:rPr lang="en-US" altLang="ko-KR" dirty="0"/>
+              <a:t>. </a:t>
+            </a:r>
+            <a:r>
+              <a:rPr lang="ko-KR" altLang="en-US" dirty="0"/>
+              <a:t>왜냐하면 가장 마지막 </a:t>
+            </a:r>
+            <a:r>
+              <a:rPr lang="en-US" altLang="ko-KR" dirty="0"/>
+              <a:t>0</a:t>
+            </a:r>
+            <a:r>
+              <a:rPr lang="ko-KR" altLang="en-US" dirty="0"/>
+              <a:t>을 항상 저장하게끔 알고리즘이 </a:t>
+            </a:r>
+            <a:r>
+              <a:rPr lang="ko-KR" altLang="en-US" dirty="0" err="1"/>
+              <a:t>짜여있기도</a:t>
+            </a:r>
+            <a:r>
+              <a:rPr lang="ko-KR" altLang="en-US" dirty="0"/>
+              <a:t> 하고</a:t>
+            </a:r>
+            <a:r>
+              <a:rPr lang="en-US" altLang="ko-KR" dirty="0"/>
+              <a:t>, (</a:t>
+            </a:r>
+            <a:r>
+              <a:rPr lang="ko-KR" altLang="en-US" dirty="0"/>
+              <a:t>곧바로 그걸 선택</a:t>
+            </a:r>
+            <a:r>
+              <a:rPr lang="en-US" altLang="ko-KR" dirty="0"/>
+              <a:t>)</a:t>
+            </a:r>
+          </a:p>
+          <a:p>
+            <a:r>
+              <a:rPr lang="ko-KR" altLang="en-US" dirty="0"/>
+              <a:t>또한 </a:t>
+            </a:r>
+            <a:r>
+              <a:rPr lang="en-US" altLang="ko-KR" dirty="0"/>
+              <a:t>bit </a:t>
+            </a:r>
+            <a:r>
+              <a:rPr lang="ko-KR" altLang="en-US" dirty="0"/>
+              <a:t>배열로 되어있기 때문에 </a:t>
+            </a:r>
+            <a:r>
+              <a:rPr lang="en-US" altLang="ko-KR" dirty="0"/>
+              <a:t>32</a:t>
+            </a:r>
+            <a:r>
+              <a:rPr lang="ko-KR" altLang="en-US" dirty="0"/>
+              <a:t>개의 오브젝트의 할당여부를 한번에 검사할 수 있다</a:t>
+            </a:r>
+            <a:r>
+              <a:rPr lang="en-US" altLang="ko-KR" dirty="0"/>
+              <a:t>. 0xFFFFFFFF</a:t>
+            </a:r>
+            <a:r>
+              <a:rPr lang="ko-KR" altLang="en-US" dirty="0"/>
+              <a:t>가 아니라면</a:t>
+            </a:r>
+            <a:endParaRPr lang="en-US" altLang="ko-KR" dirty="0"/>
+          </a:p>
+          <a:p>
+            <a:r>
+              <a:rPr lang="ko-KR" altLang="en-US" dirty="0"/>
+              <a:t>그곳에 </a:t>
+            </a:r>
+            <a:r>
+              <a:rPr lang="en-US" altLang="ko-KR" dirty="0"/>
+              <a:t>0</a:t>
+            </a:r>
+            <a:r>
+              <a:rPr lang="ko-KR" altLang="en-US" dirty="0"/>
+              <a:t>이 있다는 것이니 해당 </a:t>
+            </a:r>
+            <a:r>
+              <a:rPr lang="en-US" altLang="ko-KR" dirty="0"/>
+              <a:t>doubleword </a:t>
+            </a:r>
+            <a:r>
+              <a:rPr lang="ko-KR" altLang="en-US" dirty="0"/>
+              <a:t>를 </a:t>
+            </a:r>
+            <a:r>
+              <a:rPr lang="en-US" altLang="ko-KR" dirty="0"/>
+              <a:t>bit </a:t>
+            </a:r>
+            <a:r>
+              <a:rPr lang="ko-KR" altLang="en-US" dirty="0"/>
+              <a:t>순회한다</a:t>
+            </a:r>
+            <a:r>
+              <a:rPr lang="en-US" altLang="ko-KR" dirty="0"/>
+              <a:t>.</a:t>
+            </a:r>
+          </a:p>
+          <a:p>
+            <a:endParaRPr lang="en-US" altLang="ko-KR" dirty="0"/>
+          </a:p>
+        </p:txBody>
+      </p:sp>
+      <mc:AlternateContent xmlns:mc="http://schemas.openxmlformats.org/markup-compatibility/2006">
+        <mc:Choice xmlns:pslz="http://schemas.microsoft.com/office/powerpoint/2016/slidezoom" Requires="pslz">
+          <p:graphicFrame>
+            <p:nvGraphicFramePr>
+              <p:cNvPr id="8" name="슬라이드 확대/축소 7">
+                <a:extLst>
+                  <a:ext uri="{FF2B5EF4-FFF2-40B4-BE49-F238E27FC236}">
+                    <a16:creationId xmlns:a16="http://schemas.microsoft.com/office/drawing/2014/main" id="{D507B324-09B3-7B73-FD30-77FD1CC0027B}"/>
+                  </a:ext>
+                </a:extLst>
+              </p:cNvPr>
+              <p:cNvGraphicFramePr>
+                <a:graphicFrameLocks noChangeAspect="1"/>
+              </p:cNvGraphicFramePr>
+              <p:nvPr>
+                <p:extLst>
+                  <p:ext uri="{D42A27DB-BD31-4B8C-83A1-F6EECF244321}">
+                    <p14:modId xmlns:p14="http://schemas.microsoft.com/office/powerpoint/2010/main" val="3257729037"/>
+                  </p:ext>
+                </p:extLst>
+              </p:nvPr>
+            </p:nvGraphicFramePr>
+            <p:xfrm>
+              <a:off x="205986" y="2768395"/>
+              <a:ext cx="6617109" cy="3722124"/>
+            </p:xfrm>
+            <a:graphic>
+              <a:graphicData uri="http://schemas.microsoft.com/office/powerpoint/2016/slidezoom">
+                <pslz:sldZm>
+                  <pslz:sldZmObj sldId="283" cId="977256668">
+                    <pslz:zmPr id="{64EB6C04-2ACE-4F0E-BEC1-03A316A8B18C}" returnToParent="0" transitionDur="1000">
+                      <p166:blipFill xmlns:p166="http://schemas.microsoft.com/office/powerpoint/2016/6/main">
+                        <a:blip r:embed="rId2"/>
+                        <a:stretch>
+                          <a:fillRect/>
+                        </a:stretch>
+                      </p166:blipFill>
+                      <p166:spPr xmlns:p166="http://schemas.microsoft.com/office/powerpoint/2016/6/main">
+                        <a:xfrm>
+                          <a:off x="0" y="0"/>
+                          <a:ext cx="6617109" cy="3722124"/>
+                        </a:xfrm>
+                        <a:prstGeom prst="rect">
+                          <a:avLst/>
+                        </a:prstGeom>
+                        <a:ln w="3175">
+                          <a:solidFill>
+                            <a:prstClr val="ltGray"/>
+                          </a:solidFill>
+                        </a:ln>
+                      </p166:spPr>
+                    </pslz:zmPr>
+                  </pslz:sldZmObj>
+                </pslz:sldZm>
+              </a:graphicData>
+            </a:graphic>
+          </p:graphicFrame>
+        </mc:Choice>
+        <mc:Fallback>
+          <p:pic>
+            <p:nvPicPr>
+              <p:cNvPr id="8" name="슬라이드 확대/축소 7">
+                <a:hlinkClick r:id="rId3" action="ppaction://hlinksldjump"/>
+                <a:extLst>
+                  <a:ext uri="{FF2B5EF4-FFF2-40B4-BE49-F238E27FC236}">
+                    <a16:creationId xmlns:a16="http://schemas.microsoft.com/office/drawing/2014/main" id="{D507B324-09B3-7B73-FD30-77FD1CC0027B}"/>
+                  </a:ext>
+                </a:extLst>
+              </p:cNvPr>
+              <p:cNvPicPr>
+                <a:picLocks noGrp="1" noRot="1" noChangeAspect="1" noMove="1" noResize="1" noEditPoints="1" noAdjustHandles="1" noChangeArrowheads="1" noChangeShapeType="1"/>
+              </p:cNvPicPr>
+              <p:nvPr/>
+            </p:nvPicPr>
+            <p:blipFill>
+              <a:blip r:embed="rId2"/>
+              <a:stretch>
+                <a:fillRect/>
+              </a:stretch>
+            </p:blipFill>
+            <p:spPr>
+              <a:xfrm>
+                <a:off x="205986" y="2768395"/>
+                <a:ext cx="6617109" cy="3722124"/>
+              </a:xfrm>
+              <a:prstGeom prst="rect">
+                <a:avLst/>
+              </a:prstGeom>
+              <a:ln w="3175">
+                <a:solidFill>
+                  <a:prstClr val="ltGray"/>
+                </a:solidFill>
+              </a:ln>
+            </p:spPr>
+          </p:pic>
+        </mc:Fallback>
+      </mc:AlternateContent>
     </p:spTree>
     <p:extLst>
       <p:ext uri="{BB962C8B-B14F-4D97-AF65-F5344CB8AC3E}">
@@ -5749,7 +6830,249 @@
 </p:sld>
 </file>
 
-<file path=ppt/slides/slide26.xml><?xml version="1.0" encoding="utf-8"?>
+<file path=ppt/slides/slide27.xml><?xml version="1.0" encoding="utf-8"?>
+<p:sld xmlns:a="http://schemas.openxmlformats.org/drawingml/2006/main" xmlns:r="http://schemas.openxmlformats.org/officeDocument/2006/relationships" xmlns:p="http://schemas.openxmlformats.org/presentationml/2006/main">
+  <p:cSld>
+    <p:spTree>
+      <p:nvGrpSpPr>
+        <p:cNvPr id="1" name="">
+          <a:extLst>
+            <a:ext uri="{FF2B5EF4-FFF2-40B4-BE49-F238E27FC236}">
+              <a16:creationId xmlns:a16="http://schemas.microsoft.com/office/drawing/2014/main" id="{DF16BDEE-4E30-B33C-786A-A062222B609B}"/>
+            </a:ext>
+          </a:extLst>
+        </p:cNvPr>
+        <p:cNvGrpSpPr/>
+        <p:nvPr/>
+      </p:nvGrpSpPr>
+      <p:grpSpPr>
+        <a:xfrm>
+          <a:off x="0" y="0"/>
+          <a:ext cx="0" cy="0"/>
+          <a:chOff x="0" y="0"/>
+          <a:chExt cx="0" cy="0"/>
+        </a:xfrm>
+      </p:grpSpPr>
+      <p:sp>
+        <p:nvSpPr>
+          <p:cNvPr id="2" name="제목 1">
+            <a:extLst>
+              <a:ext uri="{FF2B5EF4-FFF2-40B4-BE49-F238E27FC236}">
+                <a16:creationId xmlns:a16="http://schemas.microsoft.com/office/drawing/2014/main" id="{FDF51FA0-2288-B9C4-6639-D7C68CFC2A26}"/>
+              </a:ext>
+            </a:extLst>
+          </p:cNvPr>
+          <p:cNvSpPr>
+            <a:spLocks noGrp="1"/>
+          </p:cNvSpPr>
+          <p:nvPr>
+            <p:ph type="title"/>
+          </p:nvPr>
+        </p:nvSpPr>
+        <p:spPr>
+          <a:xfrm>
+            <a:off x="0" y="18255"/>
+            <a:ext cx="10515600" cy="850425"/>
+          </a:xfrm>
+        </p:spPr>
+        <p:txBody>
+          <a:bodyPr>
+            <a:normAutofit/>
+          </a:bodyPr>
+          <a:lstStyle/>
+          <a:p>
+            <a:r>
+              <a:rPr lang="en-US" altLang="ko-KR" sz="5400" dirty="0" err="1"/>
+              <a:t>BitAlloter</a:t>
+            </a:r>
+            <a:r>
+              <a:rPr lang="ko-KR" altLang="en-US" sz="5400" dirty="0"/>
+              <a:t>의 순회 방법</a:t>
+            </a:r>
+          </a:p>
+        </p:txBody>
+      </p:sp>
+      <p:sp>
+        <p:nvSpPr>
+          <p:cNvPr id="4" name="TextBox 3">
+            <a:extLst>
+              <a:ext uri="{FF2B5EF4-FFF2-40B4-BE49-F238E27FC236}">
+                <a16:creationId xmlns:a16="http://schemas.microsoft.com/office/drawing/2014/main" id="{8207CD42-075F-59E4-8451-B20704309C2E}"/>
+              </a:ext>
+            </a:extLst>
+          </p:cNvPr>
+          <p:cNvSpPr txBox="1"/>
+          <p:nvPr/>
+        </p:nvSpPr>
+        <p:spPr>
+          <a:xfrm>
+            <a:off x="159773" y="970455"/>
+            <a:ext cx="11766755" cy="1200329"/>
+          </a:xfrm>
+          <a:prstGeom prst="rect">
+            <a:avLst/>
+          </a:prstGeom>
+          <a:noFill/>
+        </p:spPr>
+        <p:txBody>
+          <a:bodyPr wrap="square">
+            <a:spAutoFit/>
+          </a:bodyPr>
+          <a:lstStyle/>
+          <a:p>
+            <a:r>
+              <a:rPr lang="en-US" altLang="ko-KR" dirty="0" err="1"/>
+              <a:t>bitAlloter</a:t>
+            </a:r>
+            <a:r>
+              <a:rPr lang="ko-KR" altLang="en-US" dirty="0"/>
+              <a:t>로 관리되는 오브젝트의 순회는 결국 활성화 비트 </a:t>
+            </a:r>
+            <a:r>
+              <a:rPr lang="en-US" altLang="ko-KR" dirty="0"/>
+              <a:t>(1)</a:t>
+            </a:r>
+            <a:r>
+              <a:rPr lang="ko-KR" altLang="en-US" dirty="0"/>
+              <a:t>로 켜진 오브젝트만을 대상으로 이루어지는데</a:t>
+            </a:r>
+            <a:r>
+              <a:rPr lang="en-US" altLang="ko-KR" dirty="0"/>
+              <a:t>,</a:t>
+            </a:r>
+          </a:p>
+          <a:p>
+            <a:r>
+              <a:rPr lang="ko-KR" altLang="en-US" dirty="0"/>
+              <a:t>이는 </a:t>
+            </a:r>
+            <a:r>
+              <a:rPr lang="en-US" altLang="ko-KR" dirty="0" err="1"/>
+              <a:t>IndexRange</a:t>
+            </a:r>
+            <a:r>
+              <a:rPr lang="ko-KR" altLang="en-US" dirty="0"/>
+              <a:t>의 배열로 해당하는 오브젝트 대상을 미리 뽑아두고 순회를 할 수 있다</a:t>
+            </a:r>
+            <a:r>
+              <a:rPr lang="en-US" altLang="ko-KR" dirty="0"/>
+              <a:t>. (</a:t>
+            </a:r>
+            <a:r>
+              <a:rPr lang="ko-KR" altLang="en-US" dirty="0"/>
+              <a:t>가장 빠른 방식</a:t>
+            </a:r>
+            <a:r>
+              <a:rPr lang="en-US" altLang="ko-KR" dirty="0"/>
+              <a:t>)</a:t>
+            </a:r>
+          </a:p>
+          <a:p>
+            <a:r>
+              <a:rPr lang="en-US" altLang="ko-KR" dirty="0" err="1"/>
+              <a:t>GetTourPairs</a:t>
+            </a:r>
+            <a:r>
+              <a:rPr lang="en-US" altLang="ko-KR" dirty="0"/>
+              <a:t> range</a:t>
+            </a:r>
+            <a:r>
+              <a:rPr lang="ko-KR" altLang="en-US" dirty="0"/>
+              <a:t>의 </a:t>
+            </a:r>
+            <a:r>
+              <a:rPr lang="en-US" altLang="ko-KR" dirty="0" err="1"/>
+              <a:t>startindex</a:t>
+            </a:r>
+            <a:r>
+              <a:rPr lang="en-US" altLang="ko-KR" dirty="0"/>
+              <a:t>, </a:t>
+            </a:r>
+            <a:r>
+              <a:rPr lang="en-US" altLang="ko-KR" dirty="0" err="1"/>
+              <a:t>endindex</a:t>
+            </a:r>
+            <a:r>
+              <a:rPr lang="ko-KR" altLang="en-US" dirty="0"/>
+              <a:t>를 담은 </a:t>
+            </a:r>
+            <a:r>
+              <a:rPr lang="en-US" altLang="ko-KR" dirty="0"/>
+              <a:t>pair</a:t>
+            </a:r>
+            <a:r>
+              <a:rPr lang="ko-KR" altLang="en-US" dirty="0"/>
+              <a:t>들을 순회하며 오브젝트를 처리하면 된다</a:t>
+            </a:r>
+            <a:r>
+              <a:rPr lang="en-US" altLang="ko-KR" dirty="0"/>
+              <a:t>.</a:t>
+            </a:r>
+          </a:p>
+          <a:p>
+            <a:r>
+              <a:rPr lang="ko-KR" altLang="en-US" dirty="0"/>
+              <a:t>아래 코드 </a:t>
+            </a:r>
+            <a:r>
+              <a:rPr lang="ko-KR" altLang="en-US" dirty="0" err="1"/>
+              <a:t>처럼</a:t>
+            </a:r>
+            <a:r>
+              <a:rPr lang="ko-KR" altLang="en-US" dirty="0"/>
+              <a:t> 사용된다</a:t>
+            </a:r>
+            <a:r>
+              <a:rPr lang="en-US" altLang="ko-KR" dirty="0"/>
+              <a:t>.</a:t>
+            </a:r>
+          </a:p>
+        </p:txBody>
+      </p:sp>
+      <p:pic>
+        <p:nvPicPr>
+          <p:cNvPr id="6" name="그림 5">
+            <a:extLst>
+              <a:ext uri="{FF2B5EF4-FFF2-40B4-BE49-F238E27FC236}">
+                <a16:creationId xmlns:a16="http://schemas.microsoft.com/office/drawing/2014/main" id="{048A0B7B-D6B7-55EF-F9E4-3607956E6BB7}"/>
+              </a:ext>
+            </a:extLst>
+          </p:cNvPr>
+          <p:cNvPicPr>
+            <a:picLocks noChangeAspect="1"/>
+          </p:cNvPicPr>
+          <p:nvPr/>
+        </p:nvPicPr>
+        <p:blipFill>
+          <a:blip r:embed="rId2"/>
+          <a:stretch>
+            <a:fillRect/>
+          </a:stretch>
+        </p:blipFill>
+        <p:spPr>
+          <a:xfrm>
+            <a:off x="159773" y="2247697"/>
+            <a:ext cx="7025640" cy="2362605"/>
+          </a:xfrm>
+          <a:prstGeom prst="rect">
+            <a:avLst/>
+          </a:prstGeom>
+        </p:spPr>
+      </p:pic>
+    </p:spTree>
+    <p:extLst>
+      <p:ext uri="{BB962C8B-B14F-4D97-AF65-F5344CB8AC3E}">
+        <p14:creationId xmlns:p14="http://schemas.microsoft.com/office/powerpoint/2010/main" val="977256668"/>
+      </p:ext>
+    </p:extLst>
+  </p:cSld>
+  <p:clrMapOvr>
+    <a:masterClrMapping/>
+  </p:clrMapOvr>
+</p:sld>
+</file>
+
+<file path=ppt/slides/slide28.xml><?xml version="1.0" encoding="utf-8"?>
 <p:sld xmlns:a="http://schemas.openxmlformats.org/drawingml/2006/main" xmlns:r="http://schemas.openxmlformats.org/officeDocument/2006/relationships" xmlns:p="http://schemas.openxmlformats.org/presentationml/2006/main">
   <p:cSld>
     <p:spTree>
@@ -5808,6 +7131,342 @@
           </a:p>
         </p:txBody>
       </p:sp>
+      <p:sp>
+        <p:nvSpPr>
+          <p:cNvPr id="3" name="TextBox 2">
+            <a:extLst>
+              <a:ext uri="{FF2B5EF4-FFF2-40B4-BE49-F238E27FC236}">
+                <a16:creationId xmlns:a16="http://schemas.microsoft.com/office/drawing/2014/main" id="{AAD7D6DC-84FB-9AB3-5CDA-77D37639647D}"/>
+              </a:ext>
+            </a:extLst>
+          </p:cNvPr>
+          <p:cNvSpPr txBox="1"/>
+          <p:nvPr/>
+        </p:nvSpPr>
+        <p:spPr>
+          <a:xfrm>
+            <a:off x="0" y="868680"/>
+            <a:ext cx="10257936" cy="2308324"/>
+          </a:xfrm>
+          <a:prstGeom prst="rect">
+            <a:avLst/>
+          </a:prstGeom>
+          <a:noFill/>
+        </p:spPr>
+        <p:txBody>
+          <a:bodyPr wrap="none" rtlCol="0">
+            <a:spAutoFit/>
+          </a:bodyPr>
+          <a:lstStyle/>
+          <a:p>
+            <a:r>
+              <a:rPr lang="ko-KR" altLang="en-US" dirty="0"/>
+              <a:t>공간을 </a:t>
+            </a:r>
+            <a:r>
+              <a:rPr lang="ko-KR" altLang="en-US" dirty="0" err="1"/>
+              <a:t>청크로</a:t>
+            </a:r>
+            <a:r>
+              <a:rPr lang="ko-KR" altLang="en-US" dirty="0"/>
+              <a:t> 나누었다</a:t>
+            </a:r>
+            <a:r>
+              <a:rPr lang="en-US" altLang="ko-KR" dirty="0"/>
+              <a:t>.</a:t>
+            </a:r>
+          </a:p>
+          <a:p>
+            <a:r>
+              <a:rPr lang="en-US" altLang="ko-KR" dirty="0"/>
+              <a:t>&gt;&gt; </a:t>
+            </a:r>
+            <a:r>
+              <a:rPr lang="ko-KR" altLang="en-US" dirty="0"/>
+              <a:t>왜 나누었는가</a:t>
+            </a:r>
+            <a:r>
+              <a:rPr lang="en-US" altLang="ko-KR" dirty="0"/>
+              <a:t>?</a:t>
+            </a:r>
+          </a:p>
+          <a:p>
+            <a:r>
+              <a:rPr lang="en-US" altLang="ko-KR" dirty="0"/>
+              <a:t>1. Render</a:t>
+            </a:r>
+            <a:r>
+              <a:rPr lang="ko-KR" altLang="en-US" dirty="0"/>
+              <a:t>에서 오브젝트가 많아지더라도 뷰 </a:t>
+            </a:r>
+            <a:r>
+              <a:rPr lang="ko-KR" altLang="en-US" dirty="0" err="1"/>
+              <a:t>프러스텀</a:t>
+            </a:r>
+            <a:r>
+              <a:rPr lang="ko-KR" altLang="en-US" dirty="0"/>
+              <a:t> </a:t>
+            </a:r>
+            <a:r>
+              <a:rPr lang="ko-KR" altLang="en-US" dirty="0" err="1"/>
+              <a:t>컬링을</a:t>
+            </a:r>
+            <a:r>
+              <a:rPr lang="ko-KR" altLang="en-US" dirty="0"/>
+              <a:t> 빠르게 하고 싶었음</a:t>
+            </a:r>
+            <a:r>
+              <a:rPr lang="en-US" altLang="ko-KR" dirty="0"/>
+              <a:t>.</a:t>
+            </a:r>
+          </a:p>
+          <a:p>
+            <a:r>
+              <a:rPr lang="en-US" altLang="ko-KR" dirty="0"/>
+              <a:t>	</a:t>
+            </a:r>
+            <a:r>
+              <a:rPr lang="ko-KR" altLang="en-US" dirty="0"/>
+              <a:t>만약 </a:t>
+            </a:r>
+            <a:r>
+              <a:rPr lang="ko-KR" altLang="en-US" dirty="0" err="1"/>
+              <a:t>청크가</a:t>
+            </a:r>
+            <a:r>
+              <a:rPr lang="ko-KR" altLang="en-US" dirty="0"/>
+              <a:t> 없다면 오브젝트마다 </a:t>
+            </a:r>
+            <a:r>
+              <a:rPr lang="ko-KR" altLang="en-US" dirty="0" err="1"/>
+              <a:t>프러스텀에</a:t>
+            </a:r>
+            <a:r>
+              <a:rPr lang="ko-KR" altLang="en-US" dirty="0"/>
+              <a:t> 들어가는지 체크를 했어야 했음</a:t>
+            </a:r>
+            <a:r>
+              <a:rPr lang="en-US" altLang="ko-KR" dirty="0"/>
+              <a:t>.</a:t>
+            </a:r>
+          </a:p>
+          <a:p>
+            <a:r>
+              <a:rPr lang="en-US" altLang="ko-KR" dirty="0"/>
+              <a:t>2. </a:t>
+            </a:r>
+            <a:r>
+              <a:rPr lang="ko-KR" altLang="en-US" dirty="0"/>
+              <a:t>서버에서 충돌검사를 할 것을 염두에 두었다</a:t>
+            </a:r>
+            <a:r>
+              <a:rPr lang="en-US" altLang="ko-KR" dirty="0"/>
+              <a:t>. </a:t>
+            </a:r>
+            <a:r>
+              <a:rPr lang="ko-KR" altLang="en-US" dirty="0"/>
+              <a:t>충돌의 검사는 </a:t>
+            </a:r>
+            <a:r>
+              <a:rPr lang="en-US" altLang="ko-KR" dirty="0"/>
+              <a:t>O(N^2)</a:t>
+            </a:r>
+            <a:r>
+              <a:rPr lang="ko-KR" altLang="en-US" dirty="0"/>
+              <a:t>의 복잡도를 가지기 때문에</a:t>
+            </a:r>
+            <a:endParaRPr lang="en-US" altLang="ko-KR" dirty="0"/>
+          </a:p>
+          <a:p>
+            <a:r>
+              <a:rPr lang="en-US" altLang="ko-KR" dirty="0"/>
+              <a:t>	</a:t>
+            </a:r>
+            <a:r>
+              <a:rPr lang="ko-KR" altLang="en-US" dirty="0"/>
+              <a:t>작업을 잘게 분할을 하지 않으면 </a:t>
+            </a:r>
+            <a:r>
+              <a:rPr lang="en-US" altLang="ko-KR" dirty="0" err="1"/>
+              <a:t>cpu</a:t>
+            </a:r>
+            <a:r>
+              <a:rPr lang="en-US" altLang="ko-KR" dirty="0"/>
+              <a:t> </a:t>
+            </a:r>
+            <a:r>
+              <a:rPr lang="ko-KR" altLang="en-US" dirty="0"/>
+              <a:t>의 부담이 심해질 것 같았다</a:t>
+            </a:r>
+            <a:r>
+              <a:rPr lang="en-US" altLang="ko-KR" dirty="0"/>
+              <a:t>.</a:t>
+            </a:r>
+          </a:p>
+          <a:p>
+            <a:r>
+              <a:rPr lang="en-US" altLang="ko-KR" dirty="0"/>
+              <a:t>&gt;&gt; </a:t>
+            </a:r>
+            <a:r>
+              <a:rPr lang="ko-KR" altLang="en-US" dirty="0"/>
+              <a:t>때문에 기본적으로 모든 오브젝트들은 </a:t>
+            </a:r>
+            <a:r>
+              <a:rPr lang="en-US" altLang="ko-KR" dirty="0"/>
+              <a:t>Chunk </a:t>
+            </a:r>
+            <a:r>
+              <a:rPr lang="ko-KR" altLang="en-US" dirty="0"/>
+              <a:t>안에 있어야 했고</a:t>
+            </a:r>
+            <a:r>
+              <a:rPr lang="en-US" altLang="ko-KR" dirty="0"/>
+              <a:t>, </a:t>
+            </a:r>
+            <a:r>
+              <a:rPr lang="en-US" altLang="ko-KR" dirty="0" err="1"/>
+              <a:t>chunck</a:t>
+            </a:r>
+            <a:r>
+              <a:rPr lang="en-US" altLang="ko-KR" dirty="0"/>
+              <a:t> </a:t>
+            </a:r>
+            <a:r>
+              <a:rPr lang="ko-KR" altLang="en-US" dirty="0"/>
+              <a:t>안에 </a:t>
+            </a:r>
+            <a:endParaRPr lang="en-US" altLang="ko-KR" dirty="0"/>
+          </a:p>
+          <a:p>
+            <a:r>
+              <a:rPr lang="en-US" altLang="ko-KR" dirty="0" err="1"/>
+              <a:t>StaticObjectVecset</a:t>
+            </a:r>
+            <a:r>
+              <a:rPr lang="en-US" altLang="ko-KR" dirty="0"/>
+              <a:t>, </a:t>
+            </a:r>
+            <a:r>
+              <a:rPr lang="en-US" altLang="ko-KR" dirty="0" err="1"/>
+              <a:t>DynamicObjectVecset</a:t>
+            </a:r>
+            <a:r>
+              <a:rPr lang="en-US" altLang="ko-KR" dirty="0"/>
+              <a:t>, </a:t>
+            </a:r>
+            <a:r>
+              <a:rPr lang="en-US" altLang="ko-KR" dirty="0" err="1"/>
+              <a:t>SkinMeshObjectVecset</a:t>
+            </a:r>
+            <a:r>
+              <a:rPr lang="ko-KR" altLang="en-US" dirty="0"/>
+              <a:t>을 분리하여 저장한다</a:t>
+            </a:r>
+            <a:r>
+              <a:rPr lang="en-US" altLang="ko-KR" dirty="0"/>
+              <a:t>.</a:t>
+            </a:r>
+          </a:p>
+        </p:txBody>
+      </p:sp>
+      <mc:AlternateContent xmlns:mc="http://schemas.openxmlformats.org/markup-compatibility/2006">
+        <mc:Choice xmlns:pslz="http://schemas.microsoft.com/office/powerpoint/2016/slidezoom" Requires="pslz">
+          <p:graphicFrame>
+            <p:nvGraphicFramePr>
+              <p:cNvPr id="5" name="슬라이드 확대/축소 4">
+                <a:extLst>
+                  <a:ext uri="{FF2B5EF4-FFF2-40B4-BE49-F238E27FC236}">
+                    <a16:creationId xmlns:a16="http://schemas.microsoft.com/office/drawing/2014/main" id="{A32FD096-4D7D-DA8D-5C6D-B259A786D223}"/>
+                  </a:ext>
+                </a:extLst>
+              </p:cNvPr>
+              <p:cNvGraphicFramePr>
+                <a:graphicFrameLocks noChangeAspect="1"/>
+              </p:cNvGraphicFramePr>
+              <p:nvPr>
+                <p:extLst>
+                  <p:ext uri="{D42A27DB-BD31-4B8C-83A1-F6EECF244321}">
+                    <p14:modId xmlns:p14="http://schemas.microsoft.com/office/powerpoint/2010/main" val="331875436"/>
+                  </p:ext>
+                </p:extLst>
+              </p:nvPr>
+            </p:nvGraphicFramePr>
+            <p:xfrm>
+              <a:off x="176980" y="3177004"/>
+              <a:ext cx="6235507" cy="3507473"/>
+            </p:xfrm>
+            <a:graphic>
+              <a:graphicData uri="http://schemas.microsoft.com/office/powerpoint/2016/slidezoom">
+                <pslz:sldZm>
+                  <pslz:sldZmObj sldId="284" cId="1005892815">
+                    <pslz:zmPr id="{FE25BFE4-38C9-478C-8B0E-F498B0B711D0}" returnToParent="0" transitionDur="1000">
+                      <p166:blipFill xmlns:p166="http://schemas.microsoft.com/office/powerpoint/2016/6/main">
+                        <a:blip r:embed="rId2"/>
+                        <a:stretch>
+                          <a:fillRect/>
+                        </a:stretch>
+                      </p166:blipFill>
+                      <p166:spPr xmlns:p166="http://schemas.microsoft.com/office/powerpoint/2016/6/main">
+                        <a:xfrm>
+                          <a:off x="0" y="0"/>
+                          <a:ext cx="6235507" cy="3507473"/>
+                        </a:xfrm>
+                        <a:prstGeom prst="rect">
+                          <a:avLst/>
+                        </a:prstGeom>
+                        <a:ln w="3175">
+                          <a:solidFill>
+                            <a:prstClr val="ltGray"/>
+                          </a:solidFill>
+                        </a:ln>
+                      </p166:spPr>
+                    </pslz:zmPr>
+                  </pslz:sldZmObj>
+                </pslz:sldZm>
+              </a:graphicData>
+            </a:graphic>
+          </p:graphicFrame>
+        </mc:Choice>
+        <mc:Fallback>
+          <p:pic>
+            <p:nvPicPr>
+              <p:cNvPr id="5" name="슬라이드 확대/축소 4">
+                <a:hlinkClick r:id="rId3" action="ppaction://hlinksldjump"/>
+                <a:extLst>
+                  <a:ext uri="{FF2B5EF4-FFF2-40B4-BE49-F238E27FC236}">
+                    <a16:creationId xmlns:a16="http://schemas.microsoft.com/office/drawing/2014/main" id="{A32FD096-4D7D-DA8D-5C6D-B259A786D223}"/>
+                  </a:ext>
+                </a:extLst>
+              </p:cNvPr>
+              <p:cNvPicPr>
+                <a:picLocks noGrp="1" noRot="1" noChangeAspect="1" noMove="1" noResize="1" noEditPoints="1" noAdjustHandles="1" noChangeArrowheads="1" noChangeShapeType="1"/>
+              </p:cNvPicPr>
+              <p:nvPr/>
+            </p:nvPicPr>
+            <p:blipFill>
+              <a:blip r:embed="rId2"/>
+              <a:stretch>
+                <a:fillRect/>
+              </a:stretch>
+            </p:blipFill>
+            <p:spPr>
+              <a:xfrm>
+                <a:off x="176980" y="3177004"/>
+                <a:ext cx="6235507" cy="3507473"/>
+              </a:xfrm>
+              <a:prstGeom prst="rect">
+                <a:avLst/>
+              </a:prstGeom>
+              <a:ln w="3175">
+                <a:solidFill>
+                  <a:prstClr val="ltGray"/>
+                </a:solidFill>
+              </a:ln>
+            </p:spPr>
+          </p:pic>
+        </mc:Fallback>
+      </mc:AlternateContent>
     </p:spTree>
     <p:extLst>
       <p:ext uri="{BB962C8B-B14F-4D97-AF65-F5344CB8AC3E}">
@@ -5821,7 +7480,7 @@
 </p:sld>
 </file>
 
-<file path=ppt/slides/slide27.xml><?xml version="1.0" encoding="utf-8"?>
+<file path=ppt/slides/slide29.xml><?xml version="1.0" encoding="utf-8"?>
 <p:sld xmlns:a="http://schemas.openxmlformats.org/drawingml/2006/main" xmlns:r="http://schemas.openxmlformats.org/officeDocument/2006/relationships" xmlns:p="http://schemas.openxmlformats.org/presentationml/2006/main">
   <p:cSld>
     <p:spTree>
@@ -5829,7 +7488,7 @@
         <p:cNvPr id="1" name="">
           <a:extLst>
             <a:ext uri="{FF2B5EF4-FFF2-40B4-BE49-F238E27FC236}">
-              <a16:creationId xmlns:a16="http://schemas.microsoft.com/office/drawing/2014/main" id="{E50CB74A-4402-F9C6-688E-EB4955211B46}"/>
+              <a16:creationId xmlns:a16="http://schemas.microsoft.com/office/drawing/2014/main" id="{599985CC-4D03-1292-E226-C319E963240D}"/>
             </a:ext>
           </a:extLst>
         </p:cNvPr>
@@ -5849,7 +7508,7 @@
           <p:cNvPr id="2" name="제목 1">
             <a:extLst>
               <a:ext uri="{FF2B5EF4-FFF2-40B4-BE49-F238E27FC236}">
-                <a16:creationId xmlns:a16="http://schemas.microsoft.com/office/drawing/2014/main" id="{5A8DA8AC-A393-9337-7348-EFCF4D458A04}"/>
+                <a16:creationId xmlns:a16="http://schemas.microsoft.com/office/drawing/2014/main" id="{350DCC37-3080-F4E8-AA7B-4FF66D6E925E}"/>
               </a:ext>
             </a:extLst>
           </p:cNvPr>
@@ -5873,17 +7532,331 @@
           <a:lstStyle/>
           <a:p>
             <a:r>
-              <a:rPr lang="en-US" altLang="ko-KR" sz="5400" dirty="0"/>
-              <a:t>TimeLine</a:t>
-            </a:r>
-            <a:endParaRPr lang="ko-KR" altLang="en-US" sz="5400" dirty="0"/>
-          </a:p>
-        </p:txBody>
-      </p:sp>
+              <a:rPr lang="en-US" altLang="ko-KR" sz="5400" dirty="0" err="1"/>
+              <a:t>Chunck</a:t>
+            </a:r>
+            <a:r>
+              <a:rPr lang="ko-KR" altLang="en-US" sz="5400" dirty="0"/>
+              <a:t>의 문제점과 해결</a:t>
+            </a:r>
+          </a:p>
+        </p:txBody>
+      </p:sp>
+      <p:sp>
+        <p:nvSpPr>
+          <p:cNvPr id="4" name="TextBox 3">
+            <a:extLst>
+              <a:ext uri="{FF2B5EF4-FFF2-40B4-BE49-F238E27FC236}">
+                <a16:creationId xmlns:a16="http://schemas.microsoft.com/office/drawing/2014/main" id="{FB24A892-2A66-07AB-B5AA-3F07562002E2}"/>
+              </a:ext>
+            </a:extLst>
+          </p:cNvPr>
+          <p:cNvSpPr txBox="1"/>
+          <p:nvPr/>
+        </p:nvSpPr>
+        <p:spPr>
+          <a:xfrm>
+            <a:off x="1" y="868680"/>
+            <a:ext cx="12090400" cy="2308324"/>
+          </a:xfrm>
+          <a:prstGeom prst="rect">
+            <a:avLst/>
+          </a:prstGeom>
+          <a:noFill/>
+        </p:spPr>
+        <p:txBody>
+          <a:bodyPr wrap="square" rtlCol="0">
+            <a:spAutoFit/>
+          </a:bodyPr>
+          <a:lstStyle/>
+          <a:p>
+            <a:r>
+              <a:rPr lang="ko-KR" altLang="en-US" dirty="0"/>
+              <a:t>다만 특정 오브젝트는 여러 </a:t>
+            </a:r>
+            <a:r>
+              <a:rPr lang="ko-KR" altLang="en-US" dirty="0" err="1"/>
+              <a:t>청크에</a:t>
+            </a:r>
+            <a:r>
+              <a:rPr lang="ko-KR" altLang="en-US" dirty="0"/>
+              <a:t> 속해 있을 수 있다</a:t>
+            </a:r>
+            <a:r>
+              <a:rPr lang="en-US" altLang="ko-KR" dirty="0"/>
+              <a:t>. (</a:t>
+            </a:r>
+            <a:r>
+              <a:rPr lang="ko-KR" altLang="en-US" dirty="0"/>
+              <a:t>중간에 걸친 경우</a:t>
+            </a:r>
+            <a:r>
+              <a:rPr lang="en-US" altLang="ko-KR" dirty="0"/>
+              <a:t>)</a:t>
+            </a:r>
+          </a:p>
+          <a:p>
+            <a:r>
+              <a:rPr lang="ko-KR" altLang="en-US" dirty="0"/>
+              <a:t>이럴 경우 오브젝트의 일부를 포함하는 모든 </a:t>
+            </a:r>
+            <a:r>
+              <a:rPr lang="ko-KR" altLang="en-US" dirty="0" err="1"/>
+              <a:t>청크들의</a:t>
+            </a:r>
+            <a:r>
+              <a:rPr lang="ko-KR" altLang="en-US" dirty="0"/>
+              <a:t> </a:t>
+            </a:r>
+            <a:r>
+              <a:rPr lang="en-US" altLang="ko-KR" dirty="0" err="1"/>
+              <a:t>vecset</a:t>
+            </a:r>
+            <a:r>
+              <a:rPr lang="ko-KR" altLang="en-US" dirty="0"/>
+              <a:t>에 해당 오브젝트가 들어가게 된다</a:t>
+            </a:r>
+            <a:r>
+              <a:rPr lang="en-US" altLang="ko-KR" dirty="0"/>
+              <a:t>.</a:t>
+            </a:r>
+          </a:p>
+          <a:p>
+            <a:r>
+              <a:rPr lang="ko-KR" altLang="en-US" dirty="0"/>
+              <a:t>다만 이럴 경우 여러 문제가 생기는데</a:t>
+            </a:r>
+            <a:r>
+              <a:rPr lang="en-US" altLang="ko-KR" dirty="0"/>
+              <a:t>, </a:t>
+            </a:r>
+            <a:r>
+              <a:rPr lang="ko-KR" altLang="en-US" dirty="0"/>
+              <a:t>그것은 다음과 같다</a:t>
+            </a:r>
+            <a:r>
+              <a:rPr lang="en-US" altLang="ko-KR" dirty="0"/>
+              <a:t>.</a:t>
+            </a:r>
+          </a:p>
+          <a:p>
+            <a:pPr marL="342900" indent="-342900">
+              <a:buAutoNum type="arabicPeriod"/>
+            </a:pPr>
+            <a:r>
+              <a:rPr lang="ko-KR" altLang="en-US" dirty="0"/>
+              <a:t>오브젝트마다 한번씩 </a:t>
+            </a:r>
+            <a:r>
+              <a:rPr lang="en-US" altLang="ko-KR" dirty="0"/>
+              <a:t>Update</a:t>
+            </a:r>
+            <a:r>
+              <a:rPr lang="ko-KR" altLang="en-US" dirty="0"/>
+              <a:t>나 </a:t>
+            </a:r>
+            <a:r>
+              <a:rPr lang="en-US" altLang="ko-KR" dirty="0"/>
+              <a:t>Render</a:t>
+            </a:r>
+            <a:r>
+              <a:rPr lang="ko-KR" altLang="en-US" dirty="0"/>
+              <a:t>를 수행해야 </a:t>
+            </a:r>
+            <a:r>
+              <a:rPr lang="ko-KR" altLang="en-US" dirty="0" err="1"/>
+              <a:t>할때는</a:t>
+            </a:r>
+            <a:r>
+              <a:rPr lang="ko-KR" altLang="en-US" dirty="0"/>
+              <a:t> 어떻게 하는가</a:t>
+            </a:r>
+            <a:r>
+              <a:rPr lang="en-US" altLang="ko-KR" dirty="0"/>
+              <a:t>? </a:t>
+            </a:r>
+            <a:r>
+              <a:rPr lang="ko-KR" altLang="en-US" dirty="0"/>
+              <a:t>그럴 때마다 각자가 이미 해당 동작을</a:t>
+            </a:r>
+            <a:r>
+              <a:rPr lang="en-US" altLang="ko-KR" dirty="0"/>
+              <a:t> </a:t>
+            </a:r>
+            <a:r>
+              <a:rPr lang="ko-KR" altLang="en-US" dirty="0"/>
+              <a:t>수행했다는 표시를 해야 하는데</a:t>
+            </a:r>
+            <a:r>
+              <a:rPr lang="en-US" altLang="ko-KR" dirty="0"/>
+              <a:t>, </a:t>
+            </a:r>
+            <a:r>
+              <a:rPr lang="ko-KR" altLang="en-US" dirty="0"/>
+              <a:t>어디에 어떻게 할 것인가</a:t>
+            </a:r>
+            <a:endParaRPr lang="en-US" altLang="ko-KR" dirty="0"/>
+          </a:p>
+          <a:p>
+            <a:pPr marL="342900" indent="-342900">
+              <a:buAutoNum type="arabicPeriod"/>
+            </a:pPr>
+            <a:r>
+              <a:rPr lang="ko-KR" altLang="en-US" dirty="0"/>
+              <a:t>해당 오브젝트가 이동을 하게 된다면</a:t>
+            </a:r>
+            <a:r>
+              <a:rPr lang="en-US" altLang="ko-KR" dirty="0"/>
+              <a:t>, </a:t>
+            </a:r>
+            <a:r>
+              <a:rPr lang="ko-KR" altLang="en-US" dirty="0" err="1"/>
+              <a:t>청크에서</a:t>
+            </a:r>
+            <a:r>
+              <a:rPr lang="ko-KR" altLang="en-US" dirty="0"/>
+              <a:t> 해당 오브젝트가 빠져나가야 한다</a:t>
+            </a:r>
+            <a:r>
+              <a:rPr lang="en-US" altLang="ko-KR" dirty="0"/>
+              <a:t>. </a:t>
+            </a:r>
+            <a:r>
+              <a:rPr lang="ko-KR" altLang="en-US" dirty="0"/>
+              <a:t>그러나 </a:t>
+            </a:r>
+            <a:r>
+              <a:rPr lang="en-US" altLang="ko-KR" dirty="0" err="1"/>
+              <a:t>vecset</a:t>
+            </a:r>
+            <a:r>
+              <a:rPr lang="ko-KR" altLang="en-US" dirty="0"/>
+              <a:t>은 해당 오브젝트가 자신이 어떤 인덱스를 가지고 있었는지 기억해야만 </a:t>
+            </a:r>
+            <a:r>
+              <a:rPr lang="en-US" altLang="ko-KR" dirty="0"/>
+              <a:t>Free</a:t>
+            </a:r>
+            <a:r>
+              <a:rPr lang="ko-KR" altLang="en-US" dirty="0"/>
+              <a:t>를 할 수 있었다</a:t>
+            </a:r>
+            <a:r>
+              <a:rPr lang="en-US" altLang="ko-KR" dirty="0"/>
+              <a:t>. </a:t>
+            </a:r>
+            <a:r>
+              <a:rPr lang="ko-KR" altLang="en-US" dirty="0"/>
+              <a:t>그럼 어떻게 이동을 정상적으로 처리할 수 있겠는가</a:t>
+            </a:r>
+            <a:r>
+              <a:rPr lang="en-US" altLang="ko-KR" dirty="0"/>
+              <a:t>?</a:t>
+            </a:r>
+          </a:p>
+        </p:txBody>
+      </p:sp>
+      <mc:AlternateContent xmlns:mc="http://schemas.openxmlformats.org/markup-compatibility/2006">
+        <mc:Choice xmlns:pslz="http://schemas.microsoft.com/office/powerpoint/2016/slidezoom" Requires="pslz">
+          <p:graphicFrame>
+            <p:nvGraphicFramePr>
+              <p:cNvPr id="6" name="슬라이드 확대/축소 5">
+                <a:extLst>
+                  <a:ext uri="{FF2B5EF4-FFF2-40B4-BE49-F238E27FC236}">
+                    <a16:creationId xmlns:a16="http://schemas.microsoft.com/office/drawing/2014/main" id="{0354CA0C-3B8C-BF9F-4B32-34158CC93393}"/>
+                  </a:ext>
+                </a:extLst>
+              </p:cNvPr>
+              <p:cNvGraphicFramePr>
+                <a:graphicFrameLocks noChangeAspect="1"/>
+              </p:cNvGraphicFramePr>
+              <p:nvPr>
+                <p:extLst>
+                  <p:ext uri="{D42A27DB-BD31-4B8C-83A1-F6EECF244321}">
+                    <p14:modId xmlns:p14="http://schemas.microsoft.com/office/powerpoint/2010/main" val="2554558329"/>
+                  </p:ext>
+                </p:extLst>
+              </p:nvPr>
+            </p:nvGraphicFramePr>
+            <p:xfrm>
+              <a:off x="101599" y="3177004"/>
+              <a:ext cx="6381135" cy="3589388"/>
+            </p:xfrm>
+            <a:graphic>
+              <a:graphicData uri="http://schemas.microsoft.com/office/powerpoint/2016/slidezoom">
+                <pslz:sldZm>
+                  <pslz:sldZmObj sldId="285" cId="1008121533">
+                    <pslz:zmPr id="{1F90038D-034A-4EAB-AB1E-5F294533117C}" returnToParent="0" transitionDur="1000">
+                      <p166:blipFill xmlns:p166="http://schemas.microsoft.com/office/powerpoint/2016/6/main">
+                        <a:blip r:embed="rId2"/>
+                        <a:stretch>
+                          <a:fillRect/>
+                        </a:stretch>
+                      </p166:blipFill>
+                      <p166:spPr xmlns:p166="http://schemas.microsoft.com/office/powerpoint/2016/6/main">
+                        <a:xfrm>
+                          <a:off x="0" y="0"/>
+                          <a:ext cx="6381135" cy="3589388"/>
+                        </a:xfrm>
+                        <a:prstGeom prst="rect">
+                          <a:avLst/>
+                        </a:prstGeom>
+                        <a:ln w="3175">
+                          <a:solidFill>
+                            <a:prstClr val="ltGray"/>
+                          </a:solidFill>
+                        </a:ln>
+                      </p166:spPr>
+                    </pslz:zmPr>
+                  </pslz:sldZmObj>
+                </pslz:sldZm>
+              </a:graphicData>
+            </a:graphic>
+          </p:graphicFrame>
+        </mc:Choice>
+        <mc:Fallback>
+          <p:pic>
+            <p:nvPicPr>
+              <p:cNvPr id="6" name="슬라이드 확대/축소 5">
+                <a:hlinkClick r:id="rId3" action="ppaction://hlinksldjump"/>
+                <a:extLst>
+                  <a:ext uri="{FF2B5EF4-FFF2-40B4-BE49-F238E27FC236}">
+                    <a16:creationId xmlns:a16="http://schemas.microsoft.com/office/drawing/2014/main" id="{0354CA0C-3B8C-BF9F-4B32-34158CC93393}"/>
+                  </a:ext>
+                </a:extLst>
+              </p:cNvPr>
+              <p:cNvPicPr>
+                <a:picLocks noGrp="1" noRot="1" noChangeAspect="1" noMove="1" noResize="1" noEditPoints="1" noAdjustHandles="1" noChangeArrowheads="1" noChangeShapeType="1"/>
+              </p:cNvPicPr>
+              <p:nvPr/>
+            </p:nvPicPr>
+            <p:blipFill>
+              <a:blip r:embed="rId2"/>
+              <a:stretch>
+                <a:fillRect/>
+              </a:stretch>
+            </p:blipFill>
+            <p:spPr>
+              <a:xfrm>
+                <a:off x="101599" y="3177004"/>
+                <a:ext cx="6381135" cy="3589388"/>
+              </a:xfrm>
+              <a:prstGeom prst="rect">
+                <a:avLst/>
+              </a:prstGeom>
+              <a:ln w="3175">
+                <a:solidFill>
+                  <a:prstClr val="ltGray"/>
+                </a:solidFill>
+              </a:ln>
+            </p:spPr>
+          </p:pic>
+        </mc:Fallback>
+      </mc:AlternateContent>
     </p:spTree>
     <p:extLst>
       <p:ext uri="{BB962C8B-B14F-4D97-AF65-F5344CB8AC3E}">
-        <p14:creationId xmlns:p14="http://schemas.microsoft.com/office/powerpoint/2010/main" val="3849585021"/>
+        <p14:creationId xmlns:p14="http://schemas.microsoft.com/office/powerpoint/2010/main" val="1005892815"/>
       </p:ext>
     </p:extLst>
   </p:cSld>
@@ -5946,8 +7919,8 @@
           </a:p>
         </p:txBody>
       </p:sp>
-      <mc:AlternateContent xmlns:mc="http://schemas.openxmlformats.org/markup-compatibility/2006">
-        <mc:Choice xmlns:pslz="http://schemas.microsoft.com/office/powerpoint/2016/slidezoom" Requires="pslz">
+      <mc:AlternateContent xmlns:mc="http://schemas.openxmlformats.org/markup-compatibility/2006" xmlns:pslz="http://schemas.microsoft.com/office/powerpoint/2016/slidezoom">
+        <mc:Choice Requires="pslz">
           <p:graphicFrame>
             <p:nvGraphicFramePr>
               <p:cNvPr id="5" name="슬라이드 확대/축소 4">
@@ -6004,7 +7977,7 @@
             </a:graphic>
           </p:graphicFrame>
         </mc:Choice>
-        <mc:Fallback>
+        <mc:Fallback xmlns="">
           <p:pic>
             <p:nvPicPr>
               <p:cNvPr id="5" name="슬라이드 확대/축소 4">
@@ -6021,7 +7994,7 @@
               <p:nvPr/>
             </p:nvPicPr>
             <p:blipFill>
-              <a:blip r:embed="rId2"/>
+              <a:blip r:embed="rId4"/>
               <a:stretch>
                 <a:fillRect/>
               </a:stretch>
@@ -6043,8 +8016,8 @@
           </p:pic>
         </mc:Fallback>
       </mc:AlternateContent>
-      <mc:AlternateContent xmlns:mc="http://schemas.openxmlformats.org/markup-compatibility/2006">
-        <mc:Choice xmlns:pslz="http://schemas.microsoft.com/office/powerpoint/2016/slidezoom" Requires="pslz">
+      <mc:AlternateContent xmlns:mc="http://schemas.openxmlformats.org/markup-compatibility/2006" xmlns:pslz="http://schemas.microsoft.com/office/powerpoint/2016/slidezoom">
+        <mc:Choice Requires="pslz">
           <p:graphicFrame>
             <p:nvGraphicFramePr>
               <p:cNvPr id="7" name="슬라이드 확대/축소 6">
@@ -6075,7 +8048,7 @@
                   <pslz:sldZmObj sldId="262" cId="1872162543">
                     <pslz:zmPr id="{BDC9DA41-B291-4C0C-B1ED-02A85E5FF9C0}" returnToParent="0" transitionDur="1000">
                       <p166:blipFill xmlns:p166="http://schemas.microsoft.com/office/powerpoint/2016/6/main">
-                        <a:blip r:embed="rId4"/>
+                        <a:blip r:embed="rId5"/>
                         <a:stretch>
                           <a:fillRect/>
                         </a:stretch>
@@ -6101,11 +8074,11 @@
             </a:graphic>
           </p:graphicFrame>
         </mc:Choice>
-        <mc:Fallback>
+        <mc:Fallback xmlns="">
           <p:pic>
             <p:nvPicPr>
               <p:cNvPr id="7" name="슬라이드 확대/축소 6">
-                <a:hlinkClick r:id="rId5" action="ppaction://hlinksldjump"/>
+                <a:hlinkClick r:id="rId6" action="ppaction://hlinksldjump"/>
                 <a:extLst>
                   <a:ext uri="{FF2B5EF4-FFF2-40B4-BE49-F238E27FC236}">
                     <a16:creationId xmlns:a16="http://schemas.microsoft.com/office/drawing/2014/main" id="{5C497EDE-4B29-D25D-0F65-A42F6799D2DD}"/>
@@ -6118,7 +8091,7 @@
               <p:nvPr/>
             </p:nvPicPr>
             <p:blipFill>
-              <a:blip r:embed="rId4"/>
+              <a:blip r:embed="rId7"/>
               <a:stretch>
                 <a:fillRect/>
               </a:stretch>
@@ -6189,6 +8162,558 @@
     <p:extLst>
       <p:ext uri="{BB962C8B-B14F-4D97-AF65-F5344CB8AC3E}">
         <p14:creationId xmlns:p14="http://schemas.microsoft.com/office/powerpoint/2010/main" val="1942532360"/>
+      </p:ext>
+    </p:extLst>
+  </p:cSld>
+  <p:clrMapOvr>
+    <a:masterClrMapping/>
+  </p:clrMapOvr>
+</p:sld>
+</file>
+
+<file path=ppt/slides/slide30.xml><?xml version="1.0" encoding="utf-8"?>
+<p:sld xmlns:a="http://schemas.openxmlformats.org/drawingml/2006/main" xmlns:r="http://schemas.openxmlformats.org/officeDocument/2006/relationships" xmlns:p="http://schemas.openxmlformats.org/presentationml/2006/main">
+  <p:cSld>
+    <p:spTree>
+      <p:nvGrpSpPr>
+        <p:cNvPr id="1" name="">
+          <a:extLst>
+            <a:ext uri="{FF2B5EF4-FFF2-40B4-BE49-F238E27FC236}">
+              <a16:creationId xmlns:a16="http://schemas.microsoft.com/office/drawing/2014/main" id="{B038583A-7194-4E96-4BF8-C3EB893F3FC1}"/>
+            </a:ext>
+          </a:extLst>
+        </p:cNvPr>
+        <p:cNvGrpSpPr/>
+        <p:nvPr/>
+      </p:nvGrpSpPr>
+      <p:grpSpPr>
+        <a:xfrm>
+          <a:off x="0" y="0"/>
+          <a:ext cx="0" cy="0"/>
+          <a:chOff x="0" y="0"/>
+          <a:chExt cx="0" cy="0"/>
+        </a:xfrm>
+      </p:grpSpPr>
+      <p:sp>
+        <p:nvSpPr>
+          <p:cNvPr id="2" name="제목 1">
+            <a:extLst>
+              <a:ext uri="{FF2B5EF4-FFF2-40B4-BE49-F238E27FC236}">
+                <a16:creationId xmlns:a16="http://schemas.microsoft.com/office/drawing/2014/main" id="{A6F28DFD-DCCC-E85F-7428-B796C9192ADA}"/>
+              </a:ext>
+            </a:extLst>
+          </p:cNvPr>
+          <p:cNvSpPr>
+            <a:spLocks noGrp="1"/>
+          </p:cNvSpPr>
+          <p:nvPr>
+            <p:ph type="title"/>
+          </p:nvPr>
+        </p:nvSpPr>
+        <p:spPr>
+          <a:xfrm>
+            <a:off x="-1" y="18255"/>
+            <a:ext cx="12309987" cy="850425"/>
+          </a:xfrm>
+        </p:spPr>
+        <p:txBody>
+          <a:bodyPr>
+            <a:normAutofit fontScale="90000"/>
+          </a:bodyPr>
+          <a:lstStyle/>
+          <a:p>
+            <a:r>
+              <a:rPr lang="en-US" altLang="ko-KR" sz="5400" dirty="0" err="1"/>
+              <a:t>Chunck</a:t>
+            </a:r>
+            <a:r>
+              <a:rPr lang="ko-KR" altLang="en-US" sz="5400" dirty="0"/>
+              <a:t>에 들어가기 위한 </a:t>
+            </a:r>
+            <a:r>
+              <a:rPr lang="en-US" altLang="ko-KR" sz="5400" dirty="0" err="1"/>
+              <a:t>GameObject</a:t>
+            </a:r>
+            <a:r>
+              <a:rPr lang="en-US" altLang="ko-KR" sz="5400" dirty="0"/>
+              <a:t> </a:t>
+            </a:r>
+            <a:r>
+              <a:rPr lang="ko-KR" altLang="en-US" sz="5400" dirty="0"/>
+              <a:t>구조</a:t>
+            </a:r>
+          </a:p>
+        </p:txBody>
+      </p:sp>
+      <p:sp>
+        <p:nvSpPr>
+          <p:cNvPr id="4" name="TextBox 3">
+            <a:extLst>
+              <a:ext uri="{FF2B5EF4-FFF2-40B4-BE49-F238E27FC236}">
+                <a16:creationId xmlns:a16="http://schemas.microsoft.com/office/drawing/2014/main" id="{1808B6FB-BE27-2E62-CE2E-7CF75573670C}"/>
+              </a:ext>
+            </a:extLst>
+          </p:cNvPr>
+          <p:cNvSpPr txBox="1"/>
+          <p:nvPr/>
+        </p:nvSpPr>
+        <p:spPr>
+          <a:xfrm>
+            <a:off x="1" y="868680"/>
+            <a:ext cx="12090400" cy="369332"/>
+          </a:xfrm>
+          <a:prstGeom prst="rect">
+            <a:avLst/>
+          </a:prstGeom>
+          <a:noFill/>
+        </p:spPr>
+        <p:txBody>
+          <a:bodyPr wrap="square" rtlCol="0">
+            <a:spAutoFit/>
+          </a:bodyPr>
+          <a:lstStyle/>
+          <a:p>
+            <a:r>
+              <a:rPr lang="ko-KR" altLang="en-US" dirty="0"/>
+              <a:t>그것은 다음과 같은 </a:t>
+            </a:r>
+            <a:r>
+              <a:rPr lang="en-US" altLang="ko-KR" dirty="0" err="1"/>
+              <a:t>GameObject</a:t>
+            </a:r>
+            <a:r>
+              <a:rPr lang="en-US" altLang="ko-KR" dirty="0"/>
+              <a:t> </a:t>
+            </a:r>
+            <a:r>
+              <a:rPr lang="ko-KR" altLang="en-US" dirty="0"/>
+              <a:t>구조로 해결한다</a:t>
+            </a:r>
+            <a:r>
+              <a:rPr lang="en-US" altLang="ko-KR" dirty="0"/>
+              <a:t>.</a:t>
+            </a:r>
+          </a:p>
+        </p:txBody>
+      </p:sp>
+      <p:pic>
+        <p:nvPicPr>
+          <p:cNvPr id="5" name="그림 4">
+            <a:extLst>
+              <a:ext uri="{FF2B5EF4-FFF2-40B4-BE49-F238E27FC236}">
+                <a16:creationId xmlns:a16="http://schemas.microsoft.com/office/drawing/2014/main" id="{13325B53-DC7C-5E0F-193E-47B984BD604A}"/>
+              </a:ext>
+            </a:extLst>
+          </p:cNvPr>
+          <p:cNvPicPr>
+            <a:picLocks noChangeAspect="1"/>
+          </p:cNvPicPr>
+          <p:nvPr/>
+        </p:nvPicPr>
+        <p:blipFill>
+          <a:blip r:embed="rId2"/>
+          <a:stretch>
+            <a:fillRect/>
+          </a:stretch>
+        </p:blipFill>
+        <p:spPr>
+          <a:xfrm>
+            <a:off x="101599" y="1238012"/>
+            <a:ext cx="8209281" cy="3128402"/>
+          </a:xfrm>
+          <a:prstGeom prst="rect">
+            <a:avLst/>
+          </a:prstGeom>
+        </p:spPr>
+      </p:pic>
+      <p:sp>
+        <p:nvSpPr>
+          <p:cNvPr id="6" name="TextBox 5">
+            <a:extLst>
+              <a:ext uri="{FF2B5EF4-FFF2-40B4-BE49-F238E27FC236}">
+                <a16:creationId xmlns:a16="http://schemas.microsoft.com/office/drawing/2014/main" id="{F85F6586-A141-DF33-A5D4-18BFC127592F}"/>
+              </a:ext>
+            </a:extLst>
+          </p:cNvPr>
+          <p:cNvSpPr txBox="1"/>
+          <p:nvPr/>
+        </p:nvSpPr>
+        <p:spPr>
+          <a:xfrm>
+            <a:off x="0" y="4366414"/>
+            <a:ext cx="9737025" cy="738664"/>
+          </a:xfrm>
+          <a:prstGeom prst="rect">
+            <a:avLst/>
+          </a:prstGeom>
+          <a:noFill/>
+        </p:spPr>
+        <p:txBody>
+          <a:bodyPr wrap="none" rtlCol="0">
+            <a:spAutoFit/>
+          </a:bodyPr>
+          <a:lstStyle/>
+          <a:p>
+            <a:r>
+              <a:rPr lang="en-US" altLang="ko-KR" sz="1400" dirty="0" err="1"/>
+              <a:t>TourID</a:t>
+            </a:r>
+            <a:r>
+              <a:rPr lang="en-US" altLang="ko-KR" sz="1400" dirty="0"/>
+              <a:t> : </a:t>
+            </a:r>
+            <a:r>
+              <a:rPr lang="ko-KR" altLang="en-US" sz="1400" dirty="0"/>
+              <a:t>해당 작업에 하나의</a:t>
+            </a:r>
+            <a:r>
+              <a:rPr lang="en-US" altLang="ko-KR" sz="1400" dirty="0"/>
+              <a:t> </a:t>
+            </a:r>
+            <a:r>
+              <a:rPr lang="en-US" altLang="ko-KR" sz="1400" dirty="0" err="1"/>
+              <a:t>TourID</a:t>
+            </a:r>
+            <a:r>
+              <a:rPr lang="ko-KR" altLang="en-US" sz="1400" dirty="0"/>
+              <a:t>를 </a:t>
+            </a:r>
+            <a:r>
+              <a:rPr lang="ko-KR" altLang="en-US" sz="1400" dirty="0" err="1"/>
+              <a:t>할당받는다</a:t>
+            </a:r>
+            <a:r>
+              <a:rPr lang="en-US" altLang="ko-KR" sz="1400" dirty="0"/>
+              <a:t>. </a:t>
+            </a:r>
+            <a:r>
+              <a:rPr lang="ko-KR" altLang="en-US" sz="1400" dirty="0"/>
+              <a:t>그리고 만약 해당 작업의 </a:t>
+            </a:r>
+            <a:r>
+              <a:rPr lang="en-US" altLang="ko-KR" sz="1400" dirty="0" err="1"/>
+              <a:t>TourID</a:t>
+            </a:r>
+            <a:r>
+              <a:rPr lang="ko-KR" altLang="en-US" sz="1400" dirty="0"/>
+              <a:t>와 오브젝트의 </a:t>
+            </a:r>
+            <a:r>
+              <a:rPr lang="en-US" altLang="ko-KR" sz="1400" dirty="0" err="1"/>
+              <a:t>TourID</a:t>
+            </a:r>
+            <a:r>
+              <a:rPr lang="ko-KR" altLang="en-US" sz="1400" dirty="0"/>
+              <a:t>가 다르다면</a:t>
+            </a:r>
+            <a:endParaRPr lang="en-US" altLang="ko-KR" sz="1400" dirty="0"/>
+          </a:p>
+          <a:p>
+            <a:r>
+              <a:rPr lang="ko-KR" altLang="en-US" sz="1400" dirty="0"/>
+              <a:t>작업을 수행한 후 오브젝트의 </a:t>
+            </a:r>
+            <a:r>
+              <a:rPr lang="en-US" altLang="ko-KR" sz="1400" dirty="0" err="1"/>
+              <a:t>TourID</a:t>
+            </a:r>
+            <a:r>
+              <a:rPr lang="ko-KR" altLang="en-US" sz="1400" dirty="0"/>
+              <a:t>를 작업의 </a:t>
+            </a:r>
+            <a:r>
+              <a:rPr lang="en-US" altLang="ko-KR" sz="1400" dirty="0" err="1"/>
+              <a:t>TourID</a:t>
+            </a:r>
+            <a:r>
+              <a:rPr lang="ko-KR" altLang="en-US" sz="1400" dirty="0"/>
+              <a:t>로 바꾼다</a:t>
+            </a:r>
+            <a:r>
+              <a:rPr lang="en-US" altLang="ko-KR" sz="1400" dirty="0"/>
+              <a:t>. </a:t>
+            </a:r>
+            <a:r>
+              <a:rPr lang="ko-KR" altLang="en-US" sz="1400" dirty="0"/>
+              <a:t>그러면 다른 </a:t>
+            </a:r>
+            <a:r>
+              <a:rPr lang="ko-KR" altLang="en-US" sz="1400" dirty="0" err="1"/>
+              <a:t>청크에서</a:t>
+            </a:r>
+            <a:r>
+              <a:rPr lang="ko-KR" altLang="en-US" sz="1400" dirty="0"/>
+              <a:t> 해당 오브젝트를 참조하더라도</a:t>
+            </a:r>
+            <a:r>
+              <a:rPr lang="en-US" altLang="ko-KR" sz="1400" dirty="0"/>
+              <a:t>, </a:t>
+            </a:r>
+          </a:p>
+          <a:p>
+            <a:r>
+              <a:rPr lang="en-US" altLang="ko-KR" sz="1400" dirty="0" err="1"/>
+              <a:t>TourID</a:t>
+            </a:r>
+            <a:r>
+              <a:rPr lang="ko-KR" altLang="en-US" sz="1400" dirty="0"/>
+              <a:t>가 같으니 작업을 수행하지 않고</a:t>
+            </a:r>
+            <a:r>
+              <a:rPr lang="en-US" altLang="ko-KR" sz="1400" dirty="0"/>
+              <a:t>, </a:t>
+            </a:r>
+            <a:r>
+              <a:rPr lang="ko-KR" altLang="en-US" sz="1400" dirty="0"/>
+              <a:t>결과적으로 어떤 작업이든 모든 오브젝트에 대해 한번씩 수행이 가능하다</a:t>
+            </a:r>
+            <a:r>
+              <a:rPr lang="en-US" altLang="ko-KR" sz="1400" dirty="0"/>
+              <a:t>.</a:t>
+            </a:r>
+          </a:p>
+        </p:txBody>
+      </p:sp>
+      <p:pic>
+        <p:nvPicPr>
+          <p:cNvPr id="8" name="그림 7">
+            <a:extLst>
+              <a:ext uri="{FF2B5EF4-FFF2-40B4-BE49-F238E27FC236}">
+                <a16:creationId xmlns:a16="http://schemas.microsoft.com/office/drawing/2014/main" id="{B089B979-258E-D8D2-B5A0-4D3994A8D429}"/>
+              </a:ext>
+            </a:extLst>
+          </p:cNvPr>
+          <p:cNvPicPr>
+            <a:picLocks noChangeAspect="1"/>
+          </p:cNvPicPr>
+          <p:nvPr/>
+        </p:nvPicPr>
+        <p:blipFill>
+          <a:blip r:embed="rId3"/>
+          <a:stretch>
+            <a:fillRect/>
+          </a:stretch>
+        </p:blipFill>
+        <p:spPr>
+          <a:xfrm>
+            <a:off x="111758" y="5260657"/>
+            <a:ext cx="2257425" cy="1457325"/>
+          </a:xfrm>
+          <a:prstGeom prst="rect">
+            <a:avLst/>
+          </a:prstGeom>
+        </p:spPr>
+      </p:pic>
+      <p:pic>
+        <p:nvPicPr>
+          <p:cNvPr id="10" name="그림 9">
+            <a:extLst>
+              <a:ext uri="{FF2B5EF4-FFF2-40B4-BE49-F238E27FC236}">
+                <a16:creationId xmlns:a16="http://schemas.microsoft.com/office/drawing/2014/main" id="{95EF7EBE-9AA6-8EC3-90DB-41E0FB4C63E1}"/>
+              </a:ext>
+            </a:extLst>
+          </p:cNvPr>
+          <p:cNvPicPr>
+            <a:picLocks noChangeAspect="1"/>
+          </p:cNvPicPr>
+          <p:nvPr/>
+        </p:nvPicPr>
+        <p:blipFill>
+          <a:blip r:embed="rId4"/>
+          <a:stretch>
+            <a:fillRect/>
+          </a:stretch>
+        </p:blipFill>
+        <p:spPr>
+          <a:xfrm>
+            <a:off x="2480941" y="6060757"/>
+            <a:ext cx="2790825" cy="657225"/>
+          </a:xfrm>
+          <a:prstGeom prst="rect">
+            <a:avLst/>
+          </a:prstGeom>
+        </p:spPr>
+      </p:pic>
+      <p:sp>
+        <p:nvSpPr>
+          <p:cNvPr id="11" name="TextBox 10">
+            <a:extLst>
+              <a:ext uri="{FF2B5EF4-FFF2-40B4-BE49-F238E27FC236}">
+                <a16:creationId xmlns:a16="http://schemas.microsoft.com/office/drawing/2014/main" id="{A49783B8-1844-1FF7-3056-C781CE636D96}"/>
+              </a:ext>
+            </a:extLst>
+          </p:cNvPr>
+          <p:cNvSpPr txBox="1"/>
+          <p:nvPr/>
+        </p:nvSpPr>
+        <p:spPr>
+          <a:xfrm>
+            <a:off x="2480941" y="5260657"/>
+            <a:ext cx="5124385" cy="738664"/>
+          </a:xfrm>
+          <a:prstGeom prst="rect">
+            <a:avLst/>
+          </a:prstGeom>
+          <a:noFill/>
+        </p:spPr>
+        <p:txBody>
+          <a:bodyPr wrap="square" rtlCol="0">
+            <a:spAutoFit/>
+          </a:bodyPr>
+          <a:lstStyle/>
+          <a:p>
+            <a:r>
+              <a:rPr lang="ko-KR" altLang="en-US" sz="1400" dirty="0"/>
+              <a:t>이동시의 문제는 각 축마다 최소와 길이를 가지는 범위와</a:t>
+            </a:r>
+            <a:r>
+              <a:rPr lang="en-US" altLang="ko-KR" sz="1400" dirty="0"/>
+              <a:t>, </a:t>
+            </a:r>
+            <a:r>
+              <a:rPr lang="ko-KR" altLang="en-US" sz="1400" dirty="0"/>
+              <a:t>해당 범위에 </a:t>
+            </a:r>
+            <a:r>
+              <a:rPr lang="ko-KR" altLang="en-US" sz="1400" dirty="0" err="1"/>
+              <a:t>청크들에서</a:t>
+            </a:r>
+            <a:r>
+              <a:rPr lang="ko-KR" altLang="en-US" sz="1400" dirty="0"/>
+              <a:t> 해당 오브젝트가 어떤 인덱스에 있는지 저장하는 배열을 </a:t>
+            </a:r>
+            <a:r>
+              <a:rPr lang="ko-KR" altLang="en-US" sz="1400" dirty="0" err="1"/>
+              <a:t>힙</a:t>
+            </a:r>
+            <a:r>
+              <a:rPr lang="ko-KR" altLang="en-US" sz="1400" dirty="0"/>
+              <a:t> 메모리로 할당하여 해결한다</a:t>
+            </a:r>
+            <a:r>
+              <a:rPr lang="en-US" altLang="ko-KR" sz="1400" dirty="0"/>
+              <a:t>.</a:t>
+            </a:r>
+            <a:endParaRPr lang="ko-KR" altLang="en-US" sz="1400" dirty="0"/>
+          </a:p>
+        </p:txBody>
+      </p:sp>
+    </p:spTree>
+    <p:extLst>
+      <p:ext uri="{BB962C8B-B14F-4D97-AF65-F5344CB8AC3E}">
+        <p14:creationId xmlns:p14="http://schemas.microsoft.com/office/powerpoint/2010/main" val="1008121533"/>
+      </p:ext>
+    </p:extLst>
+  </p:cSld>
+  <p:clrMapOvr>
+    <a:masterClrMapping/>
+  </p:clrMapOvr>
+</p:sld>
+</file>
+
+<file path=ppt/slides/slide31.xml><?xml version="1.0" encoding="utf-8"?>
+<p:sld xmlns:a="http://schemas.openxmlformats.org/drawingml/2006/main" xmlns:r="http://schemas.openxmlformats.org/officeDocument/2006/relationships" xmlns:p="http://schemas.openxmlformats.org/presentationml/2006/main">
+  <p:cSld>
+    <p:spTree>
+      <p:nvGrpSpPr>
+        <p:cNvPr id="1" name="">
+          <a:extLst>
+            <a:ext uri="{FF2B5EF4-FFF2-40B4-BE49-F238E27FC236}">
+              <a16:creationId xmlns:a16="http://schemas.microsoft.com/office/drawing/2014/main" id="{E50CB74A-4402-F9C6-688E-EB4955211B46}"/>
+            </a:ext>
+          </a:extLst>
+        </p:cNvPr>
+        <p:cNvGrpSpPr/>
+        <p:nvPr/>
+      </p:nvGrpSpPr>
+      <p:grpSpPr>
+        <a:xfrm>
+          <a:off x="0" y="0"/>
+          <a:ext cx="0" cy="0"/>
+          <a:chOff x="0" y="0"/>
+          <a:chExt cx="0" cy="0"/>
+        </a:xfrm>
+      </p:grpSpPr>
+      <p:sp>
+        <p:nvSpPr>
+          <p:cNvPr id="2" name="제목 1">
+            <a:extLst>
+              <a:ext uri="{FF2B5EF4-FFF2-40B4-BE49-F238E27FC236}">
+                <a16:creationId xmlns:a16="http://schemas.microsoft.com/office/drawing/2014/main" id="{5A8DA8AC-A393-9337-7348-EFCF4D458A04}"/>
+              </a:ext>
+            </a:extLst>
+          </p:cNvPr>
+          <p:cNvSpPr>
+            <a:spLocks noGrp="1"/>
+          </p:cNvSpPr>
+          <p:nvPr>
+            <p:ph type="title"/>
+          </p:nvPr>
+        </p:nvSpPr>
+        <p:spPr>
+          <a:xfrm>
+            <a:off x="0" y="18255"/>
+            <a:ext cx="10515600" cy="850425"/>
+          </a:xfrm>
+        </p:spPr>
+        <p:txBody>
+          <a:bodyPr>
+            <a:normAutofit/>
+          </a:bodyPr>
+          <a:lstStyle/>
+          <a:p>
+            <a:r>
+              <a:rPr lang="en-US" altLang="ko-KR" sz="5400" dirty="0"/>
+              <a:t>TimeLine</a:t>
+            </a:r>
+            <a:endParaRPr lang="ko-KR" altLang="en-US" sz="5400" dirty="0"/>
+          </a:p>
+        </p:txBody>
+      </p:sp>
+      <p:sp>
+        <p:nvSpPr>
+          <p:cNvPr id="3" name="TextBox 2">
+            <a:extLst>
+              <a:ext uri="{FF2B5EF4-FFF2-40B4-BE49-F238E27FC236}">
+                <a16:creationId xmlns:a16="http://schemas.microsoft.com/office/drawing/2014/main" id="{A8AD6AEC-D4E7-CD96-5EEE-F49C9D7D504D}"/>
+              </a:ext>
+            </a:extLst>
+          </p:cNvPr>
+          <p:cNvSpPr txBox="1"/>
+          <p:nvPr/>
+        </p:nvSpPr>
+        <p:spPr>
+          <a:xfrm>
+            <a:off x="0" y="776749"/>
+            <a:ext cx="2989921" cy="369332"/>
+          </a:xfrm>
+          <a:prstGeom prst="rect">
+            <a:avLst/>
+          </a:prstGeom>
+          <a:noFill/>
+        </p:spPr>
+        <p:txBody>
+          <a:bodyPr wrap="none" rtlCol="0">
+            <a:spAutoFit/>
+          </a:bodyPr>
+          <a:lstStyle/>
+          <a:p>
+            <a:r>
+              <a:rPr lang="ko-KR" altLang="en-US" dirty="0"/>
+              <a:t>전체 타임라인을 보여준다</a:t>
+            </a:r>
+            <a:r>
+              <a:rPr lang="en-US" altLang="ko-KR" dirty="0"/>
+              <a:t>.</a:t>
+            </a:r>
+            <a:endParaRPr lang="ko-KR" altLang="en-US" dirty="0"/>
+          </a:p>
+        </p:txBody>
+      </p:sp>
+    </p:spTree>
+    <p:extLst>
+      <p:ext uri="{BB962C8B-B14F-4D97-AF65-F5344CB8AC3E}">
+        <p14:creationId xmlns:p14="http://schemas.microsoft.com/office/powerpoint/2010/main" val="3849585021"/>
       </p:ext>
     </p:extLst>
   </p:cSld>
@@ -6382,8 +8907,8 @@
           </a:p>
         </p:txBody>
       </p:sp>
-      <mc:AlternateContent xmlns:mc="http://schemas.openxmlformats.org/markup-compatibility/2006">
-        <mc:Choice xmlns:pslz="http://schemas.microsoft.com/office/powerpoint/2016/slidezoom" Requires="pslz">
+      <mc:AlternateContent xmlns:mc="http://schemas.openxmlformats.org/markup-compatibility/2006" xmlns:pslz="http://schemas.microsoft.com/office/powerpoint/2016/slidezoom">
+        <mc:Choice Requires="pslz">
           <p:graphicFrame>
             <p:nvGraphicFramePr>
               <p:cNvPr id="14" name="슬라이드 확대/축소 13">
@@ -6440,7 +8965,7 @@
             </a:graphic>
           </p:graphicFrame>
         </mc:Choice>
-        <mc:Fallback>
+        <mc:Fallback xmlns="">
           <p:pic>
             <p:nvPicPr>
               <p:cNvPr id="14" name="슬라이드 확대/축소 13">
@@ -6457,7 +8982,7 @@
               <p:nvPr/>
             </p:nvPicPr>
             <p:blipFill>
-              <a:blip r:embed="rId2"/>
+              <a:blip r:embed="rId4"/>
               <a:stretch>
                 <a:fillRect/>
               </a:stretch>
@@ -6479,8 +9004,8 @@
           </p:pic>
         </mc:Fallback>
       </mc:AlternateContent>
-      <mc:AlternateContent xmlns:mc="http://schemas.openxmlformats.org/markup-compatibility/2006">
-        <mc:Choice xmlns:pslz="http://schemas.microsoft.com/office/powerpoint/2016/slidezoom" Requires="pslz">
+      <mc:AlternateContent xmlns:mc="http://schemas.openxmlformats.org/markup-compatibility/2006" xmlns:pslz="http://schemas.microsoft.com/office/powerpoint/2016/slidezoom">
+        <mc:Choice Requires="pslz">
           <p:graphicFrame>
             <p:nvGraphicFramePr>
               <p:cNvPr id="16" name="슬라이드 확대/축소 15">
@@ -6511,7 +9036,7 @@
                   <pslz:sldZmObj sldId="263" cId="3813102566">
                     <pslz:zmPr id="{C2D96DEF-A3A8-4D0C-A6FC-CA1F606221B8}" returnToParent="0" transitionDur="1000">
                       <p166:blipFill xmlns:p166="http://schemas.microsoft.com/office/powerpoint/2016/6/main">
-                        <a:blip r:embed="rId4"/>
+                        <a:blip r:embed="rId5"/>
                         <a:stretch>
                           <a:fillRect/>
                         </a:stretch>
@@ -6537,11 +9062,11 @@
             </a:graphic>
           </p:graphicFrame>
         </mc:Choice>
-        <mc:Fallback>
+        <mc:Fallback xmlns="">
           <p:pic>
             <p:nvPicPr>
               <p:cNvPr id="16" name="슬라이드 확대/축소 15">
-                <a:hlinkClick r:id="rId5" action="ppaction://hlinksldjump"/>
+                <a:hlinkClick r:id="rId6" action="ppaction://hlinksldjump"/>
                 <a:extLst>
                   <a:ext uri="{FF2B5EF4-FFF2-40B4-BE49-F238E27FC236}">
                     <a16:creationId xmlns:a16="http://schemas.microsoft.com/office/drawing/2014/main" id="{1F2766D2-D008-AEC7-46EF-052E4AB5DEF1}"/>
@@ -6554,7 +9079,7 @@
               <p:nvPr/>
             </p:nvPicPr>
             <p:blipFill>
-              <a:blip r:embed="rId4"/>
+              <a:blip r:embed="rId7"/>
               <a:stretch>
                 <a:fillRect/>
               </a:stretch>
@@ -6593,14 +9118,14 @@
               <p:nvPr>
                 <p:extLst>
                   <p:ext uri="{D42A27DB-BD31-4B8C-83A1-F6EECF244321}">
-                    <p14:modId xmlns:p14="http://schemas.microsoft.com/office/powerpoint/2010/main" val="2647137410"/>
+                    <p14:modId xmlns:p14="http://schemas.microsoft.com/office/powerpoint/2010/main" val="2638548891"/>
                   </p:ext>
                 </p:extLst>
               </p:nvPr>
             </p:nvGraphicFramePr>
             <p:xfrm>
-              <a:off x="0" y="4286250"/>
-              <a:ext cx="4572000" cy="2571750"/>
+              <a:off x="180091" y="4407135"/>
+              <a:ext cx="4324639" cy="2432610"/>
             </p:xfrm>
             <a:graphic>
               <a:graphicData uri="http://schemas.microsoft.com/office/powerpoint/2016/slidezoom">
@@ -6608,7 +9133,7 @@
                   <pslz:sldZmObj sldId="277" cId="2880208972">
                     <pslz:zmPr id="{141A5183-2B03-4ADA-A208-45830EEB14E8}" returnToParent="0" transitionDur="1000">
                       <p166:blipFill xmlns:p166="http://schemas.microsoft.com/office/powerpoint/2016/6/main">
-                        <a:blip r:embed="rId6"/>
+                        <a:blip r:embed="rId8"/>
                         <a:stretch>
                           <a:fillRect/>
                         </a:stretch>
@@ -6616,7 +9141,7 @@
                       <p166:spPr xmlns:p166="http://schemas.microsoft.com/office/powerpoint/2016/6/main">
                         <a:xfrm>
                           <a:off x="0" y="0"/>
-                          <a:ext cx="4572000" cy="2571750"/>
+                          <a:ext cx="4324639" cy="2432610"/>
                         </a:xfrm>
                         <a:prstGeom prst="rect">
                           <a:avLst/>
@@ -6638,7 +9163,7 @@
           <p:pic>
             <p:nvPicPr>
               <p:cNvPr id="18" name="슬라이드 확대/축소 17">
-                <a:hlinkClick r:id="rId7" action="ppaction://hlinksldjump"/>
+                <a:hlinkClick r:id="rId9" action="ppaction://hlinksldjump"/>
                 <a:extLst>
                   <a:ext uri="{FF2B5EF4-FFF2-40B4-BE49-F238E27FC236}">
                     <a16:creationId xmlns:a16="http://schemas.microsoft.com/office/drawing/2014/main" id="{B72E0C2E-6C14-ED9C-31C9-A36C4BDAD061}"/>
@@ -6651,15 +9176,15 @@
               <p:nvPr/>
             </p:nvPicPr>
             <p:blipFill>
-              <a:blip r:embed="rId6"/>
+              <a:blip r:embed="rId8"/>
               <a:stretch>
                 <a:fillRect/>
               </a:stretch>
             </p:blipFill>
             <p:spPr>
               <a:xfrm>
-                <a:off x="0" y="4286250"/>
-                <a:ext cx="4572000" cy="2571750"/>
+                <a:off x="180091" y="4407135"/>
+                <a:ext cx="4324639" cy="2432610"/>
               </a:xfrm>
               <a:prstGeom prst="rect">
                 <a:avLst/>
@@ -6709,6 +9234,46 @@
             <a:r>
               <a:rPr lang="ko-KR" altLang="en-US" dirty="0"/>
               <a:t>비동기 렌더링</a:t>
+            </a:r>
+          </a:p>
+        </p:txBody>
+      </p:sp>
+      <p:sp>
+        <p:nvSpPr>
+          <p:cNvPr id="3" name="TextBox 2">
+            <a:extLst>
+              <a:ext uri="{FF2B5EF4-FFF2-40B4-BE49-F238E27FC236}">
+                <a16:creationId xmlns:a16="http://schemas.microsoft.com/office/drawing/2014/main" id="{318B3F80-6E45-2A12-2B78-E94693FE19EE}"/>
+              </a:ext>
+            </a:extLst>
+          </p:cNvPr>
+          <p:cNvSpPr txBox="1"/>
+          <p:nvPr/>
+        </p:nvSpPr>
+        <p:spPr>
+          <a:xfrm>
+            <a:off x="0" y="4062646"/>
+            <a:ext cx="1420582" cy="369332"/>
+          </a:xfrm>
+          <a:prstGeom prst="rect">
+            <a:avLst/>
+          </a:prstGeom>
+          <a:noFill/>
+          <a:ln w="25400">
+            <a:solidFill>
+              <a:schemeClr val="tx1"/>
+            </a:solidFill>
+          </a:ln>
+        </p:spPr>
+        <p:txBody>
+          <a:bodyPr wrap="none" rtlCol="0">
+            <a:spAutoFit/>
+          </a:bodyPr>
+          <a:lstStyle/>
+          <a:p>
+            <a:r>
+              <a:rPr lang="ko-KR" altLang="en-US" dirty="0"/>
+              <a:t>리소스 관리</a:t>
             </a:r>
           </a:p>
         </p:txBody>
@@ -7160,8 +9725,8 @@
           </a:p>
         </p:txBody>
       </p:sp>
-      <mc:AlternateContent xmlns:mc="http://schemas.openxmlformats.org/markup-compatibility/2006">
-        <mc:Choice xmlns:pslz="http://schemas.microsoft.com/office/powerpoint/2016/slidezoom" Requires="pslz">
+      <mc:AlternateContent xmlns:mc="http://schemas.openxmlformats.org/markup-compatibility/2006" xmlns:pslz="http://schemas.microsoft.com/office/powerpoint/2016/slidezoom">
+        <mc:Choice Requires="pslz">
           <p:graphicFrame>
             <p:nvGraphicFramePr>
               <p:cNvPr id="7" name="슬라이드 확대/축소 6">
@@ -7218,7 +9783,7 @@
             </a:graphic>
           </p:graphicFrame>
         </mc:Choice>
-        <mc:Fallback>
+        <mc:Fallback xmlns="">
           <p:pic>
             <p:nvPicPr>
               <p:cNvPr id="7" name="슬라이드 확대/축소 6">
@@ -7235,7 +9800,7 @@
               <p:nvPr/>
             </p:nvPicPr>
             <p:blipFill>
-              <a:blip r:embed="rId3"/>
+              <a:blip r:embed="rId5"/>
               <a:stretch>
                 <a:fillRect/>
               </a:stretch>
@@ -7257,8 +9822,8 @@
           </p:pic>
         </mc:Fallback>
       </mc:AlternateContent>
-      <mc:AlternateContent xmlns:mc="http://schemas.openxmlformats.org/markup-compatibility/2006">
-        <mc:Choice xmlns:pslz="http://schemas.microsoft.com/office/powerpoint/2016/slidezoom" Requires="pslz">
+      <mc:AlternateContent xmlns:mc="http://schemas.openxmlformats.org/markup-compatibility/2006" xmlns:pslz="http://schemas.microsoft.com/office/powerpoint/2016/slidezoom">
+        <mc:Choice Requires="pslz">
           <p:graphicFrame>
             <p:nvGraphicFramePr>
               <p:cNvPr id="9" name="슬라이드 확대/축소 8">
@@ -7289,7 +9854,7 @@
                   <pslz:sldZmObj sldId="282" cId="825479797">
                     <pslz:zmPr id="{CE5D8C70-59BB-47C2-87D2-7CA7FF77941B}" returnToParent="0" transitionDur="1000">
                       <p166:blipFill xmlns:p166="http://schemas.microsoft.com/office/powerpoint/2016/6/main">
-                        <a:blip r:embed="rId5"/>
+                        <a:blip r:embed="rId6"/>
                         <a:stretch>
                           <a:fillRect/>
                         </a:stretch>
@@ -7315,11 +9880,11 @@
             </a:graphic>
           </p:graphicFrame>
         </mc:Choice>
-        <mc:Fallback>
+        <mc:Fallback xmlns="">
           <p:pic>
             <p:nvPicPr>
               <p:cNvPr id="9" name="슬라이드 확대/축소 8">
-                <a:hlinkClick r:id="rId6" action="ppaction://hlinksldjump"/>
+                <a:hlinkClick r:id="rId7" action="ppaction://hlinksldjump"/>
                 <a:extLst>
                   <a:ext uri="{FF2B5EF4-FFF2-40B4-BE49-F238E27FC236}">
                     <a16:creationId xmlns:a16="http://schemas.microsoft.com/office/drawing/2014/main" id="{C9C5A58F-C6A3-86E1-87F3-43464A84862D}"/>
@@ -7332,7 +9897,7 @@
               <p:nvPr/>
             </p:nvPicPr>
             <p:blipFill>
-              <a:blip r:embed="rId5"/>
+              <a:blip r:embed="rId8"/>
               <a:stretch>
                 <a:fillRect/>
               </a:stretch>
@@ -9950,24 +12515,59 @@
             </a:r>
           </a:p>
           <a:p>
-            <a:endParaRPr lang="en-US" altLang="ko-KR" sz="1200" dirty="0"/>
-          </a:p>
-          <a:p>
+            <a:r>
+              <a:rPr lang="ko-KR" altLang="en-US" sz="1200" dirty="0"/>
+              <a:t>이걸 하기 위해 </a:t>
+            </a:r>
             <a:r>
               <a:rPr lang="en-US" altLang="ko-KR" sz="1200" dirty="0"/>
-              <a:t>&gt;&gt; </a:t>
+              <a:t>Game </a:t>
             </a:r>
             <a:r>
               <a:rPr lang="ko-KR" altLang="en-US" sz="1200" dirty="0"/>
-              <a:t>잘 </a:t>
+              <a:t>구조체에 반영구적인 리소스들의 구조체에 </a:t>
+            </a:r>
+            <a:r>
+              <a:rPr lang="en-US" altLang="ko-KR" sz="1200" dirty="0" err="1"/>
+              <a:t>DescIndex</a:t>
+            </a:r>
+            <a:r>
+              <a:rPr lang="ko-KR" altLang="en-US" sz="1200" dirty="0"/>
+              <a:t>가 있다</a:t>
+            </a:r>
+            <a:r>
+              <a:rPr lang="en-US" altLang="ko-KR" sz="1200" dirty="0"/>
+              <a:t>.</a:t>
+            </a:r>
+          </a:p>
+          <a:p>
+            <a:r>
+              <a:rPr lang="ko-KR" altLang="en-US" sz="1200" dirty="0"/>
+              <a:t>구조가 </a:t>
             </a:r>
             <a:r>
               <a:rPr lang="ko-KR" altLang="en-US" sz="1200" dirty="0" err="1"/>
-              <a:t>이해될려나</a:t>
+              <a:t>바뀔때</a:t>
+            </a:r>
+            <a:r>
+              <a:rPr lang="ko-KR" altLang="en-US" sz="1200" dirty="0"/>
+              <a:t> 해당 리소스들을 순회하면서 </a:t>
+            </a:r>
+            <a:r>
+              <a:rPr lang="en-US" altLang="ko-KR" sz="1200" dirty="0" err="1"/>
+              <a:t>DescIndex</a:t>
+            </a:r>
+            <a:r>
+              <a:rPr lang="ko-KR" altLang="en-US" sz="1200" dirty="0"/>
+              <a:t>를 알맞게 </a:t>
+            </a:r>
+            <a:r>
+              <a:rPr lang="ko-KR" altLang="en-US" sz="1200" dirty="0" err="1"/>
+              <a:t>이격해준다</a:t>
             </a:r>
             <a:r>
               <a:rPr lang="en-US" altLang="ko-KR" sz="1200" dirty="0"/>
-              <a:t>?</a:t>
+              <a:t>.</a:t>
             </a:r>
           </a:p>
         </p:txBody>
@@ -10566,7 +13166,7 @@
         </p:nvSpPr>
         <p:spPr>
           <a:xfrm>
-            <a:off x="0" y="18255"/>
+            <a:off x="0" y="0"/>
             <a:ext cx="10515600" cy="850425"/>
           </a:xfrm>
         </p:spPr>
@@ -10861,8 +13461,8 @@
           </a:p>
         </p:txBody>
       </p:sp>
-      <mc:AlternateContent xmlns:mc="http://schemas.openxmlformats.org/markup-compatibility/2006">
-        <mc:Choice xmlns:pslz="http://schemas.microsoft.com/office/powerpoint/2016/slidezoom" Requires="pslz">
+      <mc:AlternateContent xmlns:mc="http://schemas.openxmlformats.org/markup-compatibility/2006" xmlns:pslz="http://schemas.microsoft.com/office/powerpoint/2016/slidezoom">
+        <mc:Choice Requires="pslz">
           <p:graphicFrame>
             <p:nvGraphicFramePr>
               <p:cNvPr id="10" name="슬라이드 확대/축소 9">
@@ -10919,7 +13519,7 @@
             </a:graphic>
           </p:graphicFrame>
         </mc:Choice>
-        <mc:Fallback>
+        <mc:Fallback xmlns="">
           <p:pic>
             <p:nvPicPr>
               <p:cNvPr id="10" name="슬라이드 확대/축소 9">
@@ -10936,7 +13536,7 @@
               <p:nvPr/>
             </p:nvPicPr>
             <p:blipFill>
-              <a:blip r:embed="rId2"/>
+              <a:blip r:embed="rId4"/>
               <a:stretch>
                 <a:fillRect/>
               </a:stretch>
@@ -10958,8 +13558,8 @@
           </p:pic>
         </mc:Fallback>
       </mc:AlternateContent>
-      <mc:AlternateContent xmlns:mc="http://schemas.openxmlformats.org/markup-compatibility/2006">
-        <mc:Choice xmlns:pslz="http://schemas.microsoft.com/office/powerpoint/2016/slidezoom" Requires="pslz">
+      <mc:AlternateContent xmlns:mc="http://schemas.openxmlformats.org/markup-compatibility/2006" xmlns:pslz="http://schemas.microsoft.com/office/powerpoint/2016/slidezoom">
+        <mc:Choice Requires="pslz">
           <p:graphicFrame>
             <p:nvGraphicFramePr>
               <p:cNvPr id="12" name="슬라이드 확대/축소 11">
@@ -10990,7 +13590,7 @@
                   <pslz:sldZmObj sldId="266" cId="2502613761">
                     <pslz:zmPr id="{3DF0F88A-C4B4-4B73-8457-00D116026201}" returnToParent="0" transitionDur="1000">
                       <p166:blipFill xmlns:p166="http://schemas.microsoft.com/office/powerpoint/2016/6/main">
-                        <a:blip r:embed="rId4"/>
+                        <a:blip r:embed="rId5"/>
                         <a:stretch>
                           <a:fillRect/>
                         </a:stretch>
@@ -11016,11 +13616,11 @@
             </a:graphic>
           </p:graphicFrame>
         </mc:Choice>
-        <mc:Fallback>
+        <mc:Fallback xmlns="">
           <p:pic>
             <p:nvPicPr>
               <p:cNvPr id="12" name="슬라이드 확대/축소 11">
-                <a:hlinkClick r:id="rId5" action="ppaction://hlinksldjump"/>
+                <a:hlinkClick r:id="rId6" action="ppaction://hlinksldjump"/>
                 <a:extLst>
                   <a:ext uri="{FF2B5EF4-FFF2-40B4-BE49-F238E27FC236}">
                     <a16:creationId xmlns:a16="http://schemas.microsoft.com/office/drawing/2014/main" id="{C51DCB39-E942-FDA7-1A76-5358BBA4881C}"/>
@@ -11033,7 +13633,7 @@
               <p:nvPr/>
             </p:nvPicPr>
             <p:blipFill>
-              <a:blip r:embed="rId4"/>
+              <a:blip r:embed="rId7"/>
               <a:stretch>
                 <a:fillRect/>
               </a:stretch>
@@ -11055,8 +13655,8 @@
           </p:pic>
         </mc:Fallback>
       </mc:AlternateContent>
-      <mc:AlternateContent xmlns:mc="http://schemas.openxmlformats.org/markup-compatibility/2006">
-        <mc:Choice xmlns:pslz="http://schemas.microsoft.com/office/powerpoint/2016/slidezoom" Requires="pslz">
+      <mc:AlternateContent xmlns:mc="http://schemas.openxmlformats.org/markup-compatibility/2006" xmlns:pslz="http://schemas.microsoft.com/office/powerpoint/2016/slidezoom">
+        <mc:Choice Requires="pslz">
           <p:graphicFrame>
             <p:nvGraphicFramePr>
               <p:cNvPr id="14" name="슬라이드 확대/축소 13">
@@ -11087,7 +13687,7 @@
                   <pslz:sldZmObj sldId="267" cId="553687500">
                     <pslz:zmPr id="{2E8E69AB-0855-4BA1-8AD9-35242E1A23E1}" returnToParent="0" transitionDur="1000">
                       <p166:blipFill xmlns:p166="http://schemas.microsoft.com/office/powerpoint/2016/6/main">
-                        <a:blip r:embed="rId6"/>
+                        <a:blip r:embed="rId8"/>
                         <a:stretch>
                           <a:fillRect/>
                         </a:stretch>
@@ -11113,11 +13713,11 @@
             </a:graphic>
           </p:graphicFrame>
         </mc:Choice>
-        <mc:Fallback>
+        <mc:Fallback xmlns="">
           <p:pic>
             <p:nvPicPr>
               <p:cNvPr id="14" name="슬라이드 확대/축소 13">
-                <a:hlinkClick r:id="rId7" action="ppaction://hlinksldjump"/>
+                <a:hlinkClick r:id="rId9" action="ppaction://hlinksldjump"/>
                 <a:extLst>
                   <a:ext uri="{FF2B5EF4-FFF2-40B4-BE49-F238E27FC236}">
                     <a16:creationId xmlns:a16="http://schemas.microsoft.com/office/drawing/2014/main" id="{3A0C60E9-4CCD-9FCA-D82D-4FDF9CC5D6A4}"/>
@@ -11130,7 +13730,7 @@
               <p:nvPr/>
             </p:nvPicPr>
             <p:blipFill>
-              <a:blip r:embed="rId6"/>
+              <a:blip r:embed="rId10"/>
               <a:stretch>
                 <a:fillRect/>
               </a:stretch>
@@ -11152,8 +13752,8 @@
           </p:pic>
         </mc:Fallback>
       </mc:AlternateContent>
-      <mc:AlternateContent xmlns:mc="http://schemas.openxmlformats.org/markup-compatibility/2006">
-        <mc:Choice xmlns:pslz="http://schemas.microsoft.com/office/powerpoint/2016/slidezoom" Requires="pslz">
+      <mc:AlternateContent xmlns:mc="http://schemas.openxmlformats.org/markup-compatibility/2006" xmlns:pslz="http://schemas.microsoft.com/office/powerpoint/2016/slidezoom">
+        <mc:Choice Requires="pslz">
           <p:graphicFrame>
             <p:nvGraphicFramePr>
               <p:cNvPr id="16" name="슬라이드 확대/축소 15">
@@ -11184,7 +13784,7 @@
                   <pslz:sldZmObj sldId="268" cId="1408819320">
                     <pslz:zmPr id="{7AF5255F-B81A-4905-9CB3-DA9548B249DD}" returnToParent="0" transitionDur="1000">
                       <p166:blipFill xmlns:p166="http://schemas.microsoft.com/office/powerpoint/2016/6/main">
-                        <a:blip r:embed="rId8"/>
+                        <a:blip r:embed="rId11"/>
                         <a:stretch>
                           <a:fillRect/>
                         </a:stretch>
@@ -11210,11 +13810,11 @@
             </a:graphic>
           </p:graphicFrame>
         </mc:Choice>
-        <mc:Fallback>
+        <mc:Fallback xmlns="">
           <p:pic>
             <p:nvPicPr>
               <p:cNvPr id="16" name="슬라이드 확대/축소 15">
-                <a:hlinkClick r:id="rId9" action="ppaction://hlinksldjump"/>
+                <a:hlinkClick r:id="rId12" action="ppaction://hlinksldjump"/>
                 <a:extLst>
                   <a:ext uri="{FF2B5EF4-FFF2-40B4-BE49-F238E27FC236}">
                     <a16:creationId xmlns:a16="http://schemas.microsoft.com/office/drawing/2014/main" id="{32EBC4D6-83AD-7410-0B85-375DF64E846E}"/>
@@ -11227,7 +13827,7 @@
               <p:nvPr/>
             </p:nvPicPr>
             <p:blipFill>
-              <a:blip r:embed="rId8"/>
+              <a:blip r:embed="rId13"/>
               <a:stretch>
                 <a:fillRect/>
               </a:stretch>
@@ -11249,8 +13849,8 @@
           </p:pic>
         </mc:Fallback>
       </mc:AlternateContent>
-      <mc:AlternateContent xmlns:mc="http://schemas.openxmlformats.org/markup-compatibility/2006">
-        <mc:Choice xmlns:pslz="http://schemas.microsoft.com/office/powerpoint/2016/slidezoom" Requires="pslz">
+      <mc:AlternateContent xmlns:mc="http://schemas.openxmlformats.org/markup-compatibility/2006" xmlns:pslz="http://schemas.microsoft.com/office/powerpoint/2016/slidezoom">
+        <mc:Choice Requires="pslz">
           <p:graphicFrame>
             <p:nvGraphicFramePr>
               <p:cNvPr id="18" name="슬라이드 확대/축소 17">
@@ -11281,7 +13881,7 @@
                   <pslz:sldZmObj sldId="269" cId="2067884293">
                     <pslz:zmPr id="{93AF7E91-8F99-4C22-8120-C7F863FEA8A4}" returnToParent="0" transitionDur="1000">
                       <p166:blipFill xmlns:p166="http://schemas.microsoft.com/office/powerpoint/2016/6/main">
-                        <a:blip r:embed="rId10"/>
+                        <a:blip r:embed="rId14"/>
                         <a:stretch>
                           <a:fillRect/>
                         </a:stretch>
@@ -11307,11 +13907,11 @@
             </a:graphic>
           </p:graphicFrame>
         </mc:Choice>
-        <mc:Fallback>
+        <mc:Fallback xmlns="">
           <p:pic>
             <p:nvPicPr>
               <p:cNvPr id="18" name="슬라이드 확대/축소 17">
-                <a:hlinkClick r:id="rId11" action="ppaction://hlinksldjump"/>
+                <a:hlinkClick r:id="rId15" action="ppaction://hlinksldjump"/>
                 <a:extLst>
                   <a:ext uri="{FF2B5EF4-FFF2-40B4-BE49-F238E27FC236}">
                     <a16:creationId xmlns:a16="http://schemas.microsoft.com/office/drawing/2014/main" id="{E3ABA768-448A-8C95-D4DF-4AADB0CABC92}"/>
@@ -11324,7 +13924,7 @@
               <p:nvPr/>
             </p:nvPicPr>
             <p:blipFill>
-              <a:blip r:embed="rId10"/>
+              <a:blip r:embed="rId16"/>
               <a:stretch>
                 <a:fillRect/>
               </a:stretch>
@@ -11346,8 +13946,8 @@
           </p:pic>
         </mc:Fallback>
       </mc:AlternateContent>
-      <mc:AlternateContent xmlns:mc="http://schemas.openxmlformats.org/markup-compatibility/2006">
-        <mc:Choice xmlns:pslz="http://schemas.microsoft.com/office/powerpoint/2016/slidezoom" Requires="pslz">
+      <mc:AlternateContent xmlns:mc="http://schemas.openxmlformats.org/markup-compatibility/2006" xmlns:pslz="http://schemas.microsoft.com/office/powerpoint/2016/slidezoom">
+        <mc:Choice Requires="pslz">
           <p:graphicFrame>
             <p:nvGraphicFramePr>
               <p:cNvPr id="20" name="슬라이드 확대/축소 19">
@@ -11378,7 +13978,7 @@
                   <pslz:sldZmObj sldId="270" cId="4125104201">
                     <pslz:zmPr id="{3ECA6620-0ABA-4E04-813F-EADB7CE9CF63}" returnToParent="0" transitionDur="1000">
                       <p166:blipFill xmlns:p166="http://schemas.microsoft.com/office/powerpoint/2016/6/main">
-                        <a:blip r:embed="rId12"/>
+                        <a:blip r:embed="rId17"/>
                         <a:stretch>
                           <a:fillRect/>
                         </a:stretch>
@@ -11404,11 +14004,11 @@
             </a:graphic>
           </p:graphicFrame>
         </mc:Choice>
-        <mc:Fallback>
+        <mc:Fallback xmlns="">
           <p:pic>
             <p:nvPicPr>
               <p:cNvPr id="20" name="슬라이드 확대/축소 19">
-                <a:hlinkClick r:id="rId13" action="ppaction://hlinksldjump"/>
+                <a:hlinkClick r:id="rId18" action="ppaction://hlinksldjump"/>
                 <a:extLst>
                   <a:ext uri="{FF2B5EF4-FFF2-40B4-BE49-F238E27FC236}">
                     <a16:creationId xmlns:a16="http://schemas.microsoft.com/office/drawing/2014/main" id="{59C39FA5-0760-1928-8B3F-B56EAB6C80C7}"/>
@@ -11421,7 +14021,7 @@
               <p:nvPr/>
             </p:nvPicPr>
             <p:blipFill>
-              <a:blip r:embed="rId12"/>
+              <a:blip r:embed="rId19"/>
               <a:stretch>
                 <a:fillRect/>
               </a:stretch>
@@ -11443,8 +14043,8 @@
           </p:pic>
         </mc:Fallback>
       </mc:AlternateContent>
-      <mc:AlternateContent xmlns:mc="http://schemas.openxmlformats.org/markup-compatibility/2006">
-        <mc:Choice xmlns:pslz="http://schemas.microsoft.com/office/powerpoint/2016/slidezoom" Requires="pslz">
+      <mc:AlternateContent xmlns:mc="http://schemas.openxmlformats.org/markup-compatibility/2006" xmlns:pslz="http://schemas.microsoft.com/office/powerpoint/2016/slidezoom">
+        <mc:Choice Requires="pslz">
           <p:graphicFrame>
             <p:nvGraphicFramePr>
               <p:cNvPr id="22" name="슬라이드 확대/축소 21">
@@ -11475,7 +14075,7 @@
                   <pslz:sldZmObj sldId="271" cId="1815665238">
                     <pslz:zmPr id="{D690743E-41F9-4BAE-8242-679BCA3314E1}" returnToParent="0" transitionDur="1000">
                       <p166:blipFill xmlns:p166="http://schemas.microsoft.com/office/powerpoint/2016/6/main">
-                        <a:blip r:embed="rId14"/>
+                        <a:blip r:embed="rId20"/>
                         <a:stretch>
                           <a:fillRect/>
                         </a:stretch>
@@ -11501,11 +14101,11 @@
             </a:graphic>
           </p:graphicFrame>
         </mc:Choice>
-        <mc:Fallback>
+        <mc:Fallback xmlns="">
           <p:pic>
             <p:nvPicPr>
               <p:cNvPr id="22" name="슬라이드 확대/축소 21">
-                <a:hlinkClick r:id="rId15" action="ppaction://hlinksldjump"/>
+                <a:hlinkClick r:id="rId21" action="ppaction://hlinksldjump"/>
                 <a:extLst>
                   <a:ext uri="{FF2B5EF4-FFF2-40B4-BE49-F238E27FC236}">
                     <a16:creationId xmlns:a16="http://schemas.microsoft.com/office/drawing/2014/main" id="{604035B8-239E-68C6-0F7C-1B5A3AF20E87}"/>
@@ -11518,7 +14118,7 @@
               <p:nvPr/>
             </p:nvPicPr>
             <p:blipFill>
-              <a:blip r:embed="rId14"/>
+              <a:blip r:embed="rId22"/>
               <a:stretch>
                 <a:fillRect/>
               </a:stretch>
@@ -11540,8 +14140,8 @@
           </p:pic>
         </mc:Fallback>
       </mc:AlternateContent>
-      <mc:AlternateContent xmlns:mc="http://schemas.openxmlformats.org/markup-compatibility/2006">
-        <mc:Choice xmlns:pslz="http://schemas.microsoft.com/office/powerpoint/2016/slidezoom" Requires="pslz">
+      <mc:AlternateContent xmlns:mc="http://schemas.openxmlformats.org/markup-compatibility/2006" xmlns:pslz="http://schemas.microsoft.com/office/powerpoint/2016/slidezoom">
+        <mc:Choice Requires="pslz">
           <p:graphicFrame>
             <p:nvGraphicFramePr>
               <p:cNvPr id="24" name="슬라이드 확대/축소 23">
@@ -11572,7 +14172,7 @@
                   <pslz:sldZmObj sldId="272" cId="1441472548">
                     <pslz:zmPr id="{66D908C9-8FC9-4375-A6D9-E08696BEBFD6}" returnToParent="0" transitionDur="1000">
                       <p166:blipFill xmlns:p166="http://schemas.microsoft.com/office/powerpoint/2016/6/main">
-                        <a:blip r:embed="rId16"/>
+                        <a:blip r:embed="rId23"/>
                         <a:stretch>
                           <a:fillRect/>
                         </a:stretch>
@@ -11598,11 +14198,11 @@
             </a:graphic>
           </p:graphicFrame>
         </mc:Choice>
-        <mc:Fallback>
+        <mc:Fallback xmlns="">
           <p:pic>
             <p:nvPicPr>
               <p:cNvPr id="24" name="슬라이드 확대/축소 23">
-                <a:hlinkClick r:id="rId17" action="ppaction://hlinksldjump"/>
+                <a:hlinkClick r:id="rId24" action="ppaction://hlinksldjump"/>
                 <a:extLst>
                   <a:ext uri="{FF2B5EF4-FFF2-40B4-BE49-F238E27FC236}">
                     <a16:creationId xmlns:a16="http://schemas.microsoft.com/office/drawing/2014/main" id="{B671F9B6-EB52-FCB9-BBD7-0E50EC64E97F}"/>
@@ -11615,7 +14215,7 @@
               <p:nvPr/>
             </p:nvPicPr>
             <p:blipFill>
-              <a:blip r:embed="rId16"/>
+              <a:blip r:embed="rId25"/>
               <a:stretch>
                 <a:fillRect/>
               </a:stretch>
@@ -11637,8 +14237,8 @@
           </p:pic>
         </mc:Fallback>
       </mc:AlternateContent>
-      <mc:AlternateContent xmlns:mc="http://schemas.openxmlformats.org/markup-compatibility/2006">
-        <mc:Choice xmlns:pslz="http://schemas.microsoft.com/office/powerpoint/2016/slidezoom" Requires="pslz">
+      <mc:AlternateContent xmlns:mc="http://schemas.openxmlformats.org/markup-compatibility/2006" xmlns:pslz="http://schemas.microsoft.com/office/powerpoint/2016/slidezoom">
+        <mc:Choice Requires="pslz">
           <p:graphicFrame>
             <p:nvGraphicFramePr>
               <p:cNvPr id="26" name="슬라이드 확대/축소 25">
@@ -11669,7 +14269,7 @@
                   <pslz:sldZmObj sldId="273" cId="533062821">
                     <pslz:zmPr id="{5F53CD1A-DB62-4CA5-81C2-8000346DE2CB}" returnToParent="0" transitionDur="1000">
                       <p166:blipFill xmlns:p166="http://schemas.microsoft.com/office/powerpoint/2016/6/main">
-                        <a:blip r:embed="rId18"/>
+                        <a:blip r:embed="rId26"/>
                         <a:stretch>
                           <a:fillRect/>
                         </a:stretch>
@@ -11695,11 +14295,11 @@
             </a:graphic>
           </p:graphicFrame>
         </mc:Choice>
-        <mc:Fallback>
+        <mc:Fallback xmlns="">
           <p:pic>
             <p:nvPicPr>
               <p:cNvPr id="26" name="슬라이드 확대/축소 25">
-                <a:hlinkClick r:id="rId19" action="ppaction://hlinksldjump"/>
+                <a:hlinkClick r:id="rId27" action="ppaction://hlinksldjump"/>
                 <a:extLst>
                   <a:ext uri="{FF2B5EF4-FFF2-40B4-BE49-F238E27FC236}">
                     <a16:creationId xmlns:a16="http://schemas.microsoft.com/office/drawing/2014/main" id="{ED5ABB81-9220-E126-B9B6-67934342BCC2}"/>
@@ -11712,7 +14312,7 @@
               <p:nvPr/>
             </p:nvPicPr>
             <p:blipFill>
-              <a:blip r:embed="rId18"/>
+              <a:blip r:embed="rId28"/>
               <a:stretch>
                 <a:fillRect/>
               </a:stretch>
@@ -11734,8 +14334,8 @@
           </p:pic>
         </mc:Fallback>
       </mc:AlternateContent>
-      <mc:AlternateContent xmlns:mc="http://schemas.openxmlformats.org/markup-compatibility/2006">
-        <mc:Choice xmlns:pslz="http://schemas.microsoft.com/office/powerpoint/2016/slidezoom" Requires="pslz">
+      <mc:AlternateContent xmlns:mc="http://schemas.openxmlformats.org/markup-compatibility/2006" xmlns:pslz="http://schemas.microsoft.com/office/powerpoint/2016/slidezoom">
+        <mc:Choice Requires="pslz">
           <p:graphicFrame>
             <p:nvGraphicFramePr>
               <p:cNvPr id="28" name="슬라이드 확대/축소 27">
@@ -11766,7 +14366,7 @@
                   <pslz:sldZmObj sldId="274" cId="2958472303">
                     <pslz:zmPr id="{40C1809C-2EF7-4796-9DA2-52B9603AB8D1}" returnToParent="0" transitionDur="1000">
                       <p166:blipFill xmlns:p166="http://schemas.microsoft.com/office/powerpoint/2016/6/main">
-                        <a:blip r:embed="rId20"/>
+                        <a:blip r:embed="rId29"/>
                         <a:stretch>
                           <a:fillRect/>
                         </a:stretch>
@@ -11792,11 +14392,11 @@
             </a:graphic>
           </p:graphicFrame>
         </mc:Choice>
-        <mc:Fallback>
+        <mc:Fallback xmlns="">
           <p:pic>
             <p:nvPicPr>
               <p:cNvPr id="28" name="슬라이드 확대/축소 27">
-                <a:hlinkClick r:id="rId21" action="ppaction://hlinksldjump"/>
+                <a:hlinkClick r:id="rId30" action="ppaction://hlinksldjump"/>
                 <a:extLst>
                   <a:ext uri="{FF2B5EF4-FFF2-40B4-BE49-F238E27FC236}">
                     <a16:creationId xmlns:a16="http://schemas.microsoft.com/office/drawing/2014/main" id="{54DA1A88-CDE0-047B-2EDF-C1A1595113E2}"/>
@@ -11809,7 +14409,7 @@
               <p:nvPr/>
             </p:nvPicPr>
             <p:blipFill>
-              <a:blip r:embed="rId20"/>
+              <a:blip r:embed="rId31"/>
               <a:stretch>
                 <a:fillRect/>
               </a:stretch>
@@ -11916,6 +14516,378 @@
               <a:t>Culling</a:t>
             </a:r>
             <a:endParaRPr lang="ko-KR" altLang="en-US" sz="5400" dirty="0"/>
+          </a:p>
+        </p:txBody>
+      </p:sp>
+      <p:sp>
+        <p:nvSpPr>
+          <p:cNvPr id="3" name="TextBox 2">
+            <a:extLst>
+              <a:ext uri="{FF2B5EF4-FFF2-40B4-BE49-F238E27FC236}">
+                <a16:creationId xmlns:a16="http://schemas.microsoft.com/office/drawing/2014/main" id="{CAC6FA67-470F-213F-77A3-0454538B1C1D}"/>
+              </a:ext>
+            </a:extLst>
+          </p:cNvPr>
+          <p:cNvSpPr txBox="1"/>
+          <p:nvPr/>
+        </p:nvSpPr>
+        <p:spPr>
+          <a:xfrm>
+            <a:off x="12404" y="796412"/>
+            <a:ext cx="11704999" cy="3970318"/>
+          </a:xfrm>
+          <a:prstGeom prst="rect">
+            <a:avLst/>
+          </a:prstGeom>
+          <a:noFill/>
+        </p:spPr>
+        <p:txBody>
+          <a:bodyPr wrap="none" rtlCol="0">
+            <a:spAutoFit/>
+          </a:bodyPr>
+          <a:lstStyle/>
+          <a:p>
+            <a:r>
+              <a:rPr lang="ko-KR" altLang="en-US" dirty="0"/>
+              <a:t>하나의 뷰 포트는 두개의 </a:t>
+            </a:r>
+            <a:r>
+              <a:rPr lang="ko-KR" altLang="en-US" dirty="0" err="1"/>
+              <a:t>프러스텀을</a:t>
+            </a:r>
+            <a:r>
+              <a:rPr lang="ko-KR" altLang="en-US" dirty="0"/>
+              <a:t> 가질 수 있다</a:t>
+            </a:r>
+            <a:r>
+              <a:rPr lang="en-US" altLang="ko-KR" dirty="0"/>
+              <a:t>.</a:t>
+            </a:r>
+          </a:p>
+          <a:p>
+            <a:pPr marL="342900" indent="-342900">
+              <a:buAutoNum type="arabicPeriod"/>
+            </a:pPr>
+            <a:r>
+              <a:rPr lang="ko-KR" altLang="en-US" dirty="0"/>
+              <a:t>직교 </a:t>
+            </a:r>
+            <a:r>
+              <a:rPr lang="ko-KR" altLang="en-US" dirty="0" err="1"/>
+              <a:t>프러스텀</a:t>
+            </a:r>
+            <a:endParaRPr lang="en-US" altLang="ko-KR" dirty="0"/>
+          </a:p>
+          <a:p>
+            <a:pPr marL="342900" indent="-342900">
+              <a:buAutoNum type="arabicPeriod"/>
+            </a:pPr>
+            <a:r>
+              <a:rPr lang="ko-KR" altLang="en-US" dirty="0"/>
+              <a:t>원근 </a:t>
+            </a:r>
+            <a:r>
+              <a:rPr lang="ko-KR" altLang="en-US" dirty="0" err="1"/>
+              <a:t>프러스텀</a:t>
+            </a:r>
+            <a:endParaRPr lang="en-US" altLang="ko-KR" dirty="0"/>
+          </a:p>
+          <a:p>
+            <a:r>
+              <a:rPr lang="ko-KR" altLang="en-US" dirty="0"/>
+              <a:t>직교는 </a:t>
+            </a:r>
+            <a:r>
+              <a:rPr lang="ko-KR" altLang="en-US" dirty="0" err="1"/>
+              <a:t>디렉션</a:t>
+            </a:r>
+            <a:r>
+              <a:rPr lang="ko-KR" altLang="en-US" dirty="0"/>
+              <a:t> </a:t>
+            </a:r>
+            <a:r>
+              <a:rPr lang="ko-KR" altLang="en-US" dirty="0" err="1"/>
+              <a:t>라이팅의</a:t>
+            </a:r>
+            <a:r>
+              <a:rPr lang="ko-KR" altLang="en-US" dirty="0"/>
+              <a:t> 쉐도우 매핑과 같은 작업을 </a:t>
+            </a:r>
+            <a:r>
+              <a:rPr lang="ko-KR" altLang="en-US" dirty="0" err="1"/>
+              <a:t>할때</a:t>
+            </a:r>
+            <a:r>
+              <a:rPr lang="ko-KR" altLang="en-US" dirty="0"/>
+              <a:t> 오브젝트들을 직교로 거르기 위해 사용된다</a:t>
+            </a:r>
+            <a:r>
+              <a:rPr lang="en-US" altLang="ko-KR" dirty="0"/>
+              <a:t>.</a:t>
+            </a:r>
+          </a:p>
+          <a:p>
+            <a:r>
+              <a:rPr lang="ko-KR" altLang="en-US" dirty="0"/>
+              <a:t>원근은 화면 렌더링</a:t>
+            </a:r>
+            <a:r>
+              <a:rPr lang="en-US" altLang="ko-KR" dirty="0"/>
+              <a:t>, </a:t>
+            </a:r>
+            <a:r>
+              <a:rPr lang="ko-KR" altLang="en-US" dirty="0" err="1"/>
+              <a:t>오쿨루션</a:t>
+            </a:r>
+            <a:r>
+              <a:rPr lang="ko-KR" altLang="en-US" dirty="0"/>
+              <a:t> </a:t>
+            </a:r>
+            <a:r>
+              <a:rPr lang="ko-KR" altLang="en-US" dirty="0" err="1"/>
+              <a:t>컬링</a:t>
+            </a:r>
+            <a:r>
+              <a:rPr lang="en-US" altLang="ko-KR" dirty="0"/>
+              <a:t>, </a:t>
+            </a:r>
+            <a:r>
+              <a:rPr lang="ko-KR" altLang="en-US" dirty="0"/>
+              <a:t>그리고 </a:t>
+            </a:r>
+            <a:r>
+              <a:rPr lang="ko-KR" altLang="en-US" dirty="0" err="1"/>
+              <a:t>레이트레이싱에서</a:t>
+            </a:r>
+            <a:r>
+              <a:rPr lang="ko-KR" altLang="en-US" dirty="0"/>
+              <a:t> </a:t>
+            </a:r>
+            <a:r>
+              <a:rPr lang="en-US" altLang="ko-KR" dirty="0" err="1"/>
+              <a:t>SkinMeshBLASUpdate</a:t>
+            </a:r>
+            <a:r>
+              <a:rPr lang="ko-KR" altLang="en-US" dirty="0"/>
+              <a:t>를 위해 사용된다</a:t>
+            </a:r>
+            <a:r>
+              <a:rPr lang="en-US" altLang="ko-KR" dirty="0"/>
+              <a:t>.</a:t>
+            </a:r>
+          </a:p>
+          <a:p>
+            <a:r>
+              <a:rPr lang="ko-KR" altLang="en-US" dirty="0"/>
+              <a:t>직교나 원근이나 </a:t>
+            </a:r>
+            <a:r>
+              <a:rPr lang="ko-KR" altLang="en-US" dirty="0" err="1"/>
+              <a:t>프러스텀</a:t>
+            </a:r>
+            <a:r>
+              <a:rPr lang="ko-KR" altLang="en-US" dirty="0"/>
+              <a:t> </a:t>
+            </a:r>
+            <a:r>
+              <a:rPr lang="ko-KR" altLang="en-US" dirty="0" err="1"/>
+              <a:t>컬링을</a:t>
+            </a:r>
+            <a:r>
+              <a:rPr lang="ko-KR" altLang="en-US" dirty="0"/>
+              <a:t> 하는 방법은 간단하다</a:t>
+            </a:r>
+            <a:r>
+              <a:rPr lang="en-US" altLang="ko-KR" dirty="0"/>
+              <a:t>.</a:t>
+            </a:r>
+          </a:p>
+          <a:p>
+            <a:r>
+              <a:rPr lang="ko-KR" altLang="en-US" dirty="0"/>
+              <a:t>그저 </a:t>
+            </a:r>
+            <a:r>
+              <a:rPr lang="en-US" altLang="ko-KR" dirty="0"/>
+              <a:t>Game </a:t>
+            </a:r>
+            <a:r>
+              <a:rPr lang="ko-KR" altLang="en-US" dirty="0"/>
+              <a:t>구조체에 있는 </a:t>
+            </a:r>
+            <a:r>
+              <a:rPr lang="en-US" altLang="ko-KR" dirty="0" err="1"/>
+              <a:t>RenderTour</a:t>
+            </a:r>
+            <a:r>
+              <a:rPr lang="en-US" altLang="ko-KR" dirty="0"/>
+              <a:t> </a:t>
+            </a:r>
+            <a:r>
+              <a:rPr lang="ko-KR" altLang="en-US" dirty="0"/>
+              <a:t>함수를 호출하면 된다</a:t>
+            </a:r>
+            <a:r>
+              <a:rPr lang="en-US" altLang="ko-KR" dirty="0"/>
+              <a:t>.</a:t>
+            </a:r>
+          </a:p>
+          <a:p>
+            <a:endParaRPr lang="en-US" altLang="ko-KR" dirty="0"/>
+          </a:p>
+          <a:p>
+            <a:r>
+              <a:rPr lang="ko-KR" altLang="en-US" dirty="0"/>
+              <a:t>그럼 오브젝트마다 클래스의 </a:t>
+            </a:r>
+            <a:r>
+              <a:rPr lang="en-US" altLang="ko-KR" dirty="0"/>
+              <a:t>inline static </a:t>
+            </a:r>
+            <a:r>
+              <a:rPr lang="ko-KR" altLang="en-US" dirty="0"/>
+              <a:t>함수 포인터를 이용해 자신의 </a:t>
+            </a:r>
+            <a:r>
+              <a:rPr lang="ko-KR" altLang="en-US" dirty="0" err="1"/>
+              <a:t>맴버함수처럼</a:t>
+            </a:r>
+            <a:r>
+              <a:rPr lang="ko-KR" altLang="en-US" dirty="0"/>
+              <a:t> 호출을 하게 된다</a:t>
+            </a:r>
+            <a:r>
+              <a:rPr lang="en-US" altLang="ko-KR" dirty="0"/>
+              <a:t>.</a:t>
+            </a:r>
+          </a:p>
+          <a:p>
+            <a:r>
+              <a:rPr lang="ko-KR" altLang="en-US" dirty="0"/>
+              <a:t>해당 </a:t>
+            </a:r>
+            <a:r>
+              <a:rPr lang="ko-KR" altLang="en-US" dirty="0" err="1"/>
+              <a:t>함수포인터는</a:t>
+            </a:r>
+            <a:r>
+              <a:rPr lang="ko-KR" altLang="en-US" dirty="0"/>
+              <a:t> 작업을 시작하기 전에 프로그래머가 정할 수 있으며</a:t>
+            </a:r>
+            <a:r>
+              <a:rPr lang="en-US" altLang="ko-KR" dirty="0"/>
+              <a:t>, </a:t>
+            </a:r>
+            <a:r>
+              <a:rPr lang="ko-KR" altLang="en-US" dirty="0"/>
+              <a:t>그것은 </a:t>
+            </a:r>
+            <a:r>
+              <a:rPr lang="en-US" altLang="ko-KR" dirty="0"/>
+              <a:t>Update, Render, </a:t>
+            </a:r>
+            <a:r>
+              <a:rPr lang="en-US" altLang="ko-KR" dirty="0" err="1"/>
+              <a:t>BLASUpdate</a:t>
+            </a:r>
+            <a:r>
+              <a:rPr lang="ko-KR" altLang="en-US" dirty="0"/>
+              <a:t>등</a:t>
+            </a:r>
+            <a:endParaRPr lang="en-US" altLang="ko-KR" dirty="0"/>
+          </a:p>
+          <a:p>
+            <a:r>
+              <a:rPr lang="ko-KR" altLang="en-US" dirty="0"/>
+              <a:t>다양한 작업을 할 수 있다</a:t>
+            </a:r>
+            <a:r>
+              <a:rPr lang="en-US" altLang="ko-KR" dirty="0"/>
+              <a:t>.</a:t>
+            </a:r>
+          </a:p>
+          <a:p>
+            <a:r>
+              <a:rPr lang="ko-KR" altLang="en-US" dirty="0"/>
+              <a:t>또한 </a:t>
+            </a:r>
+            <a:r>
+              <a:rPr lang="en-US" altLang="ko-KR" dirty="0" err="1"/>
+              <a:t>RenderTour</a:t>
+            </a:r>
+            <a:r>
+              <a:rPr lang="en-US" altLang="ko-KR" dirty="0"/>
+              <a:t> </a:t>
+            </a:r>
+            <a:r>
+              <a:rPr lang="ko-KR" altLang="en-US" dirty="0"/>
+              <a:t>함수는 </a:t>
+            </a:r>
+            <a:r>
+              <a:rPr lang="en-US" altLang="ko-KR" dirty="0"/>
+              <a:t>template</a:t>
+            </a:r>
+            <a:r>
+              <a:rPr lang="ko-KR" altLang="en-US" dirty="0"/>
+              <a:t>함수이기 때문에</a:t>
+            </a:r>
+            <a:r>
+              <a:rPr lang="en-US" altLang="ko-KR" dirty="0"/>
+              <a:t>, </a:t>
+            </a:r>
+            <a:r>
+              <a:rPr lang="ko-KR" altLang="en-US" dirty="0" err="1"/>
+              <a:t>탬플릿</a:t>
+            </a:r>
+            <a:r>
+              <a:rPr lang="ko-KR" altLang="en-US" dirty="0"/>
+              <a:t> 변수로 </a:t>
+            </a:r>
+            <a:endParaRPr lang="en-US" altLang="ko-KR" dirty="0"/>
+          </a:p>
+          <a:p>
+            <a:r>
+              <a:rPr lang="ko-KR" altLang="en-US" dirty="0"/>
+              <a:t>어떤 오브젝트에 대해 연산을 </a:t>
+            </a:r>
+            <a:r>
+              <a:rPr lang="ko-KR" altLang="en-US" dirty="0" err="1"/>
+              <a:t>수행할건지도</a:t>
+            </a:r>
+            <a:r>
+              <a:rPr lang="ko-KR" altLang="en-US" dirty="0"/>
+              <a:t> 선택이 가능하다</a:t>
+            </a:r>
+            <a:r>
+              <a:rPr lang="en-US" altLang="ko-KR" dirty="0"/>
+              <a:t>.</a:t>
+            </a:r>
+          </a:p>
+          <a:p>
+            <a:r>
+              <a:rPr lang="ko-KR" altLang="en-US" dirty="0"/>
+              <a:t>내부적으로 </a:t>
+            </a:r>
+            <a:r>
+              <a:rPr lang="en-US" altLang="ko-KR" dirty="0"/>
+              <a:t>if </a:t>
+            </a:r>
+            <a:r>
+              <a:rPr lang="en-US" altLang="ko-KR" dirty="0" err="1"/>
+              <a:t>constexpr</a:t>
+            </a:r>
+            <a:r>
+              <a:rPr lang="en-US" altLang="ko-KR" dirty="0"/>
+              <a:t> </a:t>
+            </a:r>
+            <a:r>
+              <a:rPr lang="ko-KR" altLang="en-US" dirty="0"/>
+              <a:t>로 되어있어서 변수가 다르면 컴파일러는 다른 코드를 만든다</a:t>
+            </a:r>
+            <a:r>
+              <a:rPr lang="en-US" altLang="ko-KR" dirty="0"/>
+              <a:t>.</a:t>
+            </a:r>
           </a:p>
         </p:txBody>
       </p:sp>

</xml_diff>

<commit_message>
SyncFPS CLient/Server CompileErrorFinding / Make SyncOffset Logic / Linking / NWLibDelete / NewRendering Update
</commit_message>
<xml_diff>
--- a/Conference/GraphicsStudy/GraphicsHighLevelDesign.pptx
+++ b/Conference/GraphicsStudy/GraphicsHighLevelDesign.pptx
@@ -289,7 +289,7 @@
           <a:p>
             <a:fld id="{D8810A9B-0CC6-4053-BA0B-965178095DC3}" type="datetimeFigureOut">
               <a:rPr lang="ko-KR" altLang="en-US" smtClean="0"/>
-              <a:t>2026-03-07</a:t>
+              <a:t>2026-03-12</a:t>
             </a:fld>
             <a:endParaRPr lang="ko-KR" altLang="en-US"/>
           </a:p>
@@ -487,7 +487,7 @@
           <a:p>
             <a:fld id="{D8810A9B-0CC6-4053-BA0B-965178095DC3}" type="datetimeFigureOut">
               <a:rPr lang="ko-KR" altLang="en-US" smtClean="0"/>
-              <a:t>2026-03-07</a:t>
+              <a:t>2026-03-12</a:t>
             </a:fld>
             <a:endParaRPr lang="ko-KR" altLang="en-US"/>
           </a:p>
@@ -695,7 +695,7 @@
           <a:p>
             <a:fld id="{D8810A9B-0CC6-4053-BA0B-965178095DC3}" type="datetimeFigureOut">
               <a:rPr lang="ko-KR" altLang="en-US" smtClean="0"/>
-              <a:t>2026-03-07</a:t>
+              <a:t>2026-03-12</a:t>
             </a:fld>
             <a:endParaRPr lang="ko-KR" altLang="en-US"/>
           </a:p>
@@ -893,7 +893,7 @@
           <a:p>
             <a:fld id="{D8810A9B-0CC6-4053-BA0B-965178095DC3}" type="datetimeFigureOut">
               <a:rPr lang="ko-KR" altLang="en-US" smtClean="0"/>
-              <a:t>2026-03-07</a:t>
+              <a:t>2026-03-12</a:t>
             </a:fld>
             <a:endParaRPr lang="ko-KR" altLang="en-US"/>
           </a:p>
@@ -1168,7 +1168,7 @@
           <a:p>
             <a:fld id="{D8810A9B-0CC6-4053-BA0B-965178095DC3}" type="datetimeFigureOut">
               <a:rPr lang="ko-KR" altLang="en-US" smtClean="0"/>
-              <a:t>2026-03-07</a:t>
+              <a:t>2026-03-12</a:t>
             </a:fld>
             <a:endParaRPr lang="ko-KR" altLang="en-US"/>
           </a:p>
@@ -1433,7 +1433,7 @@
           <a:p>
             <a:fld id="{D8810A9B-0CC6-4053-BA0B-965178095DC3}" type="datetimeFigureOut">
               <a:rPr lang="ko-KR" altLang="en-US" smtClean="0"/>
-              <a:t>2026-03-07</a:t>
+              <a:t>2026-03-12</a:t>
             </a:fld>
             <a:endParaRPr lang="ko-KR" altLang="en-US"/>
           </a:p>
@@ -1845,7 +1845,7 @@
           <a:p>
             <a:fld id="{D8810A9B-0CC6-4053-BA0B-965178095DC3}" type="datetimeFigureOut">
               <a:rPr lang="ko-KR" altLang="en-US" smtClean="0"/>
-              <a:t>2026-03-07</a:t>
+              <a:t>2026-03-12</a:t>
             </a:fld>
             <a:endParaRPr lang="ko-KR" altLang="en-US"/>
           </a:p>
@@ -1986,7 +1986,7 @@
           <a:p>
             <a:fld id="{D8810A9B-0CC6-4053-BA0B-965178095DC3}" type="datetimeFigureOut">
               <a:rPr lang="ko-KR" altLang="en-US" smtClean="0"/>
-              <a:t>2026-03-07</a:t>
+              <a:t>2026-03-12</a:t>
             </a:fld>
             <a:endParaRPr lang="ko-KR" altLang="en-US"/>
           </a:p>
@@ -2099,7 +2099,7 @@
           <a:p>
             <a:fld id="{D8810A9B-0CC6-4053-BA0B-965178095DC3}" type="datetimeFigureOut">
               <a:rPr lang="ko-KR" altLang="en-US" smtClean="0"/>
-              <a:t>2026-03-07</a:t>
+              <a:t>2026-03-12</a:t>
             </a:fld>
             <a:endParaRPr lang="ko-KR" altLang="en-US"/>
           </a:p>
@@ -2410,7 +2410,7 @@
           <a:p>
             <a:fld id="{D8810A9B-0CC6-4053-BA0B-965178095DC3}" type="datetimeFigureOut">
               <a:rPr lang="ko-KR" altLang="en-US" smtClean="0"/>
-              <a:t>2026-03-07</a:t>
+              <a:t>2026-03-12</a:t>
             </a:fld>
             <a:endParaRPr lang="ko-KR" altLang="en-US"/>
           </a:p>
@@ -2698,7 +2698,7 @@
           <a:p>
             <a:fld id="{D8810A9B-0CC6-4053-BA0B-965178095DC3}" type="datetimeFigureOut">
               <a:rPr lang="ko-KR" altLang="en-US" smtClean="0"/>
-              <a:t>2026-03-07</a:t>
+              <a:t>2026-03-12</a:t>
             </a:fld>
             <a:endParaRPr lang="ko-KR" altLang="en-US"/>
           </a:p>
@@ -2939,7 +2939,7 @@
           <a:p>
             <a:fld id="{D8810A9B-0CC6-4053-BA0B-965178095DC3}" type="datetimeFigureOut">
               <a:rPr lang="ko-KR" altLang="en-US" smtClean="0"/>
-              <a:t>2026-03-07</a:t>
+              <a:t>2026-03-12</a:t>
             </a:fld>
             <a:endParaRPr lang="ko-KR" altLang="en-US"/>
           </a:p>
@@ -4837,8 +4837,8 @@
           </a:p>
         </p:txBody>
       </p:sp>
-      <mc:AlternateContent xmlns:mc="http://schemas.openxmlformats.org/markup-compatibility/2006">
-        <mc:Choice xmlns:pslz="http://schemas.microsoft.com/office/powerpoint/2016/slidezoom" Requires="pslz">
+      <mc:AlternateContent xmlns:mc="http://schemas.openxmlformats.org/markup-compatibility/2006" xmlns:pslz="http://schemas.microsoft.com/office/powerpoint/2016/slidezoom">
+        <mc:Choice Requires="pslz">
           <p:graphicFrame>
             <p:nvGraphicFramePr>
               <p:cNvPr id="11" name="슬라이드 확대/축소 10">
@@ -4895,7 +4895,7 @@
             </a:graphic>
           </p:graphicFrame>
         </mc:Choice>
-        <mc:Fallback>
+        <mc:Fallback xmlns="">
           <p:pic>
             <p:nvPicPr>
               <p:cNvPr id="11" name="슬라이드 확대/축소 10">
@@ -4912,7 +4912,7 @@
               <p:nvPr/>
             </p:nvPicPr>
             <p:blipFill>
-              <a:blip r:embed="rId8"/>
+              <a:blip r:embed="rId9"/>
               <a:stretch>
                 <a:fillRect/>
               </a:stretch>
@@ -6720,8 +6720,8 @@
           </a:p>
         </p:txBody>
       </p:sp>
-      <mc:AlternateContent xmlns:mc="http://schemas.openxmlformats.org/markup-compatibility/2006">
-        <mc:Choice xmlns:pslz="http://schemas.microsoft.com/office/powerpoint/2016/slidezoom" Requires="pslz">
+      <mc:AlternateContent xmlns:mc="http://schemas.openxmlformats.org/markup-compatibility/2006" xmlns:pslz="http://schemas.microsoft.com/office/powerpoint/2016/slidezoom">
+        <mc:Choice Requires="pslz">
           <p:graphicFrame>
             <p:nvGraphicFramePr>
               <p:cNvPr id="8" name="슬라이드 확대/축소 7">
@@ -6778,7 +6778,7 @@
             </a:graphic>
           </p:graphicFrame>
         </mc:Choice>
-        <mc:Fallback>
+        <mc:Fallback xmlns="">
           <p:pic>
             <p:nvPicPr>
               <p:cNvPr id="8" name="슬라이드 확대/축소 7">
@@ -6795,7 +6795,7 @@
               <p:nvPr/>
             </p:nvPicPr>
             <p:blipFill>
-              <a:blip r:embed="rId2"/>
+              <a:blip r:embed="rId4"/>
               <a:stretch>
                 <a:fillRect/>
               </a:stretch>
@@ -7370,8 +7370,8 @@
           </a:p>
         </p:txBody>
       </p:sp>
-      <mc:AlternateContent xmlns:mc="http://schemas.openxmlformats.org/markup-compatibility/2006">
-        <mc:Choice xmlns:pslz="http://schemas.microsoft.com/office/powerpoint/2016/slidezoom" Requires="pslz">
+      <mc:AlternateContent xmlns:mc="http://schemas.openxmlformats.org/markup-compatibility/2006" xmlns:pslz="http://schemas.microsoft.com/office/powerpoint/2016/slidezoom">
+        <mc:Choice Requires="pslz">
           <p:graphicFrame>
             <p:nvGraphicFramePr>
               <p:cNvPr id="5" name="슬라이드 확대/축소 4">
@@ -7428,7 +7428,7 @@
             </a:graphic>
           </p:graphicFrame>
         </mc:Choice>
-        <mc:Fallback>
+        <mc:Fallback xmlns="">
           <p:pic>
             <p:nvPicPr>
               <p:cNvPr id="5" name="슬라이드 확대/축소 4">
@@ -7445,7 +7445,7 @@
               <p:nvPr/>
             </p:nvPicPr>
             <p:blipFill>
-              <a:blip r:embed="rId2"/>
+              <a:blip r:embed="rId4"/>
               <a:stretch>
                 <a:fillRect/>
               </a:stretch>
@@ -7756,8 +7756,8 @@
           </a:p>
         </p:txBody>
       </p:sp>
-      <mc:AlternateContent xmlns:mc="http://schemas.openxmlformats.org/markup-compatibility/2006">
-        <mc:Choice xmlns:pslz="http://schemas.microsoft.com/office/powerpoint/2016/slidezoom" Requires="pslz">
+      <mc:AlternateContent xmlns:mc="http://schemas.openxmlformats.org/markup-compatibility/2006" xmlns:pslz="http://schemas.microsoft.com/office/powerpoint/2016/slidezoom">
+        <mc:Choice Requires="pslz">
           <p:graphicFrame>
             <p:nvGraphicFramePr>
               <p:cNvPr id="6" name="슬라이드 확대/축소 5">
@@ -7814,7 +7814,7 @@
             </a:graphic>
           </p:graphicFrame>
         </mc:Choice>
-        <mc:Fallback>
+        <mc:Fallback xmlns="">
           <p:pic>
             <p:nvPicPr>
               <p:cNvPr id="6" name="슬라이드 확대/축소 5">
@@ -7831,7 +7831,7 @@
               <p:nvPr/>
             </p:nvPicPr>
             <p:blipFill>
-              <a:blip r:embed="rId2"/>
+              <a:blip r:embed="rId4"/>
               <a:stretch>
                 <a:fillRect/>
               </a:stretch>
@@ -8685,7 +8685,7 @@
         <p:spPr>
           <a:xfrm>
             <a:off x="0" y="776749"/>
-            <a:ext cx="2989921" cy="369332"/>
+            <a:ext cx="3712876" cy="369332"/>
           </a:xfrm>
           <a:prstGeom prst="rect">
             <a:avLst/>
@@ -8700,7 +8700,7 @@
           <a:p>
             <a:r>
               <a:rPr lang="ko-KR" altLang="en-US" dirty="0"/>
-              <a:t>전체 타임라인을 보여준다</a:t>
+              <a:t>전체 실행의 타임라인을 보여준다</a:t>
             </a:r>
             <a:r>
               <a:rPr lang="en-US" altLang="ko-KR" dirty="0"/>
@@ -9101,8 +9101,8 @@
           </p:pic>
         </mc:Fallback>
       </mc:AlternateContent>
-      <mc:AlternateContent xmlns:mc="http://schemas.openxmlformats.org/markup-compatibility/2006">
-        <mc:Choice xmlns:pslz="http://schemas.microsoft.com/office/powerpoint/2016/slidezoom" Requires="pslz">
+      <mc:AlternateContent xmlns:mc="http://schemas.openxmlformats.org/markup-compatibility/2006" xmlns:pslz="http://schemas.microsoft.com/office/powerpoint/2016/slidezoom">
+        <mc:Choice Requires="pslz">
           <p:graphicFrame>
             <p:nvGraphicFramePr>
               <p:cNvPr id="18" name="슬라이드 확대/축소 17">
@@ -9159,7 +9159,7 @@
             </a:graphic>
           </p:graphicFrame>
         </mc:Choice>
-        <mc:Fallback>
+        <mc:Fallback xmlns="">
           <p:pic>
             <p:nvPicPr>
               <p:cNvPr id="18" name="슬라이드 확대/축소 17">
@@ -9176,7 +9176,7 @@
               <p:nvPr/>
             </p:nvPicPr>
             <p:blipFill>
-              <a:blip r:embed="rId8"/>
+              <a:blip r:embed="rId10"/>
               <a:stretch>
                 <a:fillRect/>
               </a:stretch>

</xml_diff>

<commit_message>
Graphic ppt add particle slide
하이레벨 디자인 ppt 파티클 부분 내용 추가
</commit_message>
<xml_diff>
--- a/Conference/GraphicsStudy/GraphicsHighLevelDesign.pptx
+++ b/Conference/GraphicsStudy/GraphicsHighLevelDesign.pptx
@@ -289,7 +289,7 @@
           <a:p>
             <a:fld id="{D8810A9B-0CC6-4053-BA0B-965178095DC3}" type="datetimeFigureOut">
               <a:rPr lang="ko-KR" altLang="en-US" smtClean="0"/>
-              <a:t>2026-03-12</a:t>
+              <a:t>2026-03-16</a:t>
             </a:fld>
             <a:endParaRPr lang="ko-KR" altLang="en-US"/>
           </a:p>
@@ -487,7 +487,7 @@
           <a:p>
             <a:fld id="{D8810A9B-0CC6-4053-BA0B-965178095DC3}" type="datetimeFigureOut">
               <a:rPr lang="ko-KR" altLang="en-US" smtClean="0"/>
-              <a:t>2026-03-12</a:t>
+              <a:t>2026-03-16</a:t>
             </a:fld>
             <a:endParaRPr lang="ko-KR" altLang="en-US"/>
           </a:p>
@@ -695,7 +695,7 @@
           <a:p>
             <a:fld id="{D8810A9B-0CC6-4053-BA0B-965178095DC3}" type="datetimeFigureOut">
               <a:rPr lang="ko-KR" altLang="en-US" smtClean="0"/>
-              <a:t>2026-03-12</a:t>
+              <a:t>2026-03-16</a:t>
             </a:fld>
             <a:endParaRPr lang="ko-KR" altLang="en-US"/>
           </a:p>
@@ -893,7 +893,7 @@
           <a:p>
             <a:fld id="{D8810A9B-0CC6-4053-BA0B-965178095DC3}" type="datetimeFigureOut">
               <a:rPr lang="ko-KR" altLang="en-US" smtClean="0"/>
-              <a:t>2026-03-12</a:t>
+              <a:t>2026-03-16</a:t>
             </a:fld>
             <a:endParaRPr lang="ko-KR" altLang="en-US"/>
           </a:p>
@@ -1168,7 +1168,7 @@
           <a:p>
             <a:fld id="{D8810A9B-0CC6-4053-BA0B-965178095DC3}" type="datetimeFigureOut">
               <a:rPr lang="ko-KR" altLang="en-US" smtClean="0"/>
-              <a:t>2026-03-12</a:t>
+              <a:t>2026-03-16</a:t>
             </a:fld>
             <a:endParaRPr lang="ko-KR" altLang="en-US"/>
           </a:p>
@@ -1433,7 +1433,7 @@
           <a:p>
             <a:fld id="{D8810A9B-0CC6-4053-BA0B-965178095DC3}" type="datetimeFigureOut">
               <a:rPr lang="ko-KR" altLang="en-US" smtClean="0"/>
-              <a:t>2026-03-12</a:t>
+              <a:t>2026-03-16</a:t>
             </a:fld>
             <a:endParaRPr lang="ko-KR" altLang="en-US"/>
           </a:p>
@@ -1845,7 +1845,7 @@
           <a:p>
             <a:fld id="{D8810A9B-0CC6-4053-BA0B-965178095DC3}" type="datetimeFigureOut">
               <a:rPr lang="ko-KR" altLang="en-US" smtClean="0"/>
-              <a:t>2026-03-12</a:t>
+              <a:t>2026-03-16</a:t>
             </a:fld>
             <a:endParaRPr lang="ko-KR" altLang="en-US"/>
           </a:p>
@@ -1986,7 +1986,7 @@
           <a:p>
             <a:fld id="{D8810A9B-0CC6-4053-BA0B-965178095DC3}" type="datetimeFigureOut">
               <a:rPr lang="ko-KR" altLang="en-US" smtClean="0"/>
-              <a:t>2026-03-12</a:t>
+              <a:t>2026-03-16</a:t>
             </a:fld>
             <a:endParaRPr lang="ko-KR" altLang="en-US"/>
           </a:p>
@@ -2099,7 +2099,7 @@
           <a:p>
             <a:fld id="{D8810A9B-0CC6-4053-BA0B-965178095DC3}" type="datetimeFigureOut">
               <a:rPr lang="ko-KR" altLang="en-US" smtClean="0"/>
-              <a:t>2026-03-12</a:t>
+              <a:t>2026-03-16</a:t>
             </a:fld>
             <a:endParaRPr lang="ko-KR" altLang="en-US"/>
           </a:p>
@@ -2410,7 +2410,7 @@
           <a:p>
             <a:fld id="{D8810A9B-0CC6-4053-BA0B-965178095DC3}" type="datetimeFigureOut">
               <a:rPr lang="ko-KR" altLang="en-US" smtClean="0"/>
-              <a:t>2026-03-12</a:t>
+              <a:t>2026-03-16</a:t>
             </a:fld>
             <a:endParaRPr lang="ko-KR" altLang="en-US"/>
           </a:p>
@@ -2698,7 +2698,7 @@
           <a:p>
             <a:fld id="{D8810A9B-0CC6-4053-BA0B-965178095DC3}" type="datetimeFigureOut">
               <a:rPr lang="ko-KR" altLang="en-US" smtClean="0"/>
-              <a:t>2026-03-12</a:t>
+              <a:t>2026-03-16</a:t>
             </a:fld>
             <a:endParaRPr lang="ko-KR" altLang="en-US"/>
           </a:p>
@@ -2939,7 +2939,7 @@
           <a:p>
             <a:fld id="{D8810A9B-0CC6-4053-BA0B-965178095DC3}" type="datetimeFigureOut">
               <a:rPr lang="ko-KR" altLang="en-US" smtClean="0"/>
-              <a:t>2026-03-12</a:t>
+              <a:t>2026-03-16</a:t>
             </a:fld>
             <a:endParaRPr lang="ko-KR" altLang="en-US"/>
           </a:p>
@@ -4182,8 +4182,8 @@
         </p:nvSpPr>
         <p:spPr>
           <a:xfrm>
-            <a:off x="0" y="868680"/>
-            <a:ext cx="2476960" cy="369332"/>
+            <a:off x="104237" y="868680"/>
+            <a:ext cx="12087763" cy="2031325"/>
           </a:xfrm>
           <a:prstGeom prst="rect">
             <a:avLst/>
@@ -4191,24 +4191,534 @@
           <a:noFill/>
         </p:spPr>
         <p:txBody>
-          <a:bodyPr wrap="none" rtlCol="0">
+          <a:bodyPr wrap="square" rtlCol="0">
             <a:spAutoFit/>
           </a:bodyPr>
           <a:lstStyle/>
           <a:p>
             <a:r>
-              <a:rPr lang="ko-KR" altLang="en-US" dirty="0"/>
-              <a:t>동건아 이거 </a:t>
-            </a:r>
-            <a:r>
-              <a:rPr lang="ko-KR" altLang="en-US" dirty="0" err="1"/>
-              <a:t>적어주셈</a:t>
-            </a:r>
-            <a:r>
-              <a:rPr lang="en-US" altLang="ko-KR" dirty="0"/>
+              <a:rPr lang="en-US" altLang="ko-KR" b="1"/>
+              <a:t>Particle Management &amp; Update</a:t>
+            </a:r>
+          </a:p>
+          <a:p>
+            <a:r>
+              <a:rPr lang="ko-KR" altLang="en-US"/>
+              <a:t>모든 파티클 데이터는 </a:t>
+            </a:r>
+            <a:r>
+              <a:rPr lang="en-US" altLang="ko-KR" b="1"/>
+              <a:t>StructuredBuffer</a:t>
+            </a:r>
+            <a:r>
+              <a:rPr lang="ko-KR" altLang="en-US"/>
+              <a:t> 형태로 </a:t>
+            </a:r>
+            <a:r>
+              <a:rPr lang="en-US" altLang="ko-KR"/>
+              <a:t>GPU </a:t>
+            </a:r>
+            <a:r>
+              <a:rPr lang="ko-KR" altLang="en-US"/>
+              <a:t>전용 메모리에 상주하며</a:t>
+            </a:r>
+            <a:r>
+              <a:rPr lang="en-US" altLang="ko-KR"/>
+              <a:t>, </a:t>
+            </a:r>
+            <a:r>
+              <a:rPr lang="en-US" altLang="ko-KR" b="1"/>
+              <a:t>Compute Shader</a:t>
+            </a:r>
+            <a:r>
+              <a:rPr lang="ko-KR" altLang="en-US"/>
+              <a:t>를 통해 </a:t>
+            </a:r>
+            <a:r>
+              <a:rPr lang="en-US" altLang="ko-KR"/>
+              <a:t>CPU </a:t>
+            </a:r>
+            <a:r>
+              <a:rPr lang="ko-KR" altLang="en-US"/>
+              <a:t>개입 없이 업데이트됨</a:t>
+            </a:r>
+            <a:endParaRPr lang="en-US" altLang="ko-KR"/>
+          </a:p>
+          <a:p>
+            <a:r>
+              <a:rPr lang="en-US" altLang="ko-KR" b="1"/>
+              <a:t>Update Logic</a:t>
+            </a:r>
+            <a:r>
+              <a:rPr lang="en-US" altLang="ko-KR"/>
+              <a:t>: </a:t>
+            </a:r>
+            <a:r>
+              <a:rPr lang="ko-KR" altLang="en-US"/>
+              <a:t>매 프레임 </a:t>
+            </a:r>
+            <a:r>
+              <a:rPr lang="en-US" altLang="ko-KR"/>
+              <a:t>TimeCB</a:t>
+            </a:r>
+            <a:r>
+              <a:rPr lang="ko-KR" altLang="en-US"/>
+              <a:t>로부터 </a:t>
+            </a:r>
+            <a:r>
+              <a:rPr lang="en-US" altLang="ko-KR"/>
+              <a:t>dt(DeltaTime)</a:t>
+            </a:r>
+            <a:r>
+              <a:rPr lang="ko-KR" altLang="en-US"/>
+              <a:t>를 전달받아 위치 연산</a:t>
+            </a:r>
+            <a:r>
+              <a:rPr lang="en-US" altLang="ko-KR"/>
+              <a:t>, </a:t>
+            </a:r>
+            <a:r>
+              <a:rPr lang="ko-KR" altLang="en-US"/>
+              <a:t>수명</a:t>
+            </a:r>
+            <a:r>
+              <a:rPr lang="en-US" altLang="ko-KR"/>
+              <a:t>(Life/Age) </a:t>
+            </a:r>
+            <a:r>
+              <a:rPr lang="ko-KR" altLang="en-US"/>
+              <a:t>계산</a:t>
+            </a:r>
+            <a:r>
+              <a:rPr lang="en-US" altLang="ko-KR"/>
+              <a:t>, </a:t>
+            </a:r>
+            <a:r>
+              <a:rPr lang="ko-KR" altLang="en-US"/>
+              <a:t>물리 시뮬레이션</a:t>
+            </a:r>
+            <a:r>
+              <a:rPr lang="en-US" altLang="ko-KR"/>
+              <a:t>(</a:t>
+            </a:r>
+            <a:r>
+              <a:rPr lang="ko-KR" altLang="en-US"/>
+              <a:t>중력</a:t>
+            </a:r>
+            <a:r>
+              <a:rPr lang="en-US" altLang="ko-KR"/>
+              <a:t>, </a:t>
+            </a:r>
+            <a:r>
+              <a:rPr lang="ko-KR" altLang="en-US"/>
+              <a:t>감쇠</a:t>
+            </a:r>
+            <a:r>
+              <a:rPr lang="en-US" altLang="ko-KR"/>
+              <a:t>)</a:t>
+            </a:r>
+            <a:r>
+              <a:rPr lang="ko-KR" altLang="en-US"/>
+              <a:t>을 병렬로 수행</a:t>
+            </a:r>
+            <a:r>
+              <a:rPr lang="en-US" altLang="ko-KR"/>
               <a:t>.</a:t>
             </a:r>
+          </a:p>
+          <a:p>
+            <a:r>
+              <a:rPr lang="en-US" altLang="ko-KR" b="1"/>
+              <a:t>Dispatch Strategy</a:t>
+            </a:r>
+            <a:r>
+              <a:rPr lang="en-US" altLang="ko-KR"/>
+              <a:t>: </a:t>
+            </a:r>
+            <a:r>
+              <a:rPr lang="ko-KR" altLang="en-US"/>
+              <a:t>대량의 파티클을 처리하기 위해 파티클 개수에 맞춰 </a:t>
+            </a:r>
+            <a:r>
+              <a:rPr lang="en-US" altLang="ko-KR"/>
+              <a:t>Thread Group</a:t>
+            </a:r>
+            <a:r>
+              <a:rPr lang="ko-KR" altLang="en-US"/>
+              <a:t>을 최적화하여 호출</a:t>
+            </a:r>
+            <a:r>
+              <a:rPr lang="en-US" altLang="ko-KR"/>
+              <a:t>.</a:t>
+            </a:r>
+          </a:p>
+          <a:p>
+            <a:r>
+              <a:rPr lang="en-US" altLang="ko-KR"/>
+              <a:t>.</a:t>
+            </a:r>
             <a:endParaRPr lang="ko-KR" altLang="en-US" dirty="0"/>
+          </a:p>
+        </p:txBody>
+      </p:sp>
+      <p:sp>
+        <p:nvSpPr>
+          <p:cNvPr id="5" name="TextBox 4">
+            <a:extLst>
+              <a:ext uri="{FF2B5EF4-FFF2-40B4-BE49-F238E27FC236}">
+                <a16:creationId xmlns:a16="http://schemas.microsoft.com/office/drawing/2014/main" id="{1330DBC7-DC95-8B9C-5FC6-18A01CB67F68}"/>
+              </a:ext>
+            </a:extLst>
+          </p:cNvPr>
+          <p:cNvSpPr txBox="1"/>
+          <p:nvPr/>
+        </p:nvSpPr>
+        <p:spPr>
+          <a:xfrm>
+            <a:off x="0" y="2826633"/>
+            <a:ext cx="12087763" cy="3416320"/>
+          </a:xfrm>
+          <a:prstGeom prst="rect">
+            <a:avLst/>
+          </a:prstGeom>
+          <a:noFill/>
+        </p:spPr>
+        <p:txBody>
+          <a:bodyPr wrap="square">
+            <a:spAutoFit/>
+          </a:bodyPr>
+          <a:lstStyle/>
+          <a:p>
+            <a:pPr>
+              <a:buNone/>
+            </a:pPr>
+            <a:r>
+              <a:rPr lang="en-US" altLang="ko-KR" b="1"/>
+              <a:t>Resource &amp; Rendering Pipeline</a:t>
+            </a:r>
+          </a:p>
+          <a:p>
+            <a:pPr>
+              <a:buNone/>
+            </a:pPr>
+            <a:r>
+              <a:rPr lang="en-US" altLang="ko-KR"/>
+              <a:t>CPU</a:t>
+            </a:r>
+            <a:r>
+              <a:rPr lang="ko-KR" altLang="en-US"/>
+              <a:t>는 최소한의 상수 데이터만 갱신하고</a:t>
+            </a:r>
+            <a:r>
+              <a:rPr lang="en-US" altLang="ko-KR"/>
+              <a:t>, </a:t>
+            </a:r>
+            <a:r>
+              <a:rPr lang="ko-KR" altLang="en-US"/>
+              <a:t>실제 렌더링에 필요한 모든 연산은 </a:t>
+            </a:r>
+            <a:r>
+              <a:rPr lang="en-US" altLang="ko-KR"/>
+              <a:t>GPU </a:t>
+            </a:r>
+            <a:r>
+              <a:rPr lang="ko-KR" altLang="en-US"/>
+              <a:t>내에서 완결</a:t>
+            </a:r>
+            <a:r>
+              <a:rPr lang="en-US" altLang="ko-KR"/>
+              <a:t>.</a:t>
+            </a:r>
+          </a:p>
+          <a:p>
+            <a:pPr>
+              <a:buFont typeface="Arial" panose="020B0604020202020204" pitchFamily="34" charset="0"/>
+              <a:buChar char="•"/>
+            </a:pPr>
+            <a:r>
+              <a:rPr lang="en-US" altLang="ko-KR" b="1"/>
+              <a:t>Root Signature Design</a:t>
+            </a:r>
+            <a:r>
+              <a:rPr lang="en-US" altLang="ko-KR"/>
+              <a:t>:</a:t>
+            </a:r>
+          </a:p>
+          <a:p>
+            <a:pPr marL="742950" lvl="1" indent="-285750">
+              <a:buFont typeface="Arial" panose="020B0604020202020204" pitchFamily="34" charset="0"/>
+              <a:buChar char="•"/>
+            </a:pPr>
+            <a:r>
+              <a:rPr lang="en-US" altLang="ko-KR" b="1"/>
+              <a:t>UAV (u0)</a:t>
+            </a:r>
+            <a:r>
+              <a:rPr lang="en-US" altLang="ko-KR"/>
+              <a:t>: </a:t>
+            </a:r>
+            <a:r>
+              <a:rPr lang="ko-KR" altLang="en-US"/>
+              <a:t>파티클 데이터 쓰기</a:t>
+            </a:r>
+            <a:r>
+              <a:rPr lang="en-US" altLang="ko-KR"/>
+              <a:t>/</a:t>
+            </a:r>
+            <a:r>
+              <a:rPr lang="ko-KR" altLang="en-US"/>
+              <a:t>읽기용 </a:t>
+            </a:r>
+            <a:r>
+              <a:rPr lang="en-US" altLang="ko-KR"/>
+              <a:t>(Compute)</a:t>
+            </a:r>
+          </a:p>
+          <a:p>
+            <a:pPr marL="742950" lvl="1" indent="-285750">
+              <a:buFont typeface="Arial" panose="020B0604020202020204" pitchFamily="34" charset="0"/>
+              <a:buChar char="•"/>
+            </a:pPr>
+            <a:r>
+              <a:rPr lang="en-US" altLang="ko-KR" b="1"/>
+              <a:t>SRV (t0)</a:t>
+            </a:r>
+            <a:r>
+              <a:rPr lang="en-US" altLang="ko-KR"/>
+              <a:t>: </a:t>
+            </a:r>
+            <a:r>
+              <a:rPr lang="ko-KR" altLang="en-US"/>
+              <a:t>업데이트된 데이터를 </a:t>
+            </a:r>
+            <a:r>
+              <a:rPr lang="en-US" altLang="ko-KR"/>
+              <a:t>Vertex Shader</a:t>
+            </a:r>
+            <a:r>
+              <a:rPr lang="ko-KR" altLang="en-US"/>
+              <a:t>에서 참조 </a:t>
+            </a:r>
+            <a:r>
+              <a:rPr lang="en-US" altLang="ko-KR"/>
+              <a:t>(Rendering)</a:t>
+            </a:r>
+          </a:p>
+          <a:p>
+            <a:pPr marL="742950" lvl="1" indent="-285750">
+              <a:buFont typeface="Arial" panose="020B0604020202020204" pitchFamily="34" charset="0"/>
+              <a:buChar char="•"/>
+            </a:pPr>
+            <a:r>
+              <a:rPr lang="en-US" altLang="ko-KR" b="1"/>
+              <a:t>CBV (b0, b1)</a:t>
+            </a:r>
+            <a:r>
+              <a:rPr lang="en-US" altLang="ko-KR"/>
+              <a:t>: </a:t>
+            </a:r>
+            <a:r>
+              <a:rPr lang="ko-KR" altLang="en-US"/>
+              <a:t>시간 데이터</a:t>
+            </a:r>
+            <a:r>
+              <a:rPr lang="en-US" altLang="ko-KR"/>
+              <a:t>(</a:t>
+            </a:r>
+            <a:r>
+              <a:rPr lang="en-US" altLang="ko-KR">
+                <a:latin typeface="Courier New" panose="02070309020205020404" pitchFamily="49" charset="0"/>
+              </a:rPr>
+              <a:t>TimeCB</a:t>
+            </a:r>
+            <a:r>
+              <a:rPr lang="en-US" altLang="ko-KR"/>
+              <a:t>) </a:t>
+            </a:r>
+            <a:r>
+              <a:rPr lang="ko-KR" altLang="en-US"/>
+              <a:t>및 특정 이벤트 데이터</a:t>
+            </a:r>
+            <a:r>
+              <a:rPr lang="en-US" altLang="ko-KR"/>
+              <a:t>(</a:t>
+            </a:r>
+            <a:r>
+              <a:rPr lang="en-US" altLang="ko-KR">
+                <a:latin typeface="Courier New" panose="02070309020205020404" pitchFamily="49" charset="0"/>
+              </a:rPr>
+              <a:t>MuzzleCB</a:t>
+            </a:r>
+            <a:r>
+              <a:rPr lang="en-US" altLang="ko-KR"/>
+              <a:t>) </a:t>
+            </a:r>
+            <a:r>
+              <a:rPr lang="ko-KR" altLang="en-US"/>
+              <a:t>바인딩</a:t>
+            </a:r>
+          </a:p>
+          <a:p>
+            <a:pPr>
+              <a:buFont typeface="Arial" panose="020B0604020202020204" pitchFamily="34" charset="0"/>
+              <a:buChar char="•"/>
+            </a:pPr>
+            <a:r>
+              <a:rPr lang="en-US" altLang="ko-KR" b="1"/>
+              <a:t>Geometry-less Rendering</a:t>
+            </a:r>
+            <a:r>
+              <a:rPr lang="en-US" altLang="ko-KR"/>
+              <a:t>:</a:t>
+            </a:r>
+          </a:p>
+          <a:p>
+            <a:pPr marL="742950" lvl="1" indent="-285750">
+              <a:buFont typeface="Arial" panose="020B0604020202020204" pitchFamily="34" charset="0"/>
+              <a:buChar char="•"/>
+            </a:pPr>
+            <a:r>
+              <a:rPr lang="ko-KR" altLang="en-US"/>
+              <a:t>별도의 </a:t>
+            </a:r>
+            <a:r>
+              <a:rPr lang="en-US" altLang="ko-KR"/>
+              <a:t>Vertex Buffer </a:t>
+            </a:r>
+            <a:r>
+              <a:rPr lang="ko-KR" altLang="en-US"/>
+              <a:t>없이 </a:t>
+            </a:r>
+            <a:r>
+              <a:rPr lang="en-US" altLang="ko-KR">
+                <a:latin typeface="Courier New" panose="02070309020205020404" pitchFamily="49" charset="0"/>
+              </a:rPr>
+              <a:t>SV_VertexID</a:t>
+            </a:r>
+            <a:r>
+              <a:rPr lang="ko-KR" altLang="en-US"/>
+              <a:t>를 사용하여 셰이더 내부에서 빌보드</a:t>
+            </a:r>
+            <a:r>
+              <a:rPr lang="en-US" altLang="ko-KR"/>
+              <a:t>(Billboard) </a:t>
+            </a:r>
+            <a:r>
+              <a:rPr lang="ko-KR" altLang="en-US"/>
+              <a:t>정점을 실시간 생성</a:t>
+            </a:r>
+            <a:r>
+              <a:rPr lang="en-US" altLang="ko-KR"/>
+              <a:t>.</a:t>
+            </a:r>
+            <a:r>
+              <a:rPr lang="ko-KR" altLang="en-US"/>
+              <a:t> </a:t>
+            </a:r>
+            <a:r>
+              <a:rPr lang="en-US" altLang="ko-KR" b="1"/>
+              <a:t>Instanced Drawing</a:t>
+            </a:r>
+            <a:r>
+              <a:rPr lang="en-US" altLang="ko-KR"/>
+              <a:t>: </a:t>
+            </a:r>
+            <a:r>
+              <a:rPr lang="ko-KR" altLang="en-US"/>
+              <a:t>파티클 개수만큼 </a:t>
+            </a:r>
+            <a:r>
+              <a:rPr lang="en-US" altLang="ko-KR">
+                <a:latin typeface="Courier New" panose="02070309020205020404" pitchFamily="49" charset="0"/>
+              </a:rPr>
+              <a:t>DrawInstanced</a:t>
+            </a:r>
+            <a:r>
+              <a:rPr lang="ko-KR" altLang="en-US"/>
+              <a:t>를 호출하여 기하학적 메모리 점유율을 최소화</a:t>
+            </a:r>
+            <a:r>
+              <a:rPr lang="en-US" altLang="ko-KR"/>
+              <a:t>.</a:t>
+            </a:r>
+          </a:p>
+          <a:p>
+            <a:pPr>
+              <a:buFont typeface="Arial" panose="020B0604020202020204" pitchFamily="34" charset="0"/>
+              <a:buChar char="•"/>
+            </a:pPr>
+            <a:r>
+              <a:rPr lang="en-US" altLang="ko-KR" b="1"/>
+              <a:t>Visual Optimization</a:t>
+            </a:r>
+            <a:r>
+              <a:rPr lang="en-US" altLang="ko-KR"/>
+              <a:t>:</a:t>
+            </a:r>
+          </a:p>
+          <a:p>
+            <a:pPr marL="742950" lvl="1" indent="-285750">
+              <a:buFont typeface="Arial" panose="020B0604020202020204" pitchFamily="34" charset="0"/>
+              <a:buChar char="•"/>
+            </a:pPr>
+            <a:r>
+              <a:rPr lang="en-US" altLang="ko-KR" b="1"/>
+              <a:t>Additive Blending</a:t>
+            </a:r>
+            <a:r>
+              <a:rPr lang="en-US" altLang="ko-KR"/>
+              <a:t>: </a:t>
+            </a:r>
+            <a:r>
+              <a:rPr lang="ko-KR" altLang="en-US"/>
+              <a:t>빛의 중첩 표현을 위해 가산 혼합 적용</a:t>
+            </a:r>
+            <a:r>
+              <a:rPr lang="en-US" altLang="ko-KR"/>
+              <a:t>.</a:t>
+            </a:r>
+          </a:p>
+          <a:p>
+            <a:pPr marL="742950" lvl="1" indent="-285750">
+              <a:buFont typeface="Arial" panose="020B0604020202020204" pitchFamily="34" charset="0"/>
+              <a:buChar char="•"/>
+            </a:pPr>
+            <a:r>
+              <a:rPr lang="en-US" altLang="ko-KR" b="1"/>
+              <a:t>Depth Stencil</a:t>
+            </a:r>
+            <a:r>
+              <a:rPr lang="en-US" altLang="ko-KR"/>
+              <a:t>: </a:t>
+            </a:r>
+            <a:r>
+              <a:rPr lang="ko-KR" altLang="en-US"/>
+              <a:t>파티클 간의 불필요한 가림을 방지하고 부드러운 합성을 위해 </a:t>
+            </a:r>
+            <a:r>
+              <a:rPr lang="en-US" altLang="ko-KR">
+                <a:latin typeface="Courier New" panose="02070309020205020404" pitchFamily="49" charset="0"/>
+              </a:rPr>
+              <a:t>DepthWrite</a:t>
+            </a:r>
+            <a:r>
+              <a:rPr lang="ko-KR" altLang="en-US"/>
+              <a:t>를 비활성화</a:t>
+            </a:r>
+            <a:r>
+              <a:rPr lang="en-US" altLang="ko-KR"/>
+              <a:t>(</a:t>
+            </a:r>
+            <a:r>
+              <a:rPr lang="en-US" altLang="ko-KR">
+                <a:latin typeface="Courier New" panose="02070309020205020404" pitchFamily="49" charset="0"/>
+              </a:rPr>
+              <a:t>ZERO</a:t>
+            </a:r>
+            <a:r>
+              <a:rPr lang="en-US" altLang="ko-KR"/>
+              <a:t>)</a:t>
+            </a:r>
           </a:p>
         </p:txBody>
       </p:sp>

</xml_diff>